<commit_message>
updating number of rocks in training
</commit_message>
<xml_diff>
--- a/slides/overview.pptx
+++ b/slides/overview.pptx
@@ -1001,7 +1001,7 @@
           <a:lstStyle/>
           <a:p>
             <a:r>
-              <a:t>Masked-element modelling. Encoder is TRAINED here (frozen is the downstream state). Loss is per-element standardized log-space MSE so traces get supervised. Over 474k rocks.</a:t>
+              <a:t>Masked-element modelling. Encoder is TRAINED here (frozen is the downstream state). Loss is per-element standardized log-space MSE so traces get supervised. Over ~167k rocks.</a:t>
             </a:r>
           </a:p>
         </p:txBody>
@@ -6738,7 +6738,7 @@
                   <a:srgbClr val="8A93A3"/>
                 </a:solidFill>
               </a:rPr>
-              <a:t>~474k igneous bulks</a:t>
+              <a:t>~167k igneous bulks</a:t>
             </a:r>
           </a:p>
           <a:p>

</xml_diff>

<commit_message>
overview deck: Dirichlet-branch worked-example slide (one row through the magnitude head: alpha sliced to the true support,   predicted mean +/- Beta-marginal spread vs truth, PIT read, teacher-forcing + sub-composition captions), mirroring the Bernoulli reliability   example. CLAUDE.md: lock corpus terminology (bulk / draw / rung / row / assemblage; scenario reserved for inference posterior clusters). Drop the   accidentally committed PowerPoint lock file
</commit_message>
<xml_diff>
--- a/slides/overview.pptx
+++ b/slides/overview.pptx
@@ -21,6 +21,7 @@
     <p:sldId id="269" r:id="rId21"/>
     <p:sldId id="270" r:id="rId22"/>
     <p:sldId id="271" r:id="rId23"/>
+    <p:sldId id="272" r:id="rId24"/>
   </p:sldIdLst>
   <p:sldSz cx="12191695" cy="6858000" type="screen4x3"/>
   <p:notesSz cx="6858000" cy="9144000"/>
@@ -937,7 +938,7 @@
           <a:lstStyle/>
           <a:p>
             <a:r>
-              <a:t>Output FORM, not measured results (heads train in issue #10). ModeHead = hurdle Dirichlet over the crystals-renormalized solid assemblage (liq/fl dropped, solids sum to 1 -- matches real itemized-phenocrysts + lumped-groundmass granularity). EVERY phase gets a presence Bernoulli AND a conditional amount +/- CI; near-certain phases just have p~1. Amp 0.41 / opx 0.63 anti-correlated is the flagship multimodality (deep-wet-amp vs shallow-dry-opx), so their marginal amounts are conditional on presence, not rock-wide means. CondHead = per-axis GMM; P and H2O were sampled at generation, T is derived (cooling endpoint at the phenocryst window), hence the lower illustrative T. Second read-out view: top-K scenarios; weights labeled prior-weighted plausibility, reweightable p/q. Mass-balance closure teacher-forces the label melt fraction at training. Numbers illustrative.</a:t>
+              <a:t>Eval-semantics slide for the magnitude branch, mirroring the presence branch's reliability worked example. Numbers illustrative but to scale: alpha sliced to the true 4-phase support gives Dirichlet means alpha_i/alpha0 and Beta marginals Beta(alpha_i, alpha0 - alpha_i); plag Beta(12,13) has mean 0.48, sd ~0.10, and truth 0.44 lands at CDF 0.34. alpha0 is the single shared confidence knob per row -- the reason per-phase spreads can't be tuned independently (see alpha_concentration.png). PIT histograms are the magnitude analog of reliability diagrams; parity plots are the point-estimate view. Scored by masked Dirichlet NLL (anatomy slide's L_magnitude).</a:t>
             </a:r>
           </a:p>
         </p:txBody>
@@ -963,6 +964,76 @@
 </file>
 
 <file path=ppt/notesSlides/notesSlide16.xml><?xml version="1.0" encoding="utf-8"?>
+<p:notes xmlns:a="http://schemas.openxmlformats.org/drawingml/2006/main" xmlns:p="http://schemas.openxmlformats.org/presentationml/2006/main" xmlns:r="http://schemas.openxmlformats.org/officeDocument/2006/relationships">
+  <p:cSld>
+    <p:spTree>
+      <p:nvGrpSpPr>
+        <p:cNvPr id="1" name=""/>
+        <p:cNvGrpSpPr/>
+        <p:nvPr/>
+      </p:nvGrpSpPr>
+      <p:grpSpPr>
+        <a:xfrm>
+          <a:off x="0" y="0"/>
+          <a:ext cx="0" cy="0"/>
+          <a:chOff x="0" y="0"/>
+          <a:chExt cx="0" cy="0"/>
+        </a:xfrm>
+      </p:grpSpPr>
+      <p:sp>
+        <p:nvSpPr>
+          <p:cNvPr id="2" name="Slide Image Placeholder 1"/>
+          <p:cNvSpPr>
+            <a:spLocks noGrp="1"/>
+          </p:cNvSpPr>
+          <p:nvPr>
+            <p:ph type="sldImg" idx="2"/>
+          </p:nvPr>
+        </p:nvSpPr>
+        <p:spPr/>
+      </p:sp>
+      <p:sp>
+        <p:nvSpPr>
+          <p:cNvPr id="3" name="Notes Placeholder 2"/>
+          <p:cNvSpPr>
+            <a:spLocks noGrp="1"/>
+          </p:cNvSpPr>
+          <p:nvPr>
+            <p:ph type="body" idx="3" sz="quarter"/>
+          </p:nvPr>
+        </p:nvSpPr>
+        <p:spPr/>
+        <p:txBody>
+          <a:bodyPr/>
+          <a:lstStyle/>
+          <a:p>
+            <a:r>
+              <a:t>Output FORM, not measured results (heads train in issue #10). ModeHead = hurdle Dirichlet over the crystals-renormalized solid assemblage (liq/fl dropped, solids sum to 1 -- matches real itemized-phenocrysts + lumped-groundmass granularity). EVERY phase gets a presence Bernoulli AND a conditional amount +/- CI; near-certain phases just have p~1. Amp 0.41 / opx 0.63 anti-correlated is the flagship multimodality (deep-wet-amp vs shallow-dry-opx), so their marginal amounts are conditional on presence, not rock-wide means. CondHead = per-axis GMM; P and H2O were sampled at generation, T is derived (cooling endpoint at the phenocryst window), hence the lower illustrative T. Second read-out view: top-K scenarios; weights labeled prior-weighted plausibility, reweightable p/q. Mass-balance closure teacher-forces the label melt fraction at training. Numbers illustrative.</a:t>
+            </a:r>
+          </a:p>
+        </p:txBody>
+      </p:sp>
+      <p:sp>
+        <p:nvSpPr>
+          <p:cNvPr id="4" name="Slide Number Placeholder 3"/>
+          <p:cNvSpPr>
+            <a:spLocks noGrp="1"/>
+          </p:cNvSpPr>
+          <p:nvPr>
+            <p:ph type="sldNum" idx="5" sz="quarter"/>
+          </p:nvPr>
+        </p:nvSpPr>
+        <p:spPr/>
+      </p:sp>
+    </p:spTree>
+  </p:cSld>
+  <p:clrMapOvr>
+    <a:masterClrMapping/>
+  </p:clrMapOvr>
+</p:notes>
+</file>
+
+<file path=ppt/notesSlides/notesSlide17.xml><?xml version="1.0" encoding="utf-8"?>
 <p:notes xmlns:a="http://schemas.openxmlformats.org/drawingml/2006/main" xmlns:p="http://schemas.openxmlformats.org/presentationml/2006/main" xmlns:r="http://schemas.openxmlformats.org/officeDocument/2006/relationships">
   <p:cSld>
     <p:spTree>
@@ -10245,6 +10316,958 @@
                   <a:srgbClr val="1A2238"/>
                 </a:solidFill>
               </a:rPr>
+              <a:t>If it's there, how much? One row through the Dirichlet</a:t>
+            </a:r>
+          </a:p>
+        </p:txBody>
+      </p:sp>
+      <p:sp>
+        <p:nvSpPr>
+          <p:cNvPr id="4" name="TextBox 3"/>
+          <p:cNvSpPr txBox="1"/>
+          <p:nvPr/>
+        </p:nvSpPr>
+        <p:spPr>
+          <a:xfrm>
+            <a:off x="502920" y="1051560"/>
+            <a:ext cx="11155680" cy="731520"/>
+          </a:xfrm>
+          <a:prstGeom prst="rect">
+            <a:avLst/>
+          </a:prstGeom>
+          <a:noFill/>
+        </p:spPr>
+        <p:txBody>
+          <a:bodyPr wrap="square">
+            <a:spAutoFit/>
+          </a:bodyPr>
+          <a:lstStyle/>
+          <a:p>
+            <a:pPr algn="l"/>
+            <a:r>
+              <a:rPr sz="1300" b="0">
+                <a:solidFill>
+                  <a:srgbClr val="8A93A3"/>
+                </a:solidFill>
+              </a:rPr>
+              <a:t>the magnitude branch's eval: slice the predicted concentrations to the row's true support, compare means to truth, and ask whether the claimed spread is honest (PIT)</a:t>
+            </a:r>
+          </a:p>
+        </p:txBody>
+      </p:sp>
+      <p:sp>
+        <p:nvSpPr>
+          <p:cNvPr id="5" name="Rounded Rectangle 4"/>
+          <p:cNvSpPr/>
+          <p:nvPr/>
+        </p:nvSpPr>
+        <p:spPr>
+          <a:xfrm>
+            <a:off x="502920" y="1920240"/>
+            <a:ext cx="2743200" cy="1828800"/>
+          </a:xfrm>
+          <a:prstGeom prst="roundRect">
+            <a:avLst/>
+          </a:prstGeom>
+          <a:solidFill>
+            <a:srgbClr val="E1F1EF"/>
+          </a:solidFill>
+          <a:ln w="25400">
+            <a:solidFill>
+              <a:srgbClr val="2A9D8F"/>
+            </a:solidFill>
+          </a:ln>
+          <a:effectLst/>
+        </p:spPr>
+        <p:style>
+          <a:lnRef idx="1">
+            <a:schemeClr val="accent1"/>
+          </a:lnRef>
+          <a:fillRef idx="3">
+            <a:schemeClr val="accent1"/>
+          </a:fillRef>
+          <a:effectRef idx="2">
+            <a:schemeClr val="accent1"/>
+          </a:effectRef>
+          <a:fontRef idx="minor">
+            <a:schemeClr val="lt1"/>
+          </a:fontRef>
+        </p:style>
+        <p:txBody>
+          <a:bodyPr rtlCol="0" anchor="ctr" wrap="square"/>
+          <a:lstStyle/>
+          <a:p>
+            <a:pPr algn="ctr"/>
+            <a:r>
+              <a:rPr sz="1200" b="1">
+                <a:solidFill>
+                  <a:srgbClr val="1A2238"/>
+                </a:solidFill>
+              </a:rPr>
+              <a:t>one row's truth</a:t>
+            </a:r>
+          </a:p>
+          <a:p>
+            <a:pPr algn="ctr"/>
+            <a:r>
+              <a:rPr sz="900" b="0">
+                <a:solidFill>
+                  <a:srgbClr val="8A93A3"/>
+                </a:solidFill>
+              </a:rPr>
+              <a:t>bulk X . draw 17 . rung 50</a:t>
+            </a:r>
+          </a:p>
+          <a:p>
+            <a:pPr algn="ctr"/>
+            <a:r>
+              <a:rPr sz="900" b="0">
+                <a:solidFill>
+                  <a:srgbClr val="8A93A3"/>
+                </a:solidFill>
+              </a:rPr>
+              <a:t>present: plag cpx amp ilm</a:t>
+            </a:r>
+          </a:p>
+          <a:p>
+            <a:pPr algn="ctr"/>
+            <a:r>
+              <a:rPr sz="900" b="0">
+                <a:solidFill>
+                  <a:srgbClr val="8A93A3"/>
+                </a:solidFill>
+              </a:rPr>
+              <a:t>modes: .44  .26  .19  .11</a:t>
+            </a:r>
+          </a:p>
+          <a:p>
+            <a:pPr algn="ctr"/>
+            <a:r>
+              <a:rPr sz="900" b="0">
+                <a:solidFill>
+                  <a:srgbClr val="8A93A3"/>
+                </a:solidFill>
+              </a:rPr>
+              <a:t>(crystals-renormalized, sum 1)</a:t>
+            </a:r>
+          </a:p>
+        </p:txBody>
+      </p:sp>
+      <p:sp>
+        <p:nvSpPr>
+          <p:cNvPr id="6" name="Right Arrow 5"/>
+          <p:cNvSpPr/>
+          <p:nvPr/>
+        </p:nvSpPr>
+        <p:spPr>
+          <a:xfrm>
+            <a:off x="3337560" y="2651760"/>
+            <a:ext cx="365760" cy="320040"/>
+          </a:xfrm>
+          <a:prstGeom prst="rightArrow">
+            <a:avLst/>
+          </a:prstGeom>
+          <a:solidFill>
+            <a:srgbClr val="1A2238"/>
+          </a:solidFill>
+          <a:ln>
+            <a:noFill/>
+          </a:ln>
+          <a:effectLst/>
+        </p:spPr>
+        <p:style>
+          <a:lnRef idx="1">
+            <a:schemeClr val="accent1"/>
+          </a:lnRef>
+          <a:fillRef idx="3">
+            <a:schemeClr val="accent1"/>
+          </a:fillRef>
+          <a:effectRef idx="2">
+            <a:schemeClr val="accent1"/>
+          </a:effectRef>
+          <a:fontRef idx="minor">
+            <a:schemeClr val="lt1"/>
+          </a:fontRef>
+        </p:style>
+        <p:txBody>
+          <a:bodyPr rtlCol="0" anchor="ctr"/>
+          <a:lstStyle/>
+          <a:p>
+            <a:pPr algn="ctr"/>
+          </a:p>
+        </p:txBody>
+      </p:sp>
+      <p:sp>
+        <p:nvSpPr>
+          <p:cNvPr id="7" name="Rounded Rectangle 6"/>
+          <p:cNvSpPr/>
+          <p:nvPr/>
+        </p:nvSpPr>
+        <p:spPr>
+          <a:xfrm>
+            <a:off x="3794760" y="1920240"/>
+            <a:ext cx="2743200" cy="1828800"/>
+          </a:xfrm>
+          <a:prstGeom prst="roundRect">
+            <a:avLst/>
+          </a:prstGeom>
+          <a:solidFill>
+            <a:srgbClr val="FBEEE3"/>
+          </a:solidFill>
+          <a:ln w="25400">
+            <a:solidFill>
+              <a:srgbClr val="E8883A"/>
+            </a:solidFill>
+          </a:ln>
+          <a:effectLst/>
+        </p:spPr>
+        <p:style>
+          <a:lnRef idx="1">
+            <a:schemeClr val="accent1"/>
+          </a:lnRef>
+          <a:fillRef idx="3">
+            <a:schemeClr val="accent1"/>
+          </a:fillRef>
+          <a:effectRef idx="2">
+            <a:schemeClr val="accent1"/>
+          </a:effectRef>
+          <a:fontRef idx="minor">
+            <a:schemeClr val="lt1"/>
+          </a:fontRef>
+        </p:style>
+        <p:txBody>
+          <a:bodyPr rtlCol="0" anchor="ctr" wrap="square"/>
+          <a:lstStyle/>
+          <a:p>
+            <a:pPr algn="ctr"/>
+            <a:r>
+              <a:rPr sz="1200" b="1">
+                <a:solidFill>
+                  <a:srgbClr val="1A2238"/>
+                </a:solidFill>
+              </a:rPr>
+              <a:t>head output for bulk X</a:t>
+            </a:r>
+          </a:p>
+          <a:p>
+            <a:pPr algn="ctr"/>
+            <a:r>
+              <a:rPr sz="900" b="0">
+                <a:solidFill>
+                  <a:srgbClr val="8A93A3"/>
+                </a:solidFill>
+              </a:rPr>
+              <a:t>alpha, sliced to the true support:</a:t>
+            </a:r>
+          </a:p>
+          <a:p>
+            <a:pPr algn="ctr"/>
+            <a:r>
+              <a:rPr sz="900" b="0">
+                <a:solidFill>
+                  <a:srgbClr val="8A93A3"/>
+                </a:solidFill>
+              </a:rPr>
+              <a:t>plag 12.0    cpx 7.0</a:t>
+            </a:r>
+          </a:p>
+          <a:p>
+            <a:pPr algn="ctr"/>
+            <a:r>
+              <a:rPr sz="900" b="0">
+                <a:solidFill>
+                  <a:srgbClr val="8A93A3"/>
+                </a:solidFill>
+              </a:rPr>
+              <a:t>amp 4.5      ilm 1.5</a:t>
+            </a:r>
+          </a:p>
+          <a:p>
+            <a:pPr algn="ctr"/>
+            <a:r>
+              <a:rPr sz="900" b="0">
+                <a:solidFill>
+                  <a:srgbClr val="8A93A3"/>
+                </a:solidFill>
+              </a:rPr>
+              <a:t>alpha0 = sum = 25 (confidence)</a:t>
+            </a:r>
+          </a:p>
+        </p:txBody>
+      </p:sp>
+      <p:sp>
+        <p:nvSpPr>
+          <p:cNvPr id="8" name="Right Arrow 7"/>
+          <p:cNvSpPr/>
+          <p:nvPr/>
+        </p:nvSpPr>
+        <p:spPr>
+          <a:xfrm>
+            <a:off x="6629400" y="2651760"/>
+            <a:ext cx="365760" cy="320040"/>
+          </a:xfrm>
+          <a:prstGeom prst="rightArrow">
+            <a:avLst/>
+          </a:prstGeom>
+          <a:solidFill>
+            <a:srgbClr val="1A2238"/>
+          </a:solidFill>
+          <a:ln>
+            <a:noFill/>
+          </a:ln>
+          <a:effectLst/>
+        </p:spPr>
+        <p:style>
+          <a:lnRef idx="1">
+            <a:schemeClr val="accent1"/>
+          </a:lnRef>
+          <a:fillRef idx="3">
+            <a:schemeClr val="accent1"/>
+          </a:fillRef>
+          <a:effectRef idx="2">
+            <a:schemeClr val="accent1"/>
+          </a:effectRef>
+          <a:fontRef idx="minor">
+            <a:schemeClr val="lt1"/>
+          </a:fontRef>
+        </p:style>
+        <p:txBody>
+          <a:bodyPr rtlCol="0" anchor="ctr"/>
+          <a:lstStyle/>
+          <a:p>
+            <a:pPr algn="ctr"/>
+          </a:p>
+        </p:txBody>
+      </p:sp>
+      <p:sp>
+        <p:nvSpPr>
+          <p:cNvPr id="9" name="Rounded Rectangle 8"/>
+          <p:cNvSpPr/>
+          <p:nvPr/>
+        </p:nvSpPr>
+        <p:spPr>
+          <a:xfrm>
+            <a:off x="7086600" y="1920240"/>
+            <a:ext cx="2743200" cy="1828800"/>
+          </a:xfrm>
+          <a:prstGeom prst="roundRect">
+            <a:avLst/>
+          </a:prstGeom>
+          <a:solidFill>
+            <a:srgbClr val="EAE8FB"/>
+          </a:solidFill>
+          <a:ln w="25400">
+            <a:solidFill>
+              <a:srgbClr val="6C5CE7"/>
+            </a:solidFill>
+          </a:ln>
+          <a:effectLst/>
+        </p:spPr>
+        <p:style>
+          <a:lnRef idx="1">
+            <a:schemeClr val="accent1"/>
+          </a:lnRef>
+          <a:fillRef idx="3">
+            <a:schemeClr val="accent1"/>
+          </a:fillRef>
+          <a:effectRef idx="2">
+            <a:schemeClr val="accent1"/>
+          </a:effectRef>
+          <a:fontRef idx="minor">
+            <a:schemeClr val="lt1"/>
+          </a:fontRef>
+        </p:style>
+        <p:txBody>
+          <a:bodyPr rtlCol="0" anchor="ctr" wrap="square"/>
+          <a:lstStyle/>
+          <a:p>
+            <a:pPr algn="ctr"/>
+            <a:r>
+              <a:rPr sz="1200" b="1">
+                <a:solidFill>
+                  <a:srgbClr val="1A2238"/>
+                </a:solidFill>
+              </a:rPr>
+              <a:t>predicted mean +/- spread</a:t>
+            </a:r>
+          </a:p>
+          <a:p>
+            <a:pPr algn="ctr"/>
+            <a:r>
+              <a:rPr sz="900" b="0">
+                <a:solidFill>
+                  <a:srgbClr val="8A93A3"/>
+                </a:solidFill>
+              </a:rPr>
+              <a:t>plag 0.48 +/- 0.10   (true .44)</a:t>
+            </a:r>
+          </a:p>
+          <a:p>
+            <a:pPr algn="ctr"/>
+            <a:r>
+              <a:rPr sz="900" b="0">
+                <a:solidFill>
+                  <a:srgbClr val="8A93A3"/>
+                </a:solidFill>
+              </a:rPr>
+              <a:t>cpx 0.28 +/- 0.09   (true .26)</a:t>
+            </a:r>
+          </a:p>
+          <a:p>
+            <a:pPr algn="ctr"/>
+            <a:r>
+              <a:rPr sz="900" b="0">
+                <a:solidFill>
+                  <a:srgbClr val="8A93A3"/>
+                </a:solidFill>
+              </a:rPr>
+              <a:t>amp 0.18 +/- 0.08   (true .19)</a:t>
+            </a:r>
+          </a:p>
+          <a:p>
+            <a:pPr algn="ctr"/>
+            <a:r>
+              <a:rPr sz="900" b="0">
+                <a:solidFill>
+                  <a:srgbClr val="8A93A3"/>
+                </a:solidFill>
+              </a:rPr>
+              <a:t>ilm 0.06 +/- 0.05   (true .11)</a:t>
+            </a:r>
+          </a:p>
+        </p:txBody>
+      </p:sp>
+      <p:sp>
+        <p:nvSpPr>
+          <p:cNvPr id="10" name="Freeform 9"/>
+          <p:cNvSpPr/>
+          <p:nvPr/>
+        </p:nvSpPr>
+        <p:spPr>
+          <a:xfrm>
+            <a:off x="10104120" y="2240280"/>
+            <a:ext cx="1828800" cy="1051560"/>
+          </a:xfrm>
+          <a:custGeom>
+            <a:avLst/>
+            <a:gdLst/>
+            <a:ahLst/>
+            <a:cxnLst/>
+            <a:rect l="l" t="t" r="r" b="b"/>
+            <a:pathLst>
+              <a:path w="1828800" h="1051560">
+                <a:moveTo>
+                  <a:pt x="0" y="1051560"/>
+                </a:moveTo>
+                <a:lnTo>
+                  <a:pt x="0" y="1051549"/>
+                </a:lnTo>
+                <a:lnTo>
+                  <a:pt x="38100" y="1051532"/>
+                </a:lnTo>
+                <a:lnTo>
+                  <a:pt x="76200" y="1051489"/>
+                </a:lnTo>
+                <a:lnTo>
+                  <a:pt x="114300" y="1051387"/>
+                </a:lnTo>
+                <a:lnTo>
+                  <a:pt x="152400" y="1051157"/>
+                </a:lnTo>
+                <a:lnTo>
+                  <a:pt x="190500" y="1050659"/>
+                </a:lnTo>
+                <a:lnTo>
+                  <a:pt x="228600" y="1049631"/>
+                </a:lnTo>
+                <a:lnTo>
+                  <a:pt x="266700" y="1047606"/>
+                </a:lnTo>
+                <a:lnTo>
+                  <a:pt x="304800" y="1043798"/>
+                </a:lnTo>
+                <a:lnTo>
+                  <a:pt x="342900" y="1036971"/>
+                </a:lnTo>
+                <a:lnTo>
+                  <a:pt x="381000" y="1025303"/>
+                </a:lnTo>
+                <a:lnTo>
+                  <a:pt x="419100" y="1006310"/>
+                </a:lnTo>
+                <a:lnTo>
+                  <a:pt x="457200" y="976891"/>
+                </a:lnTo>
+                <a:lnTo>
+                  <a:pt x="495300" y="933578"/>
+                </a:lnTo>
+                <a:lnTo>
+                  <a:pt x="533400" y="873059"/>
+                </a:lnTo>
+                <a:lnTo>
+                  <a:pt x="571500" y="792967"/>
+                </a:lnTo>
+                <a:lnTo>
+                  <a:pt x="609600" y="692851"/>
+                </a:lnTo>
+                <a:lnTo>
+                  <a:pt x="647700" y="575109"/>
+                </a:lnTo>
+                <a:lnTo>
+                  <a:pt x="685800" y="445599"/>
+                </a:lnTo>
+                <a:lnTo>
+                  <a:pt x="723900" y="313619"/>
+                </a:lnTo>
+                <a:lnTo>
+                  <a:pt x="762000" y="191063"/>
+                </a:lnTo>
+                <a:lnTo>
+                  <a:pt x="800100" y="90773"/>
+                </a:lnTo>
+                <a:lnTo>
+                  <a:pt x="838200" y="24359"/>
+                </a:lnTo>
+                <a:lnTo>
+                  <a:pt x="876300" y="0"/>
+                </a:lnTo>
+                <a:lnTo>
+                  <a:pt x="914400" y="20786"/>
+                </a:lnTo>
+                <a:lnTo>
+                  <a:pt x="952500" y="84078"/>
+                </a:lnTo>
+                <a:lnTo>
+                  <a:pt x="990600" y="182053"/>
+                </a:lnTo>
+                <a:lnTo>
+                  <a:pt x="1028700" y="303298"/>
+                </a:lnTo>
+                <a:lnTo>
+                  <a:pt x="1066800" y="434987"/>
+                </a:lnTo>
+                <a:lnTo>
+                  <a:pt x="1104900" y="565079"/>
+                </a:lnTo>
+                <a:lnTo>
+                  <a:pt x="1143000" y="684026"/>
+                </a:lnTo>
+                <a:lnTo>
+                  <a:pt x="1181100" y="785683"/>
+                </a:lnTo>
+                <a:lnTo>
+                  <a:pt x="1219200" y="867393"/>
+                </a:lnTo>
+                <a:lnTo>
+                  <a:pt x="1257300" y="929409"/>
+                </a:lnTo>
+                <a:lnTo>
+                  <a:pt x="1295400" y="973983"/>
+                </a:lnTo>
+                <a:lnTo>
+                  <a:pt x="1333500" y="1004385"/>
+                </a:lnTo>
+                <a:lnTo>
+                  <a:pt x="1371600" y="1024090"/>
+                </a:lnTo>
+                <a:lnTo>
+                  <a:pt x="1409700" y="1036244"/>
+                </a:lnTo>
+                <a:lnTo>
+                  <a:pt x="1447800" y="1043383"/>
+                </a:lnTo>
+                <a:lnTo>
+                  <a:pt x="1485900" y="1047380"/>
+                </a:lnTo>
+                <a:lnTo>
+                  <a:pt x="1524000" y="1049514"/>
+                </a:lnTo>
+                <a:lnTo>
+                  <a:pt x="1562100" y="1050601"/>
+                </a:lnTo>
+                <a:lnTo>
+                  <a:pt x="1600200" y="1051129"/>
+                </a:lnTo>
+                <a:lnTo>
+                  <a:pt x="1638300" y="1051375"/>
+                </a:lnTo>
+                <a:lnTo>
+                  <a:pt x="1676400" y="1051483"/>
+                </a:lnTo>
+                <a:lnTo>
+                  <a:pt x="1714500" y="1051530"/>
+                </a:lnTo>
+                <a:lnTo>
+                  <a:pt x="1752600" y="1051548"/>
+                </a:lnTo>
+                <a:lnTo>
+                  <a:pt x="1790700" y="1051555"/>
+                </a:lnTo>
+                <a:lnTo>
+                  <a:pt x="1828800" y="1051558"/>
+                </a:lnTo>
+                <a:lnTo>
+                  <a:pt x="1828800" y="1051560"/>
+                </a:lnTo>
+                <a:close/>
+              </a:path>
+            </a:pathLst>
+          </a:custGeom>
+          <a:solidFill>
+            <a:srgbClr val="D5D1F8"/>
+          </a:solidFill>
+          <a:ln w="25400">
+            <a:solidFill>
+              <a:srgbClr val="6C5CE7"/>
+            </a:solidFill>
+          </a:ln>
+          <a:effectLst/>
+        </p:spPr>
+        <p:style>
+          <a:lnRef idx="1">
+            <a:schemeClr val="accent1"/>
+          </a:lnRef>
+          <a:fillRef idx="3">
+            <a:schemeClr val="accent1"/>
+          </a:fillRef>
+          <a:effectRef idx="2">
+            <a:schemeClr val="accent1"/>
+          </a:effectRef>
+          <a:fontRef idx="minor">
+            <a:schemeClr val="lt1"/>
+          </a:fontRef>
+        </p:style>
+        <p:txBody>
+          <a:bodyPr rtlCol="0" anchor="ctr"/>
+          <a:lstStyle/>
+          <a:p>
+            <a:pPr algn="ctr"/>
+          </a:p>
+        </p:txBody>
+      </p:sp>
+      <p:cxnSp>
+        <p:nvCxnSpPr>
+          <p:cNvPr id="11" name="Connector 10"/>
+          <p:cNvCxnSpPr/>
+          <p:nvPr/>
+        </p:nvCxnSpPr>
+        <p:spPr>
+          <a:xfrm>
+            <a:off x="10104120" y="3291840"/>
+            <a:ext cx="1828800" cy="0"/>
+          </a:xfrm>
+          <a:prstGeom prst="bentConnector3">
+            <a:avLst/>
+          </a:prstGeom>
+          <a:ln w="12700">
+            <a:solidFill>
+              <a:srgbClr val="8A93A3"/>
+            </a:solidFill>
+          </a:ln>
+          <a:effectLst/>
+        </p:spPr>
+        <p:style>
+          <a:lnRef idx="2">
+            <a:schemeClr val="accent1"/>
+          </a:lnRef>
+          <a:fillRef idx="0">
+            <a:schemeClr val="accent1"/>
+          </a:fillRef>
+          <a:effectRef idx="1">
+            <a:schemeClr val="accent1"/>
+          </a:effectRef>
+          <a:fontRef idx="minor">
+            <a:schemeClr val="tx1"/>
+          </a:fontRef>
+        </p:style>
+      </p:cxnSp>
+      <p:sp>
+        <p:nvSpPr>
+          <p:cNvPr id="12" name="TextBox 11"/>
+          <p:cNvSpPr txBox="1"/>
+          <p:nvPr/>
+        </p:nvSpPr>
+        <p:spPr>
+          <a:xfrm>
+            <a:off x="9921240" y="3337560"/>
+            <a:ext cx="2194560" cy="365760"/>
+          </a:xfrm>
+          <a:prstGeom prst="rect">
+            <a:avLst/>
+          </a:prstGeom>
+          <a:noFill/>
+        </p:spPr>
+        <p:txBody>
+          <a:bodyPr wrap="square">
+            <a:spAutoFit/>
+          </a:bodyPr>
+          <a:lstStyle/>
+          <a:p>
+            <a:pPr algn="ctr"/>
+            <a:r>
+              <a:rPr sz="1200" b="1">
+                <a:solidFill>
+                  <a:srgbClr val="1A2238"/>
+                </a:solidFill>
+              </a:rPr>
+              <a:t>plag marginal: Beta(12, 13)</a:t>
+            </a:r>
+          </a:p>
+        </p:txBody>
+      </p:sp>
+      <p:cxnSp>
+        <p:nvCxnSpPr>
+          <p:cNvPr id="13" name="Connector 12"/>
+          <p:cNvCxnSpPr/>
+          <p:nvPr/>
+        </p:nvCxnSpPr>
+        <p:spPr>
+          <a:xfrm flipV="1">
+            <a:off x="10908792" y="2103120"/>
+            <a:ext cx="0" cy="1188720"/>
+          </a:xfrm>
+          <a:prstGeom prst="bentConnector3">
+            <a:avLst/>
+          </a:prstGeom>
+          <a:ln w="25400">
+            <a:solidFill>
+              <a:srgbClr val="2A9D8F"/>
+            </a:solidFill>
+          </a:ln>
+          <a:effectLst/>
+        </p:spPr>
+        <p:style>
+          <a:lnRef idx="2">
+            <a:schemeClr val="accent1"/>
+          </a:lnRef>
+          <a:fillRef idx="0">
+            <a:schemeClr val="accent1"/>
+          </a:fillRef>
+          <a:effectRef idx="1">
+            <a:schemeClr val="accent1"/>
+          </a:effectRef>
+          <a:fontRef idx="minor">
+            <a:schemeClr val="tx1"/>
+          </a:fontRef>
+        </p:style>
+      </p:cxnSp>
+      <p:sp>
+        <p:nvSpPr>
+          <p:cNvPr id="14" name="TextBox 13"/>
+          <p:cNvSpPr txBox="1"/>
+          <p:nvPr/>
+        </p:nvSpPr>
+        <p:spPr>
+          <a:xfrm>
+            <a:off x="9875520" y="1737360"/>
+            <a:ext cx="2286000" cy="731520"/>
+          </a:xfrm>
+          <a:prstGeom prst="rect">
+            <a:avLst/>
+          </a:prstGeom>
+          <a:noFill/>
+        </p:spPr>
+        <p:txBody>
+          <a:bodyPr wrap="square">
+            <a:spAutoFit/>
+          </a:bodyPr>
+          <a:lstStyle/>
+          <a:p>
+            <a:pPr algn="ctr"/>
+            <a:r>
+              <a:rPr sz="1000" b="0">
+                <a:solidFill>
+                  <a:srgbClr val="2A9D8F"/>
+                </a:solidFill>
+              </a:rPr>
+              <a:t>truth 0.44 -&gt; PIT 0.34</a:t>
+            </a:r>
+          </a:p>
+        </p:txBody>
+      </p:sp>
+      <p:sp>
+        <p:nvSpPr>
+          <p:cNvPr id="15" name="TextBox 14"/>
+          <p:cNvSpPr txBox="1"/>
+          <p:nvPr/>
+        </p:nvSpPr>
+        <p:spPr>
+          <a:xfrm>
+            <a:off x="502920" y="4160520"/>
+            <a:ext cx="11155680" cy="731520"/>
+          </a:xfrm>
+          <a:prstGeom prst="rect">
+            <a:avLst/>
+          </a:prstGeom>
+          <a:noFill/>
+        </p:spPr>
+        <p:txBody>
+          <a:bodyPr wrap="square">
+            <a:spAutoFit/>
+          </a:bodyPr>
+          <a:lstStyle/>
+          <a:p>
+            <a:pPr algn="l"/>
+            <a:r>
+              <a:rPr sz="1100" b="0">
+                <a:solidFill>
+                  <a:srgbClr val="1A2238"/>
+                </a:solidFill>
+              </a:rPr>
+              <a:t>each present phase's marginal is a Beta distribution; PIT = where the truth lands inside it (its CDF value). Over many rows a flat PIT histogram means the spread is honest; a U means overconfident (truth keeps escaping the claimed range), a hump means underconfident.</a:t>
+            </a:r>
+          </a:p>
+        </p:txBody>
+      </p:sp>
+      <p:sp>
+        <p:nvSpPr>
+          <p:cNvPr id="16" name="TextBox 15"/>
+          <p:cNvSpPr txBox="1"/>
+          <p:nvPr/>
+        </p:nvSpPr>
+        <p:spPr>
+          <a:xfrm>
+            <a:off x="502920" y="4892040"/>
+            <a:ext cx="11155680" cy="731520"/>
+          </a:xfrm>
+          <a:prstGeom prst="rect">
+            <a:avLst/>
+          </a:prstGeom>
+          <a:noFill/>
+        </p:spPr>
+        <p:txBody>
+          <a:bodyPr wrap="square">
+            <a:spAutoFit/>
+          </a:bodyPr>
+          <a:lstStyle/>
+          <a:p>
+            <a:pPr algn="l"/>
+            <a:r>
+              <a:rPr sz="1100" b="0">
+                <a:solidFill>
+                  <a:srgbClr val="1A2238"/>
+                </a:solidFill>
+              </a:rPr>
+              <a:t>the support is teacher-forced: training and this eval slice alpha to the row's TRUE present set (absent phases contribute nothing -- they belong to the Bernoullis; the sub-composition of a Dirichlet is itself a Dirichlet, so the sliced score is a proper density). At inference the support is sampled from the presence branch instead.</a:t>
+            </a:r>
+          </a:p>
+        </p:txBody>
+      </p:sp>
+      <p:sp>
+        <p:nvSpPr>
+          <p:cNvPr id="17" name="TextBox 16"/>
+          <p:cNvSpPr txBox="1"/>
+          <p:nvPr/>
+        </p:nvSpPr>
+        <p:spPr>
+          <a:xfrm>
+            <a:off x="502920" y="5760720"/>
+            <a:ext cx="11155680" cy="731520"/>
+          </a:xfrm>
+          <a:prstGeom prst="rect">
+            <a:avLst/>
+          </a:prstGeom>
+          <a:noFill/>
+        </p:spPr>
+        <p:txBody>
+          <a:bodyPr wrap="square">
+            <a:spAutoFit/>
+          </a:bodyPr>
+          <a:lstStyle/>
+          <a:p>
+            <a:pPr algn="l"/>
+            <a:r>
+              <a:rPr sz="1000" b="0">
+                <a:solidFill>
+                  <a:srgbClr val="8A93A3"/>
+                </a:solidFill>
+              </a:rPr>
+              <a:t>population: only truly-present (row, phase) pairs are scored -- ~68k pairs for plag down to ~200 for corundum; single-phase rows are excluded (nothing to size). current limits (provisional): amphibole U-shaped PIT (spread too narrow; truth plausibly bimodal across paths), oxide accessories humped (too wide), plag under-sized. full report: results/mode_head/&lt;tag&gt;/ (magnitude_parity, magnitude_pit).</a:t>
+            </a:r>
+          </a:p>
+        </p:txBody>
+      </p:sp>
+    </p:spTree>
+  </p:cSld>
+  <p:clrMapOvr>
+    <a:masterClrMapping/>
+  </p:clrMapOvr>
+</p:sld>
+</file>
+
+<file path=ppt/slides/slide16.xml><?xml version="1.0" encoding="utf-8"?>
+<p:sld xmlns:a="http://schemas.openxmlformats.org/drawingml/2006/main" xmlns:p="http://schemas.openxmlformats.org/presentationml/2006/main" xmlns:r="http://schemas.openxmlformats.org/officeDocument/2006/relationships">
+  <p:cSld>
+    <p:spTree>
+      <p:nvGrpSpPr>
+        <p:cNvPr id="1" name=""/>
+        <p:cNvGrpSpPr/>
+        <p:nvPr/>
+      </p:nvGrpSpPr>
+      <p:grpSpPr/>
+      <p:sp>
+        <p:nvSpPr>
+          <p:cNvPr id="2" name="TextBox 1"/>
+          <p:cNvSpPr txBox="1"/>
+          <p:nvPr/>
+        </p:nvSpPr>
+        <p:spPr>
+          <a:xfrm>
+            <a:off x="502920" y="274320"/>
+            <a:ext cx="10972800" cy="365760"/>
+          </a:xfrm>
+          <a:prstGeom prst="rect">
+            <a:avLst/>
+          </a:prstGeom>
+          <a:noFill/>
+        </p:spPr>
+        <p:txBody>
+          <a:bodyPr wrap="square">
+            <a:spAutoFit/>
+          </a:bodyPr>
+          <a:lstStyle/>
+          <a:p>
+            <a:pPr algn="l"/>
+            <a:r>
+              <a:rPr sz="1300" b="1">
+                <a:solidFill>
+                  <a:srgbClr val="2E5BFF"/>
+                </a:solidFill>
+              </a:rPr>
+              <a:t>HEADS</a:t>
+            </a:r>
+          </a:p>
+        </p:txBody>
+      </p:sp>
+      <p:sp>
+        <p:nvSpPr>
+          <p:cNvPr id="3" name="TextBox 2"/>
+          <p:cNvSpPr txBox="1"/>
+          <p:nvPr/>
+        </p:nvSpPr>
+        <p:spPr>
+          <a:xfrm>
+            <a:off x="502920" y="603504"/>
+            <a:ext cx="11155680" cy="731520"/>
+          </a:xfrm>
+          <a:prstGeom prst="rect">
+            <a:avLst/>
+          </a:prstGeom>
+          <a:noFill/>
+        </p:spPr>
+        <p:txBody>
+          <a:bodyPr wrap="square">
+            <a:spAutoFit/>
+          </a:bodyPr>
+          <a:lstStyle/>
+          <a:p>
+            <a:pPr algn="l"/>
+            <a:r>
+              <a:rPr sz="2600" b="1">
+                <a:solidFill>
+                  <a:srgbClr val="1A2238"/>
+                </a:solidFill>
+              </a:rPr>
               <a:t>What the heads emit (distributions, not point estimates)</a:t>
             </a:r>
           </a:p>
@@ -12483,7 +13506,7 @@
 </p:sld>
 </file>
 
-<file path=ppt/slides/slide16.xml><?xml version="1.0" encoding="utf-8"?>
+<file path=ppt/slides/slide17.xml><?xml version="1.0" encoding="utf-8"?>
 <p:sld xmlns:a="http://schemas.openxmlformats.org/drawingml/2006/main" xmlns:p="http://schemas.openxmlformats.org/presentationml/2006/main" xmlns:r="http://schemas.openxmlformats.org/officeDocument/2006/relationships">
   <p:cSld>
     <p:spTree>

</xml_diff>

<commit_message>
Dirichlet worked-example slide: redraw as two tracks converging at a scoring node (truth contributes its support only as a grading mask; modes meet prediction at scoring -- old layout implied truth flows into the prediction). Adds expanded masked-NLL box   (normalizer vs shape term, symbol definitions, density-goes-negative caveat) with worked numbers in the notes.
</commit_message>
<xml_diff>
--- a/slides/overview.pptx
+++ b/slides/overview.pptx
@@ -938,7 +938,7 @@
           <a:lstStyle/>
           <a:p>
             <a:r>
-              <a:t>Eval-semantics slide for the magnitude branch, mirroring the presence branch's reliability worked example. Numbers illustrative but to scale: alpha sliced to the true 4-phase support gives Dirichlet means alpha_i/alpha0 and Beta marginals Beta(alpha_i, alpha0 - alpha_i); plag Beta(12,13) has mean 0.48, sd ~0.10, and truth 0.44 lands at CDF 0.34. alpha0 is the single shared confidence knob per row -- the reason per-phase spreads can't be tuned independently (see alpha_concentration.png). PIT histograms are the magnitude analog of reliability diagrams; parity plots are the point-estimate view. Scored by masked Dirichlet NLL (anatomy slide's L_magnitude).</a:t>
+              <a:t>Eval-semantics slide for the magnitude branch, mirroring the presence branch's reliability worked example. Laid out as two tracks converging at a scoring node: the prediction track never sees the truth's modes; the truth contributes only its support to the slice (teacher-forced) and meets the prediction at scoring. Numbers illustrative but to scale: alpha sliced to the true 4-phase support gives Dirichlet means alpha_i/alpha0 and Beta marginals Beta(alpha_i, alpha0 - alpha_i); plag Beta(12,13) has mean 0.48, sd ~0.10, and truth 0.44 lands at CDF 0.34. alpha0 is the single shared confidence knob per row -- the reason per-phase spreads can't be tuned independently (see alpha_concentration.png). PIT histograms are the magnitude analog of reliability diagrams; parity plots are the point-estimate view. Scored by masked Dirichlet NLL (anatomy slide's L_magnitude). Worked numbers for the expansion box: this row scores -4.34 nats (normalizer -28.37 + shape +24.03); scaling alpha x4 improves to -5.26 when truth is near the peak but explodes to +17.9 when truth swaps to the other hump (plag/amp values exchanged) -- the mechanism that pins amphibole's alpha0 low and its mean in the middle.</a:t>
             </a:r>
           </a:p>
         </p:txBody>
@@ -10350,7 +10350,7 @@
                   <a:srgbClr val="8A93A3"/>
                 </a:solidFill>
               </a:rPr>
-              <a:t>the magnitude branch's eval: slice the predicted concentrations to the row's true support, compare means to truth, and ask whether the claimed spread is honest (PIT)</a:t>
+              <a:t>the magnitude branch's eval: slice the predicted concentrations to the row's true support, then meet the truth at the scoring step -- are the means right, and is the claimed spread honest (PIT)?</a:t>
             </a:r>
           </a:p>
         </p:txBody>
@@ -10363,8 +10363,368 @@
         </p:nvSpPr>
         <p:spPr>
           <a:xfrm>
-            <a:off x="502920" y="1920240"/>
-            <a:ext cx="2743200" cy="1828800"/>
+            <a:off x="502920" y="1783080"/>
+            <a:ext cx="2560320" cy="1371600"/>
+          </a:xfrm>
+          <a:prstGeom prst="roundRect">
+            <a:avLst/>
+          </a:prstGeom>
+          <a:solidFill>
+            <a:srgbClr val="FBEEE3"/>
+          </a:solidFill>
+          <a:ln w="25400">
+            <a:solidFill>
+              <a:srgbClr val="E8883A"/>
+            </a:solidFill>
+          </a:ln>
+          <a:effectLst/>
+        </p:spPr>
+        <p:style>
+          <a:lnRef idx="1">
+            <a:schemeClr val="accent1"/>
+          </a:lnRef>
+          <a:fillRef idx="3">
+            <a:schemeClr val="accent1"/>
+          </a:fillRef>
+          <a:effectRef idx="2">
+            <a:schemeClr val="accent1"/>
+          </a:effectRef>
+          <a:fontRef idx="minor">
+            <a:schemeClr val="lt1"/>
+          </a:fontRef>
+        </p:style>
+        <p:txBody>
+          <a:bodyPr rtlCol="0" anchor="ctr" wrap="square"/>
+          <a:lstStyle/>
+          <a:p>
+            <a:pPr algn="ctr"/>
+            <a:r>
+              <a:rPr sz="1100" b="1">
+                <a:solidFill>
+                  <a:srgbClr val="1A2238"/>
+                </a:solidFill>
+              </a:rPr>
+              <a:t>head output for bulk X</a:t>
+            </a:r>
+          </a:p>
+          <a:p>
+            <a:pPr algn="ctr"/>
+            <a:r>
+              <a:rPr sz="800" b="0">
+                <a:solidFill>
+                  <a:srgbClr val="8A93A3"/>
+                </a:solidFill>
+              </a:rPr>
+              <a:t>alpha for all 21 phases,</a:t>
+            </a:r>
+          </a:p>
+          <a:p>
+            <a:pPr algn="ctr"/>
+            <a:r>
+              <a:rPr sz="800" b="0">
+                <a:solidFill>
+                  <a:srgbClr val="8A93A3"/>
+                </a:solidFill>
+              </a:rPr>
+              <a:t>computed from the latent --</a:t>
+            </a:r>
+          </a:p>
+          <a:p>
+            <a:pPr algn="ctr"/>
+            <a:r>
+              <a:rPr sz="800" b="0">
+                <a:solidFill>
+                  <a:srgbClr val="8A93A3"/>
+                </a:solidFill>
+              </a:rPr>
+              <a:t>truth is not an input</a:t>
+            </a:r>
+          </a:p>
+        </p:txBody>
+      </p:sp>
+      <p:sp>
+        <p:nvSpPr>
+          <p:cNvPr id="6" name="Right Arrow 5"/>
+          <p:cNvSpPr/>
+          <p:nvPr/>
+        </p:nvSpPr>
+        <p:spPr>
+          <a:xfrm>
+            <a:off x="3154680" y="2331720"/>
+            <a:ext cx="320040" cy="274320"/>
+          </a:xfrm>
+          <a:prstGeom prst="rightArrow">
+            <a:avLst/>
+          </a:prstGeom>
+          <a:solidFill>
+            <a:srgbClr val="1A2238"/>
+          </a:solidFill>
+          <a:ln>
+            <a:noFill/>
+          </a:ln>
+          <a:effectLst/>
+        </p:spPr>
+        <p:style>
+          <a:lnRef idx="1">
+            <a:schemeClr val="accent1"/>
+          </a:lnRef>
+          <a:fillRef idx="3">
+            <a:schemeClr val="accent1"/>
+          </a:fillRef>
+          <a:effectRef idx="2">
+            <a:schemeClr val="accent1"/>
+          </a:effectRef>
+          <a:fontRef idx="minor">
+            <a:schemeClr val="lt1"/>
+          </a:fontRef>
+        </p:style>
+        <p:txBody>
+          <a:bodyPr rtlCol="0" anchor="ctr"/>
+          <a:lstStyle/>
+          <a:p>
+            <a:pPr algn="ctr"/>
+          </a:p>
+        </p:txBody>
+      </p:sp>
+      <p:sp>
+        <p:nvSpPr>
+          <p:cNvPr id="7" name="Rounded Rectangle 6"/>
+          <p:cNvSpPr/>
+          <p:nvPr/>
+        </p:nvSpPr>
+        <p:spPr>
+          <a:xfrm>
+            <a:off x="3520440" y="1783080"/>
+            <a:ext cx="2560320" cy="1371600"/>
+          </a:xfrm>
+          <a:prstGeom prst="roundRect">
+            <a:avLst/>
+          </a:prstGeom>
+          <a:solidFill>
+            <a:srgbClr val="FBEEE3"/>
+          </a:solidFill>
+          <a:ln w="25400">
+            <a:solidFill>
+              <a:srgbClr val="E8883A"/>
+            </a:solidFill>
+          </a:ln>
+          <a:effectLst/>
+        </p:spPr>
+        <p:style>
+          <a:lnRef idx="1">
+            <a:schemeClr val="accent1"/>
+          </a:lnRef>
+          <a:fillRef idx="3">
+            <a:schemeClr val="accent1"/>
+          </a:fillRef>
+          <a:effectRef idx="2">
+            <a:schemeClr val="accent1"/>
+          </a:effectRef>
+          <a:fontRef idx="minor">
+            <a:schemeClr val="lt1"/>
+          </a:fontRef>
+        </p:style>
+        <p:txBody>
+          <a:bodyPr rtlCol="0" anchor="ctr" wrap="square"/>
+          <a:lstStyle/>
+          <a:p>
+            <a:pPr algn="ctr"/>
+            <a:r>
+              <a:rPr sz="1100" b="1">
+                <a:solidFill>
+                  <a:srgbClr val="1A2238"/>
+                </a:solidFill>
+              </a:rPr>
+              <a:t>alpha sliced to the support</a:t>
+            </a:r>
+          </a:p>
+          <a:p>
+            <a:pPr algn="ctr"/>
+            <a:r>
+              <a:rPr sz="800" b="0">
+                <a:solidFill>
+                  <a:srgbClr val="8A93A3"/>
+                </a:solidFill>
+              </a:rPr>
+              <a:t>plag 12.0    cpx 7.0</a:t>
+            </a:r>
+          </a:p>
+          <a:p>
+            <a:pPr algn="ctr"/>
+            <a:r>
+              <a:rPr sz="800" b="0">
+                <a:solidFill>
+                  <a:srgbClr val="8A93A3"/>
+                </a:solidFill>
+              </a:rPr>
+              <a:t>amp 4.5      ilm 1.5</a:t>
+            </a:r>
+          </a:p>
+          <a:p>
+            <a:pPr algn="ctr"/>
+            <a:r>
+              <a:rPr sz="800" b="0">
+                <a:solidFill>
+                  <a:srgbClr val="8A93A3"/>
+                </a:solidFill>
+              </a:rPr>
+              <a:t>alpha0 = sum = 25 (confidence)</a:t>
+            </a:r>
+          </a:p>
+        </p:txBody>
+      </p:sp>
+      <p:sp>
+        <p:nvSpPr>
+          <p:cNvPr id="8" name="Right Arrow 7"/>
+          <p:cNvSpPr/>
+          <p:nvPr/>
+        </p:nvSpPr>
+        <p:spPr>
+          <a:xfrm>
+            <a:off x="6172200" y="2331720"/>
+            <a:ext cx="320040" cy="274320"/>
+          </a:xfrm>
+          <a:prstGeom prst="rightArrow">
+            <a:avLst/>
+          </a:prstGeom>
+          <a:solidFill>
+            <a:srgbClr val="1A2238"/>
+          </a:solidFill>
+          <a:ln>
+            <a:noFill/>
+          </a:ln>
+          <a:effectLst/>
+        </p:spPr>
+        <p:style>
+          <a:lnRef idx="1">
+            <a:schemeClr val="accent1"/>
+          </a:lnRef>
+          <a:fillRef idx="3">
+            <a:schemeClr val="accent1"/>
+          </a:fillRef>
+          <a:effectRef idx="2">
+            <a:schemeClr val="accent1"/>
+          </a:effectRef>
+          <a:fontRef idx="minor">
+            <a:schemeClr val="lt1"/>
+          </a:fontRef>
+        </p:style>
+        <p:txBody>
+          <a:bodyPr rtlCol="0" anchor="ctr"/>
+          <a:lstStyle/>
+          <a:p>
+            <a:pPr algn="ctr"/>
+          </a:p>
+        </p:txBody>
+      </p:sp>
+      <p:sp>
+        <p:nvSpPr>
+          <p:cNvPr id="9" name="Rounded Rectangle 8"/>
+          <p:cNvSpPr/>
+          <p:nvPr/>
+        </p:nvSpPr>
+        <p:spPr>
+          <a:xfrm>
+            <a:off x="6537960" y="1783080"/>
+            <a:ext cx="2560320" cy="1371600"/>
+          </a:xfrm>
+          <a:prstGeom prst="roundRect">
+            <a:avLst/>
+          </a:prstGeom>
+          <a:solidFill>
+            <a:srgbClr val="EAE8FB"/>
+          </a:solidFill>
+          <a:ln w="25400">
+            <a:solidFill>
+              <a:srgbClr val="6C5CE7"/>
+            </a:solidFill>
+          </a:ln>
+          <a:effectLst/>
+        </p:spPr>
+        <p:style>
+          <a:lnRef idx="1">
+            <a:schemeClr val="accent1"/>
+          </a:lnRef>
+          <a:fillRef idx="3">
+            <a:schemeClr val="accent1"/>
+          </a:fillRef>
+          <a:effectRef idx="2">
+            <a:schemeClr val="accent1"/>
+          </a:effectRef>
+          <a:fontRef idx="minor">
+            <a:schemeClr val="lt1"/>
+          </a:fontRef>
+        </p:style>
+        <p:txBody>
+          <a:bodyPr rtlCol="0" anchor="ctr" wrap="square"/>
+          <a:lstStyle/>
+          <a:p>
+            <a:pPr algn="ctr"/>
+            <a:r>
+              <a:rPr sz="1100" b="1">
+                <a:solidFill>
+                  <a:srgbClr val="1A2238"/>
+                </a:solidFill>
+              </a:rPr>
+              <a:t>predicted mean +/- spread</a:t>
+            </a:r>
+          </a:p>
+          <a:p>
+            <a:pPr algn="ctr"/>
+            <a:r>
+              <a:rPr sz="800" b="0">
+                <a:solidFill>
+                  <a:srgbClr val="8A93A3"/>
+                </a:solidFill>
+              </a:rPr>
+              <a:t>plag 0.48 +/- 0.10</a:t>
+            </a:r>
+          </a:p>
+          <a:p>
+            <a:pPr algn="ctr"/>
+            <a:r>
+              <a:rPr sz="800" b="0">
+                <a:solidFill>
+                  <a:srgbClr val="8A93A3"/>
+                </a:solidFill>
+              </a:rPr>
+              <a:t>cpx 0.28 +/- 0.09</a:t>
+            </a:r>
+          </a:p>
+          <a:p>
+            <a:pPr algn="ctr"/>
+            <a:r>
+              <a:rPr sz="800" b="0">
+                <a:solidFill>
+                  <a:srgbClr val="8A93A3"/>
+                </a:solidFill>
+              </a:rPr>
+              <a:t>amp 0.18 +/- 0.08</a:t>
+            </a:r>
+          </a:p>
+          <a:p>
+            <a:pPr algn="ctr"/>
+            <a:r>
+              <a:rPr sz="800" b="0">
+                <a:solidFill>
+                  <a:srgbClr val="8A93A3"/>
+                </a:solidFill>
+              </a:rPr>
+              <a:t>ilm 0.06 +/- 0.05</a:t>
+            </a:r>
+          </a:p>
+        </p:txBody>
+      </p:sp>
+      <p:sp>
+        <p:nvSpPr>
+          <p:cNvPr id="10" name="Rounded Rectangle 9"/>
+          <p:cNvSpPr/>
+          <p:nvPr/>
+        </p:nvSpPr>
+        <p:spPr>
+          <a:xfrm>
+            <a:off x="502920" y="3429000"/>
+            <a:ext cx="2560320" cy="1188720"/>
           </a:xfrm>
           <a:prstGeom prst="roundRect">
             <a:avLst/>
@@ -10399,7 +10759,7 @@
           <a:p>
             <a:pPr algn="ctr"/>
             <a:r>
-              <a:rPr sz="1200" b="1">
+              <a:rPr sz="1100" b="1">
                 <a:solidFill>
                   <a:srgbClr val="1A2238"/>
                 </a:solidFill>
@@ -10410,7 +10770,7 @@
           <a:p>
             <a:pPr algn="ctr"/>
             <a:r>
-              <a:rPr sz="900" b="0">
+              <a:rPr sz="800" b="0">
                 <a:solidFill>
                   <a:srgbClr val="8A93A3"/>
                 </a:solidFill>
@@ -10421,7 +10781,7 @@
           <a:p>
             <a:pPr algn="ctr"/>
             <a:r>
-              <a:rPr sz="900" b="0">
+              <a:rPr sz="800" b="0">
                 <a:solidFill>
                   <a:srgbClr val="8A93A3"/>
                 </a:solidFill>
@@ -10432,7 +10792,7 @@
           <a:p>
             <a:pPr algn="ctr"/>
             <a:r>
-              <a:rPr sz="900" b="0">
+              <a:rPr sz="800" b="0">
                 <a:solidFill>
                   <a:srgbClr val="8A93A3"/>
                 </a:solidFill>
@@ -10440,29 +10800,18 @@
               <a:t>modes: .44  .26  .19  .11</a:t>
             </a:r>
           </a:p>
-          <a:p>
-            <a:pPr algn="ctr"/>
-            <a:r>
-              <a:rPr sz="900" b="0">
-                <a:solidFill>
-                  <a:srgbClr val="8A93A3"/>
-                </a:solidFill>
-              </a:rPr>
-              <a:t>(crystals-renormalized, sum 1)</a:t>
-            </a:r>
-          </a:p>
-        </p:txBody>
-      </p:sp>
-      <p:sp>
-        <p:nvSpPr>
-          <p:cNvPr id="6" name="Right Arrow 5"/>
+        </p:txBody>
+      </p:sp>
+      <p:sp>
+        <p:nvSpPr>
+          <p:cNvPr id="11" name="Right Arrow 10"/>
           <p:cNvSpPr/>
           <p:nvPr/>
         </p:nvSpPr>
         <p:spPr>
           <a:xfrm>
-            <a:off x="3337560" y="2651760"/>
-            <a:ext cx="365760" cy="320040"/>
+            <a:off x="3154680" y="3886200"/>
+            <a:ext cx="320040" cy="274320"/>
           </a:xfrm>
           <a:prstGeom prst="rightArrow">
             <a:avLst/>
@@ -10499,24 +10848,24 @@
       </p:sp>
       <p:sp>
         <p:nvSpPr>
-          <p:cNvPr id="7" name="Rounded Rectangle 6"/>
+          <p:cNvPr id="12" name="Rounded Rectangle 11"/>
           <p:cNvSpPr/>
           <p:nvPr/>
         </p:nvSpPr>
         <p:spPr>
           <a:xfrm>
-            <a:off x="3794760" y="1920240"/>
-            <a:ext cx="2743200" cy="1828800"/>
+            <a:off x="3520440" y="3429000"/>
+            <a:ext cx="2560320" cy="1188720"/>
           </a:xfrm>
           <a:prstGeom prst="roundRect">
             <a:avLst/>
           </a:prstGeom>
           <a:solidFill>
-            <a:srgbClr val="FBEEE3"/>
+            <a:srgbClr val="E1E8FF"/>
           </a:solidFill>
           <a:ln w="25400">
             <a:solidFill>
-              <a:srgbClr val="E8883A"/>
+              <a:srgbClr val="2E5BFF"/>
             </a:solidFill>
           </a:ln>
           <a:effectLst/>
@@ -10541,122 +10890,123 @@
           <a:p>
             <a:pPr algn="ctr"/>
             <a:r>
-              <a:rPr sz="1200" b="1">
+              <a:rPr sz="1100" b="1">
                 <a:solidFill>
                   <a:srgbClr val="1A2238"/>
                 </a:solidFill>
               </a:rPr>
-              <a:t>head output for bulk X</a:t>
-            </a:r>
-          </a:p>
-          <a:p>
-            <a:pPr algn="ctr"/>
+              <a:t>scoring -- truth meets prediction</a:t>
+            </a:r>
+          </a:p>
+          <a:p>
+            <a:pPr algn="ctr"/>
+            <a:r>
+              <a:rPr sz="800" b="0">
+                <a:solidFill>
+                  <a:srgbClr val="8A93A3"/>
+                </a:solidFill>
+              </a:rPr>
+              <a:t>eval: PIT of each true mode</a:t>
+            </a:r>
+          </a:p>
+          <a:p>
+            <a:pPr algn="ctr"/>
+            <a:r>
+              <a:rPr sz="800" b="0">
+                <a:solidFill>
+                  <a:srgbClr val="8A93A3"/>
+                </a:solidFill>
+              </a:rPr>
+              <a:t>train: masked Dirichlet NLL</a:t>
+            </a:r>
+          </a:p>
+        </p:txBody>
+      </p:sp>
+      <p:cxnSp>
+        <p:nvCxnSpPr>
+          <p:cNvPr id="13" name="Connector 12"/>
+          <p:cNvCxnSpPr/>
+          <p:nvPr/>
+        </p:nvCxnSpPr>
+        <p:spPr>
+          <a:xfrm flipV="1">
+            <a:off x="2651760" y="3154680"/>
+            <a:ext cx="1280160" cy="274320"/>
+          </a:xfrm>
+          <a:prstGeom prst="bentConnector3">
+            <a:avLst/>
+          </a:prstGeom>
+          <a:ln w="19050">
+            <a:solidFill>
+              <a:srgbClr val="2A9D8F"/>
+            </a:solidFill>
+          </a:ln>
+          <a:effectLst/>
+        </p:spPr>
+        <p:style>
+          <a:lnRef idx="2">
+            <a:schemeClr val="accent1"/>
+          </a:lnRef>
+          <a:fillRef idx="0">
+            <a:schemeClr val="accent1"/>
+          </a:fillRef>
+          <a:effectRef idx="1">
+            <a:schemeClr val="accent1"/>
+          </a:effectRef>
+          <a:fontRef idx="minor">
+            <a:schemeClr val="tx1"/>
+          </a:fontRef>
+        </p:style>
+      </p:cxnSp>
+      <p:sp>
+        <p:nvSpPr>
+          <p:cNvPr id="14" name="TextBox 13"/>
+          <p:cNvSpPr txBox="1"/>
+          <p:nvPr/>
+        </p:nvSpPr>
+        <p:spPr>
+          <a:xfrm>
+            <a:off x="548640" y="3172968"/>
+            <a:ext cx="2377440" cy="731520"/>
+          </a:xfrm>
+          <a:prstGeom prst="rect">
+            <a:avLst/>
+          </a:prstGeom>
+          <a:noFill/>
+        </p:spPr>
+        <p:txBody>
+          <a:bodyPr wrap="square">
+            <a:spAutoFit/>
+          </a:bodyPr>
+          <a:lstStyle/>
+          <a:p>
+            <a:pPr algn="l"/>
             <a:r>
               <a:rPr sz="900" b="0">
                 <a:solidFill>
-                  <a:srgbClr val="8A93A3"/>
-                </a:solidFill>
-              </a:rPr>
-              <a:t>alpha, sliced to the true support:</a:t>
-            </a:r>
-          </a:p>
-          <a:p>
-            <a:pPr algn="ctr"/>
-            <a:r>
-              <a:rPr sz="900" b="0">
-                <a:solidFill>
-                  <a:srgbClr val="8A93A3"/>
-                </a:solidFill>
-              </a:rPr>
-              <a:t>plag 12.0    cpx 7.0</a:t>
-            </a:r>
-          </a:p>
-          <a:p>
-            <a:pPr algn="ctr"/>
-            <a:r>
-              <a:rPr sz="900" b="0">
-                <a:solidFill>
-                  <a:srgbClr val="8A93A3"/>
-                </a:solidFill>
-              </a:rPr>
-              <a:t>amp 4.5      ilm 1.5</a:t>
-            </a:r>
-          </a:p>
-          <a:p>
-            <a:pPr algn="ctr"/>
-            <a:r>
-              <a:rPr sz="900" b="0">
-                <a:solidFill>
-                  <a:srgbClr val="8A93A3"/>
-                </a:solidFill>
-              </a:rPr>
-              <a:t>alpha0 = sum = 25 (confidence)</a:t>
-            </a:r>
-          </a:p>
-        </p:txBody>
-      </p:sp>
-      <p:sp>
-        <p:nvSpPr>
-          <p:cNvPr id="8" name="Right Arrow 7"/>
-          <p:cNvSpPr/>
-          <p:nvPr/>
-        </p:nvSpPr>
-        <p:spPr>
-          <a:xfrm>
-            <a:off x="6629400" y="2651760"/>
-            <a:ext cx="365760" cy="320040"/>
-          </a:xfrm>
-          <a:prstGeom prst="rightArrow">
-            <a:avLst/>
-          </a:prstGeom>
-          <a:solidFill>
-            <a:srgbClr val="1A2238"/>
-          </a:solidFill>
-          <a:ln>
-            <a:noFill/>
-          </a:ln>
-          <a:effectLst/>
-        </p:spPr>
-        <p:style>
-          <a:lnRef idx="1">
-            <a:schemeClr val="accent1"/>
-          </a:lnRef>
-          <a:fillRef idx="3">
-            <a:schemeClr val="accent1"/>
-          </a:fillRef>
-          <a:effectRef idx="2">
-            <a:schemeClr val="accent1"/>
-          </a:effectRef>
-          <a:fontRef idx="minor">
-            <a:schemeClr val="lt1"/>
-          </a:fontRef>
-        </p:style>
-        <p:txBody>
-          <a:bodyPr rtlCol="0" anchor="ctr"/>
-          <a:lstStyle/>
-          <a:p>
-            <a:pPr algn="ctr"/>
-          </a:p>
-        </p:txBody>
-      </p:sp>
-      <p:sp>
-        <p:nvSpPr>
-          <p:cNvPr id="9" name="Rounded Rectangle 8"/>
-          <p:cNvSpPr/>
-          <p:nvPr/>
-        </p:nvSpPr>
-        <p:spPr>
-          <a:xfrm>
-            <a:off x="7086600" y="1920240"/>
-            <a:ext cx="2743200" cy="1828800"/>
-          </a:xfrm>
-          <a:prstGeom prst="roundRect">
-            <a:avLst/>
-          </a:prstGeom>
-          <a:solidFill>
-            <a:srgbClr val="EAE8FB"/>
-          </a:solidFill>
-          <a:ln w="25400">
+                  <a:srgbClr val="2A9D8F"/>
+                </a:solidFill>
+              </a:rPr>
+              <a:t>support only (which phases)</a:t>
+            </a:r>
+          </a:p>
+        </p:txBody>
+      </p:sp>
+      <p:cxnSp>
+        <p:nvCxnSpPr>
+          <p:cNvPr id="15" name="Connector 14"/>
+          <p:cNvCxnSpPr/>
+          <p:nvPr/>
+        </p:nvCxnSpPr>
+        <p:spPr>
+          <a:xfrm flipH="1">
+            <a:off x="6080760" y="3154680"/>
+            <a:ext cx="1737360" cy="777240"/>
+          </a:xfrm>
+          <a:prstGeom prst="bentConnector3">
+            <a:avLst/>
+          </a:prstGeom>
+          <a:ln w="19050">
             <a:solidFill>
               <a:srgbClr val="6C5CE7"/>
             </a:solidFill>
@@ -10664,6 +11014,45 @@
           <a:effectLst/>
         </p:spPr>
         <p:style>
+          <a:lnRef idx="2">
+            <a:schemeClr val="accent1"/>
+          </a:lnRef>
+          <a:fillRef idx="0">
+            <a:schemeClr val="accent1"/>
+          </a:fillRef>
+          <a:effectRef idx="1">
+            <a:schemeClr val="accent1"/>
+          </a:effectRef>
+          <a:fontRef idx="minor">
+            <a:schemeClr val="tx1"/>
+          </a:fontRef>
+        </p:style>
+      </p:cxnSp>
+      <p:sp>
+        <p:nvSpPr>
+          <p:cNvPr id="16" name="Rounded Rectangle 15"/>
+          <p:cNvSpPr/>
+          <p:nvPr/>
+        </p:nvSpPr>
+        <p:spPr>
+          <a:xfrm>
+            <a:off x="7315200" y="3429000"/>
+            <a:ext cx="4297680" cy="1188720"/>
+          </a:xfrm>
+          <a:prstGeom prst="roundRect">
+            <a:avLst/>
+          </a:prstGeom>
+          <a:solidFill>
+            <a:srgbClr val="FFFFFF"/>
+          </a:solidFill>
+          <a:ln w="12700">
+            <a:solidFill>
+              <a:srgbClr val="C8CDD6"/>
+            </a:solidFill>
+          </a:ln>
+          <a:effectLst/>
+        </p:spPr>
+        <p:style>
           <a:lnRef idx="1">
             <a:schemeClr val="accent1"/>
           </a:lnRef>
@@ -10683,63 +11072,74 @@
           <a:p>
             <a:pPr algn="ctr"/>
             <a:r>
-              <a:rPr sz="1200" b="1">
-                <a:solidFill>
-                  <a:srgbClr val="1A2238"/>
-                </a:solidFill>
-              </a:rPr>
-              <a:t>predicted mean +/- spread</a:t>
-            </a:r>
-          </a:p>
-          <a:p>
-            <a:pPr algn="ctr"/>
-            <a:r>
-              <a:rPr sz="900" b="0">
+              <a:rPr sz="1100" b="1">
                 <a:solidFill>
                   <a:srgbClr val="8A93A3"/>
                 </a:solidFill>
               </a:rPr>
-              <a:t>plag 0.48 +/- 0.10   (true .44)</a:t>
-            </a:r>
-          </a:p>
-          <a:p>
-            <a:pPr algn="ctr"/>
-            <a:r>
-              <a:rPr sz="900" b="0">
+              <a:t>L_magnitude = −log Dir(mₛ | αₛ), expanded:</a:t>
+            </a:r>
+          </a:p>
+          <a:p>
+            <a:pPr algn="ctr"/>
+            <a:r>
+              <a:rPr sz="1100" b="1">
                 <a:solidFill>
                   <a:srgbClr val="8A93A3"/>
                 </a:solidFill>
               </a:rPr>
-              <a:t>cpx 0.28 +/- 0.09   (true .26)</a:t>
-            </a:r>
-          </a:p>
-          <a:p>
-            <a:pPr algn="ctr"/>
-            <a:r>
-              <a:rPr sz="900" b="0">
+              <a:t>= Σ lnΓ(αᵢ) − lnΓ(α₀) − Σ (αᵢ−1) ln mᵢ   (sums over S)</a:t>
+            </a:r>
+          </a:p>
+          <a:p>
+            <a:pPr algn="ctr"/>
+            <a:r>
+              <a:rPr sz="800" b="0">
                 <a:solidFill>
                   <a:srgbClr val="8A93A3"/>
                 </a:solidFill>
               </a:rPr>
-              <a:t>amp 0.18 +/- 0.08   (true .19)</a:t>
-            </a:r>
-          </a:p>
-          <a:p>
-            <a:pPr algn="ctr"/>
-            <a:r>
-              <a:rPr sz="900" b="0">
+              <a:t>mᵢ true mode . αᵢ predicted concentration . α₀ = Σ αᵢ . Γ extends factorial</a:t>
+            </a:r>
+          </a:p>
+          <a:p>
+            <a:pPr algn="ctr"/>
+            <a:r>
+              <a:rPr sz="800" b="0">
                 <a:solidFill>
                   <a:srgbClr val="8A93A3"/>
                 </a:solidFill>
               </a:rPr>
-              <a:t>ilm 0.06 +/- 0.05   (true .11)</a:t>
-            </a:r>
-          </a:p>
-        </p:txBody>
-      </p:sp>
-      <p:sp>
-        <p:nvSpPr>
-          <p:cNvPr id="10" name="Freeform 9"/>
+              <a:t>Γ terms: normalizer -- the cost of confidence, grows with α₀</a:t>
+            </a:r>
+          </a:p>
+          <a:p>
+            <a:pPr algn="ctr"/>
+            <a:r>
+              <a:rPr sz="800" b="0">
+                <a:solidFill>
+                  <a:srgbClr val="8A93A3"/>
+                </a:solidFill>
+              </a:rPr>
+              <a:t>(αᵢ−1) ln mᵢ: shape term -- the only place truth meets prediction</a:t>
+            </a:r>
+          </a:p>
+          <a:p>
+            <a:pPr algn="ctr"/>
+            <a:r>
+              <a:rPr sz="800" b="0">
+                <a:solidFill>
+                  <a:srgbClr val="8A93A3"/>
+                </a:solidFill>
+              </a:rPr>
+              <a:t>a density, not a probability -- well-scored rows go negative</a:t>
+            </a:r>
+          </a:p>
+        </p:txBody>
+      </p:sp>
+      <p:sp>
+        <p:nvSpPr>
+          <p:cNvPr id="17" name="Freeform 16"/>
           <p:cNvSpPr/>
           <p:nvPr/>
         </p:nvSpPr>
@@ -10947,7 +11347,7 @@
       </p:sp>
       <p:cxnSp>
         <p:nvCxnSpPr>
-          <p:cNvPr id="11" name="Connector 10"/>
+          <p:cNvPr id="18" name="Connector 17"/>
           <p:cNvCxnSpPr/>
           <p:nvPr/>
         </p:nvCxnSpPr>
@@ -10983,7 +11383,7 @@
       </p:cxnSp>
       <p:sp>
         <p:nvSpPr>
-          <p:cNvPr id="12" name="TextBox 11"/>
+          <p:cNvPr id="19" name="TextBox 18"/>
           <p:cNvSpPr txBox="1"/>
           <p:nvPr/>
         </p:nvSpPr>
@@ -11017,7 +11417,7 @@
       </p:sp>
       <p:cxnSp>
         <p:nvCxnSpPr>
-          <p:cNvPr id="13" name="Connector 12"/>
+          <p:cNvPr id="20" name="Connector 19"/>
           <p:cNvCxnSpPr/>
           <p:nvPr/>
         </p:nvCxnSpPr>
@@ -11053,7 +11453,7 @@
       </p:cxnSp>
       <p:sp>
         <p:nvSpPr>
-          <p:cNvPr id="14" name="TextBox 13"/>
+          <p:cNvPr id="21" name="TextBox 20"/>
           <p:cNvSpPr txBox="1"/>
           <p:nvPr/>
         </p:nvSpPr>
@@ -11087,13 +11487,13 @@
       </p:sp>
       <p:sp>
         <p:nvSpPr>
-          <p:cNvPr id="15" name="TextBox 14"/>
+          <p:cNvPr id="22" name="TextBox 21"/>
           <p:cNvSpPr txBox="1"/>
           <p:nvPr/>
         </p:nvSpPr>
         <p:spPr>
           <a:xfrm>
-            <a:off x="502920" y="4160520"/>
+            <a:off x="502920" y="4754880"/>
             <a:ext cx="11155680" cy="731520"/>
           </a:xfrm>
           <a:prstGeom prst="rect">
@@ -11121,13 +11521,13 @@
       </p:sp>
       <p:sp>
         <p:nvSpPr>
-          <p:cNvPr id="16" name="TextBox 15"/>
+          <p:cNvPr id="23" name="TextBox 22"/>
           <p:cNvSpPr txBox="1"/>
           <p:nvPr/>
         </p:nvSpPr>
         <p:spPr>
           <a:xfrm>
-            <a:off x="502920" y="4892040"/>
+            <a:off x="502920" y="5486400"/>
             <a:ext cx="11155680" cy="731520"/>
           </a:xfrm>
           <a:prstGeom prst="rect">
@@ -11148,20 +11548,20 @@
                   <a:srgbClr val="1A2238"/>
                 </a:solidFill>
               </a:rPr>
-              <a:t>the support is teacher-forced: training and this eval slice alpha to the row's TRUE present set (absent phases contribute nothing -- they belong to the Bernoullis; the sub-composition of a Dirichlet is itself a Dirichlet, so the sliced score is a proper density). At inference the support is sampled from the presence branch instead.</a:t>
-            </a:r>
-          </a:p>
-        </p:txBody>
-      </p:sp>
-      <p:sp>
-        <p:nvSpPr>
-          <p:cNvPr id="17" name="TextBox 16"/>
+              <a:t>the truth plays two roles, never as a model input: its support slices alpha (teacher-forced at train/eval, sampled from the presence branch at inference; a Dirichlet sub-composition is itself a Dirichlet, so the sliced score is a proper density), and its modes appear only at the scoring step.</a:t>
+            </a:r>
+          </a:p>
+        </p:txBody>
+      </p:sp>
+      <p:sp>
+        <p:nvSpPr>
+          <p:cNvPr id="24" name="TextBox 23"/>
           <p:cNvSpPr txBox="1"/>
           <p:nvPr/>
         </p:nvSpPr>
         <p:spPr>
           <a:xfrm>
-            <a:off x="502920" y="5760720"/>
+            <a:off x="502920" y="6263640"/>
             <a:ext cx="11155680" cy="731520"/>
           </a:xfrm>
           <a:prstGeom prst="rect">

</xml_diff>

<commit_message>
with valtest corpus generation complete, swapped that in for the previous split on train (Whereby 80% of train was used to train and 20% used for the quality control evals and plots. updated slides, docs, tests, etc. accordingly. no major changes in conclusions, though stronger on amphibole strengthens intuition on previous exploration re: bimodality, conditioning mode prediction on the set of predicted minerals, and mixture of distribution prediction
</commit_message>
<xml_diff>
--- a/slides/overview.pptx
+++ b/slides/overview.pptx
@@ -868,7 +868,7 @@
           <a:lstStyle/>
           <a:p>
             <a:r>
-              <a:t>Worked example for the reliability diagram in results/mode_head/&lt;tag&gt;/reliability.png. Numbers illustrative but to scale: three rocks predicted in [0.70, 0.80) -- a real bin edge of the 10 equal-width bins the code uses -- contribute 3 predictions x 96 labels = 288 (p, truth) pairs -- 3 predictions, not 288; each rock's single p is scored against its 96 labels. x = count-weighted mean p (0.740), y = pooled fraction of pairs with cpx present (205/288 = 0.712). ECE on the real panels is the count-weighted |x - y| over 10 such bins. The gray ghost dot shows the overconfident failure mode. Real population: val split of the provisional bulk-level hash split (~20% of 4,670 corpus rocks at 47/100 chunks); the '~930 rocks / 86,617 rows' line is a current snapshot and grows with the corpus -- update it on regen. Pair with figure 2 (p vs within-bulk frequency): reliability is aggregate honesty, the scatter is per-rock sharpness; a base-rate predictor passes the first and fails the second.</a:t>
+              <a:t>Worked example for the reliability diagram in results/mode_head/&lt;tag&gt;/reliability.png. Numbers illustrative but to scale: three rocks predicted in [0.70, 0.80) -- a real bin edge of the 10 equal-width bins the code uses -- contribute 3 predictions x 256 labels = 768 (p, truth) pairs -- 3 predictions, not 768; each rock's single p is scored against its 256 labels. x = count-weighted mean p (0.740), y = pooled fraction of pairs with cpx present (547/768 = 0.712). ECE on the real panels is the count-weighted |x - y| over 10 such bins. The gray ghost dot shows the overconfident failure mode. Real population: the sealed valtest tier's val roster (221 assigned rocks, 218 contributing 55,576 rows at 128 draws x rungs 50/30, minus attrition). Fixed roster: panel numbers move only when the head retrains. Pair with figure 2 (p vs within-bulk frequency): reliability is aggregate honesty, the scatter is per-rock sharpness; a base-rate predictor passes the first and fails the second.</a:t>
             </a:r>
           </a:p>
         </p:txBody>
@@ -1358,7 +1358,7 @@
           <a:lstStyle/>
           <a:p>
             <a:r>
-              <a:t>Status strip for the corpus regen. Stages 1-2 are code, landed and tested. Stage 3-5 are runs the owner executes in his own terminal; each has a decision gate before the next. Update this slide as stages complete.</a:t>
+              <a:t>Status strip for the corpus regen, now fully landed -- the slide is a record, not a plan. Candidate to retire or fold into the corpora slide at the next deck pass (owner call).</a:t>
             </a:r>
           </a:p>
         </p:txBody>
@@ -9290,7 +9290,7 @@
                   <a:srgbClr val="1A2238"/>
                 </a:solidFill>
               </a:rPr>
-              <a:t>96 rows: cpx in 70</a:t>
+              <a:t>256 rows: cpx in 187</a:t>
             </a:r>
           </a:p>
         </p:txBody>
@@ -9489,7 +9489,7 @@
                   <a:srgbClr val="1A2238"/>
                 </a:solidFill>
               </a:rPr>
-              <a:t>96 rows: cpx in 61</a:t>
+              <a:t>256 rows: cpx in 163</a:t>
             </a:r>
           </a:p>
         </p:txBody>
@@ -9688,7 +9688,7 @@
                   <a:srgbClr val="1A2238"/>
                 </a:solidFill>
               </a:rPr>
-              <a:t>96 rows: cpx in 74</a:t>
+              <a:t>256 rows: cpx in 197</a:t>
             </a:r>
           </a:p>
         </p:txBody>
@@ -9800,7 +9800,7 @@
                   <a:srgbClr val="8A93A3"/>
                 </a:solidFill>
               </a:rPr>
-              <a:t>x 96 labels each = 288 pairs</a:t>
+              <a:t>x 256 labels each = 768 pairs</a:t>
             </a:r>
           </a:p>
           <a:p>
@@ -9822,7 +9822,7 @@
                   <a:srgbClr val="8A93A3"/>
                 </a:solidFill>
               </a:rPr>
-              <a:t>present: 205 / 288 = 0.712</a:t>
+              <a:t>present: 547 / 768 = 0.712</a:t>
             </a:r>
           </a:p>
         </p:txBody>
@@ -10128,7 +10128,7 @@
                   <a:srgbClr val="8A93A3"/>
                 </a:solidFill>
               </a:rPr>
-              <a:t>gray dot: overconfident (if truth were 135/288)</a:t>
+              <a:t>gray dot: overconfident (if truth were 360/768)</a:t>
             </a:r>
           </a:p>
         </p:txBody>
@@ -10196,7 +10196,7 @@
                   <a:srgbClr val="1A2238"/>
                 </a:solidFill>
               </a:rPr>
-              <a:t>3 rocks shown; the real figure pools the validation rocks only -- currently ~930 rocks x 96 rows = 86,617 (p, truth) pairs per mineral panel, partitioned across the 10 bins (the gray bars). Training rocks are excluded because a head that memorized them would grade itself calibrated. And since all 96 rows of a rock share one prediction, a panel holds only ~930 distinct p values, each stamped 96x -- the effective sample size is rocks, not rows, which is why every number stays provisional until the valtest tier (500 rocks x 128 draws) lands.</a:t>
+              <a:t>3 rocks shown; the real figure pools the val-roster rocks only -- 218 rocks x ~255 rows = 55,576 (p, truth) pairs per mineral panel, partitioned across the 10 bins (the gray bars). Training rocks are excluded because a head that memorized them would grade itself calibrated. And since all ~255 rows of a rock share one prediction, a panel holds only 218 distinct p values, each stamped ~255x -- the effective sample size is rocks, not rows. The population is the fixed val roster of the sealed valtest tier (128 draws/rock at rungs 50+30), so panels are comparable across retrains.</a:t>
             </a:r>
           </a:p>
         </p:txBody>
@@ -10230,7 +10230,7 @@
                   <a:srgbClr val="8A93A3"/>
                 </a:solidFill>
               </a:rPr>
-              <a:t>BCE's per-rock minimum is the true fraction, so an honest head lands on the diagonal by construction. current limits (provisional): garnet presence under-predicted even at f &gt; 0.9; amphibole magnitude spread too narrow. full report: results/mode_head/&lt;tag&gt;/</a:t>
+              <a:t>BCE's per-rock minimum is the true fraction, so an honest head lands on the diagonal by construction. current limits: intermediate-frequency presence is the miss mode (garnet recall 1.0 at f &gt; 0.9 but 0.0 below f = 0.5; opx 0.23 / ru 0.13 / ol 0.04 overall); spinel is the worst-calibrated panel (ECE 0.043); amphibole magnitude spread stays too narrow (next slide). full report: results/mode_head/&lt;tag&gt;/</a:t>
             </a:r>
           </a:p>
         </p:txBody>
@@ -11582,7 +11582,7 @@
                   <a:srgbClr val="8A93A3"/>
                 </a:solidFill>
               </a:rPr>
-              <a:t>population: only truly-present (row, phase) pairs are scored -- ~68k pairs for plag down to ~200 for corundum; single-phase rows are excluded (nothing to size). current limits (provisional): amphibole U-shaped PIT (spread too narrow; truth plausibly bimodal across paths), oxide accessories humped (too wide), plag under-sized. full report: results/mode_head/&lt;tag&gt;/ (magnitude_parity, magnitude_pit).</a:t>
+              <a:t>population: only truly-present (row, phase) pairs are scored -- ~41k pairs for plag down to ~240 for andalusite; single-phase rows are excluded (nothing to size). current limits: amphibole PIT U-shaped with a high-side tilt (tails 0.27 vs 0.10 expected: spread too narrow and conditionally under-sized; corpus bimodality measured), oxide accessories humped (spl/ilm/ru tails ~0.01: too wide); plag's earlier under-sizing flattened with the full-tier retrain (tails 0.12). full report: results/mode_head/&lt;tag&gt;/ (magnitude_parity, magnitude_pit).</a:t>
             </a:r>
           </a:p>
         </p:txBody>
@@ -18574,11 +18574,11 @@
             <a:avLst/>
           </a:prstGeom>
           <a:solidFill>
-            <a:srgbClr val="FBEEE3"/>
+            <a:srgbClr val="E1F1EF"/>
           </a:solidFill>
           <a:ln w="25400">
             <a:solidFill>
-              <a:srgbClr val="E8883A"/>
+              <a:srgbClr val="2A9D8F"/>
             </a:solidFill>
           </a:ln>
           <a:effectLst/>
@@ -18630,7 +18630,7 @@
                   <a:srgbClr val="1A2238"/>
                 </a:solidFill>
               </a:rPr>
-              <a:t>first 5 train chunks</a:t>
+              <a:t>passed; rungs locked</a:t>
             </a:r>
           </a:p>
           <a:p>
@@ -18641,7 +18641,7 @@
                   <a:srgbClr val="8A93A3"/>
                 </a:solidFill>
               </a:rPr>
-              <a:t>health report +</a:t>
+              <a:t>50 + 30 (owner,</a:t>
             </a:r>
           </a:p>
           <a:p>
@@ -18652,7 +18652,7 @@
                   <a:srgbClr val="8A93A3"/>
                 </a:solidFill>
               </a:rPr>
-              <a:t>rung_prescreen.py -&gt; owner</a:t>
+              <a:t>rung_prescreen.py)</a:t>
             </a:r>
           </a:p>
         </p:txBody>
@@ -18683,10 +18683,10 @@
             <a:r>
               <a:rPr sz="1100" b="0">
                 <a:solidFill>
-                  <a:srgbClr val="E8883A"/>
-                </a:solidFill>
-              </a:rPr>
-              <a:t>NEXT</a:t>
+                  <a:srgbClr val="2A9D8F"/>
+                </a:solidFill>
+              </a:rPr>
+              <a:t>LANDED</a:t>
             </a:r>
           </a:p>
         </p:txBody>
@@ -18750,11 +18750,11 @@
             <a:avLst/>
           </a:prstGeom>
           <a:solidFill>
-            <a:srgbClr val="FFFFFF"/>
+            <a:srgbClr val="E1F1EF"/>
           </a:solidFill>
-          <a:ln w="12700">
+          <a:ln w="25400">
             <a:solidFill>
-              <a:srgbClr val="C8CDD6"/>
+              <a:srgbClr val="2A9D8F"/>
             </a:solidFill>
           </a:ln>
           <a:effectLst/>
@@ -18781,54 +18781,65 @@
             <a:r>
               <a:rPr sz="1200" b="1">
                 <a:solidFill>
+                  <a:srgbClr val="1A2238"/>
+                </a:solidFill>
+              </a:rPr>
+              <a:t>5. production</a:t>
+            </a:r>
+          </a:p>
+          <a:p>
+            <a:pPr algn="ctr"/>
+            <a:r>
+              <a:rPr sz="1200" b="1">
+                <a:solidFill>
+                  <a:srgbClr val="1A2238"/>
+                </a:solidFill>
+              </a:rPr>
+              <a:t/>
+            </a:r>
+          </a:p>
+          <a:p>
+            <a:pPr algn="ctr"/>
+            <a:r>
+              <a:rPr sz="1200" b="1">
+                <a:solidFill>
+                  <a:srgbClr val="1A2238"/>
+                </a:solidFill>
+              </a:rPr>
+              <a:t>both tiers complete</a:t>
+            </a:r>
+          </a:p>
+          <a:p>
+            <a:pPr algn="ctr"/>
+            <a:r>
+              <a:rPr sz="900" b="0">
+                <a:solidFill>
                   <a:srgbClr val="8A93A3"/>
                 </a:solidFill>
               </a:rPr>
-              <a:t>5. production</a:t>
-            </a:r>
-          </a:p>
-          <a:p>
-            <a:pPr algn="ctr"/>
-            <a:r>
-              <a:rPr sz="1200" b="1">
+              <a:t>948k train rows;</a:t>
+            </a:r>
+          </a:p>
+          <a:p>
+            <a:pPr algn="ctr"/>
+            <a:r>
+              <a:rPr sz="900" b="0">
                 <a:solidFill>
                   <a:srgbClr val="8A93A3"/>
                 </a:solidFill>
               </a:rPr>
-              <a:t/>
-            </a:r>
-          </a:p>
-          <a:p>
-            <a:pPr algn="ctr"/>
-            <a:r>
-              <a:rPr sz="1200" b="1">
+              <a:t>valtest 125k, sealed</a:t>
+            </a:r>
+          </a:p>
+          <a:p>
+            <a:pPr algn="ctr"/>
+            <a:r>
+              <a:rPr sz="900" b="0">
                 <a:solidFill>
                   <a:srgbClr val="8A93A3"/>
                 </a:solidFill>
               </a:rPr>
-              <a:t>10k x 48 + 500 x 128</a:t>
-            </a:r>
-          </a:p>
-          <a:p>
-            <a:pPr algn="ctr"/>
-            <a:r>
-              <a:rPr sz="900" b="0">
-                <a:solidFill>
-                  <a:srgbClr val="8A93A3"/>
-                </a:solidFill>
-              </a:rPr>
-              <a:t>~2 days, pausable</a:t>
-            </a:r>
-          </a:p>
-          <a:p>
-            <a:pPr algn="ctr"/>
-            <a:r>
-              <a:rPr sz="900" b="0">
-                <a:solidFill>
-                  <a:srgbClr val="8A93A3"/>
-                </a:solidFill>
-              </a:rPr>
-              <a:t>rerun command = resume</a:t>
+              <a:t>221/278 val/test roster</a:t>
             </a:r>
           </a:p>
         </p:txBody>
@@ -18859,10 +18870,10 @@
             <a:r>
               <a:rPr sz="1100" b="0">
                 <a:solidFill>
-                  <a:srgbClr val="8A93A3"/>
-                </a:solidFill>
-              </a:rPr>
-              <a:t>queued</a:t>
+                  <a:srgbClr val="2A9D8F"/>
+                </a:solidFill>
+              </a:rPr>
+              <a:t>LANDED</a:t>
             </a:r>
           </a:p>
         </p:txBody>
@@ -18882,7 +18893,7 @@
             <a:avLst/>
           </a:prstGeom>
           <a:solidFill>
-            <a:srgbClr val="C8CDD6"/>
+            <a:srgbClr val="1A2238"/>
           </a:solidFill>
           <a:ln>
             <a:noFill/>
@@ -18940,7 +18951,7 @@
                   <a:srgbClr val="1A2238"/>
                 </a:solidFill>
               </a:rPr>
-              <a:t>gates between stages: the A/B re-checks the amp/opx multimodality magnitude and the biotite presence gap under bounded water; the pilot pre-screen scores each rung against the real benchmark (presence per SiO2 band, then rank of proportions) and the owner picks the training rung before production launches.</a:t>
+              <a:t>all gates passed: the water A/B held under bounded sampling; the pilot pre-screen locked rungs 50 + 30; production completed 2026-07-17 (train 99.2% point convergence, valtest 97.7% usable rows after dropping one solver-poisoned bulk). The 499 valtest bulks divide 16:20 into a committed val/test roster (valtest_split.csv); test stays sealed.</a:t>
             </a:r>
           </a:p>
         </p:txBody>
@@ -18974,7 +18985,7 @@
                   <a:srgbClr val="8A93A3"/>
                 </a:solidFill>
               </a:rPr>
-              <a:t>spec: docs/corpus_regen_spec.md (all design decisions locked 2026-07-14; what remains is measurement and generation).</a:t>
+              <a:t>spec: docs/corpus_regen_spec.md (all design decisions locked 2026-07-14; generation complete 2026-07-17).</a:t>
             </a:r>
           </a:p>
         </p:txBody>

</xml_diff>

<commit_message>
docs: seal the main sweep in journal + roadmap; fix rotted HPO cross-references; deck dials to adopted values
  journal: 42-trial seal, trial-21 tiebreak adoption, layers-extension
  rejection, fANOVA/scatter reads, epochs 60 -> 120, mini-sweep design +
  sequential-run rationale. roadmap status advanced (#35 done, #36 running).
  hpo config comments repointed (baseline = pre-sweep values; mini-sweep
  configs now exist). comp/cond anatomy dials updated to adopted
  dropout/lambda_balance; dropped the stale n_components-sweep claim.
  technique index regenerated, zero hits: none
</commit_message>
<xml_diff>
--- a/slides/overview.pptx
+++ b/slides/overview.pptx
@@ -12628,7 +12628,7 @@
                   <a:srgbClr val="8A93A3"/>
                 </a:solidFill>
               </a:rPr>
-              <a:t>dials (configs/heads/joint_heads.yaml): comp_hidden 128 . comp_layers 1 . dropout 0.0 . alpha_eps 1e-6 . comp_eps 1e-4 (hard-zero clip on targets) . lambda_comp 1.0 . lambda_balance 1.0 -- fixed in code: GELU, AdamW, per-head grad-clip 1.0</a:t>
+              <a:t>dials (configs/heads/joint_heads.yaml): comp_hidden 128 . comp_layers 1 . dropout 0.35 . alpha_eps 1e-6 . comp_eps 1e-4 (hard-zero clip on targets) . lambda_comp 1.0 . lambda_balance 54.5 -- fixed in code: GELU, AdamW, per-head grad-clip 1.0</a:t>
             </a:r>
           </a:p>
         </p:txBody>
@@ -14005,7 +14005,7 @@
                   <a:srgbClr val="8A93A3"/>
                 </a:solidFill>
               </a:rPr>
-              <a:t>dials (configs/heads/joint_heads.yaml): cond_n_components 3 (HPO sweeps {2,3,4}) . cond_sigma_eps 1e-3 . cond_hidden 128 . cond_layers 1 . dropout 0.0 . lambda_cond 0.01 -- fixed in code: GELU, AdamW, per-head grad-clip 1.0, linear units (no log transform of T/P/H2O)</a:t>
+              <a:t>dials (configs/heads/joint_heads.yaml): cond_n_components 3 . cond_sigma_eps 1e-3 . cond_hidden 128 . cond_layers 1 (architecture mini-sweep pending) . dropout 0.35 . lambda_cond 0.01 -- fixed in code: GELU, AdamW, per-head grad-clip 1.0, linear units (no log transform of T/P/H2O)</a:t>
             </a:r>
           </a:p>
         </p:txBody>

</xml_diff>

<commit_message>
rename untracked results/ to runs/; RESULTS_ROOT becomes RUNS_ROOT
</commit_message>
<xml_diff>
--- a/slides/overview.pptx
+++ b/slides/overview.pptx
@@ -872,7 +872,7 @@
           <a:lstStyle/>
           <a:p>
             <a:r>
-              <a:t>Worked example for the reliability diagram in results/mode_head/&lt;tag&gt;/reliability.png. Numbers illustrative but to scale: three rocks predicted in [0.70, 0.80) -- a real bin edge of the 10 equal-width bins the code uses -- contribute 3 predictions x 256 labels = 768 (p, truth) pairs -- 3 predictions, not 768; each rock's single p is scored against its 256 labels. x = count-weighted mean p (0.740), y = pooled fraction of pairs with cpx present (547/768 = 0.712). ECE on the real panels is the count-weighted |x - y| over 10 such bins. The gray ghost dot shows the overconfident failure mode. Real population: the sealed valtest tier's val roster (221 assigned rocks, 218 contributing 55,576 rows at 128 draws x rungs 50/30, minus attrition). Fixed roster: panel numbers move only when the head retrains. Pair with figure 2 (p vs within-bulk frequency): reliability is aggregate honesty, the scatter is per-rock sharpness; a base-rate predictor passes the first and fails the second.</a:t>
+              <a:t>Worked example for the reliability diagram in runs/mode_head/&lt;tag&gt;/reliability.png. Numbers illustrative but to scale: three rocks predicted in [0.70, 0.80) -- a real bin edge of the 10 equal-width bins the code uses -- contribute 3 predictions x 256 labels = 768 (p, truth) pairs -- 3 predictions, not 768; each rock's single p is scored against its 256 labels. x = count-weighted mean p (0.740), y = pooled fraction of pairs with cpx present (547/768 = 0.712). ECE on the real panels is the count-weighted |x - y| over 10 such bins. The gray ghost dot shows the overconfident failure mode. Real population: the sealed valtest tier's val roster (221 assigned rocks, 218 contributing 55,576 rows at 128 draws x rungs 50/30, minus attrition). Fixed roster: panel numbers move only when the head retrains. Pair with figure 2 (p vs within-bulk frequency): reliability is aggregate honesty, the scatter is per-rock sharpness; a base-rate predictor passes the first and fails the second.</a:t>
             </a:r>
           </a:p>
         </p:txBody>
@@ -1082,7 +1082,7 @@
           <a:lstStyle/>
           <a:p>
             <a:r>
-              <a:t>Eval-semantics slide for CompHead, mirroring the ModeHead magnitude worked example: two tracks converge at a scoring node; the truth contributes its support to the slice and meets the prediction only at scoring. Box numbers illustrative but to scale (a plag Dirichlet with alpha0 ~780 has SiO2 sd ~0.018); headline numbers are real, from results/comp_head/joint_heads_seed0/metrics.json vs the preserved joint_heads_seed0_baseline run: NLL -50.25 -&gt; -53.85, closure L2 mean 0.0181 -&gt; 0.0134 with the stable +SiO2/-Al2O3 signed bias collapsed to zero-centered residuals (the closure-penalty-form question, #38, closed on this evidence), An# parity mae 0.064 -&gt; 0.060 / r 0.920 -&gt; 0.927. The alpha0-span story is the headline fix: comp_concentration.png baseline vs tuned shows the 100-650 compression opening to 25-32,000, ordered by how constrained each mineral's chemistry really is. PIT here is per-oxide Beta marginals of the 11-simplex Dirichlet (same sub-composition property as the mode slice).</a:t>
+              <a:t>Eval-semantics slide for CompHead, mirroring the ModeHead magnitude worked example: two tracks converge at a scoring node; the truth contributes its support to the slice and meets the prediction only at scoring. Box numbers illustrative but to scale (a plag Dirichlet with alpha0 ~780 has SiO2 sd ~0.018); headline numbers are real, from runs/comp_head/joint_heads_seed0/metrics.json vs the preserved joint_heads_seed0_baseline run: NLL -50.25 -&gt; -53.85, closure L2 mean 0.0181 -&gt; 0.0134 with the stable +SiO2/-Al2O3 signed bias collapsed to zero-centered residuals (the closure-penalty-form question, #38, closed on this evidence), An# parity mae 0.064 -&gt; 0.060 / r 0.920 -&gt; 0.927. The alpha0-span story is the headline fix: comp_concentration.png baseline vs tuned shows the 100-650 compression opening to 25-32,000, ordered by how constrained each mineral's chemistry really is. PIT here is per-oxide Beta marginals of the 11-simplex Dirichlet (same sub-composition property as the mode slice).</a:t>
             </a:r>
           </a:p>
         </p:txBody>
@@ -1222,7 +1222,7 @@
           <a:lstStyle/>
           <a:p>
             <a:r>
-              <a:t>Eval-semantics slide for CondHead. The two-pass protocol is the point: teacher-forced scoring isolates the head's conditional skill p(T,P,H2O | h, true support); sampled-support scoring measures the deployed chain with ModeHead's Bernoulli draws standing in for the truth (exposure_seed pins reproducibility). Mixture drawing illustrative but to scale for a bimodal amp/opx bulk (deep-wet vs shallow-dry is the flagship condition multimodality). Real numbers from results/cond_head/joint_heads_seed0/metrics.json vs the preserved baseline: teacher-forced NLL 8.60 -&gt; 8.32 and coverage_68 0.65-0.69 -&gt; 0.67-0.72 (tuning + the 512x2 trunk), while the exposure delta WIDENED (T 2.91 -&gt; 3.94, H2O 1.53 -&gt; 2.40, P finite -&gt; inf on some rows) -- the sharper head is more wrong under mismatched supports. Coverage is central-interval mass via the mixture CDF (PIT), same construction as the mode/comp calibration reads.</a:t>
+              <a:t>Eval-semantics slide for CondHead. The two-pass protocol is the point: teacher-forced scoring isolates the head's conditional skill p(T,P,H2O | h, true support); sampled-support scoring measures the deployed chain with ModeHead's Bernoulli draws standing in for the truth (exposure_seed pins reproducibility). Mixture drawing illustrative but to scale for a bimodal amp/opx bulk (deep-wet vs shallow-dry is the flagship condition multimodality). Real numbers from runs/cond_head/joint_heads_seed0/metrics.json vs the preserved baseline: teacher-forced NLL 8.60 -&gt; 8.32 and coverage_68 0.65-0.69 -&gt; 0.67-0.72 (tuning + the 512x2 trunk), while the exposure delta WIDENED (T 2.91 -&gt; 3.94, H2O 1.53 -&gt; 2.40, P finite -&gt; inf on some rows) -- the sharper head is more wrong under mismatched supports. Coverage is central-interval mass via the mixture CDF (PIT), same construction as the mode/comp calibration reads.</a:t>
             </a:r>
           </a:p>
         </p:txBody>
@@ -10514,7 +10514,7 @@
                   <a:srgbClr val="8A93A3"/>
                 </a:solidFill>
               </a:rPr>
-              <a:t>BCE's per-rock minimum is the true fraction, so an honest head lands on the diagonal by construction. current limits (tuned model): intermediate-frequency presence is the miss mode (garnet recall 0.58 in f = [0.5, 0.9) and 0.0 elsewhere; opx 0.25 / ru 0.08 / ol 0.08 overall); spinel is the worst-calibrated panel (ECE 0.037); amphibole magnitude spread stays too narrow (next slide). full report: results/mode_head/&lt;tag&gt;/</a:t>
+              <a:t>BCE's per-rock minimum is the true fraction, so an honest head lands on the diagonal by construction. current limits (tuned model): intermediate-frequency presence is the miss mode (garnet recall 0.58 in f = [0.5, 0.9) and 0.0 elsewhere; opx 0.25 / ru 0.08 / ol 0.08 overall); spinel is the worst-calibrated panel (ECE 0.037); amphibole magnitude spread stays too narrow (next slide). full report: runs/mode_head/&lt;tag&gt;/</a:t>
             </a:r>
           </a:p>
         </p:txBody>
@@ -11866,7 +11866,7 @@
                   <a:srgbClr val="8A93A3"/>
                 </a:solidFill>
               </a:rPr>
-              <a:t>population: only truly-present (row, phase) pairs are scored -- ~41k pairs for plag down to ~240 for andalusite; single-phase rows are excluded (nothing to size). current limits (tuned model): amphibole stays the flagship miss -- 65% of its (rock, support) PIT groups are mean-shifted (within-bulk bimodality collapses to the mean; mixture fix staged, #25) and tuning did not move its magnitude error; plag/afs/q are majority-shifted too (the support-conditioning signal, heads.md). full report: results/mode_head/&lt;tag&gt;/ (magnitude_parity, magnitude_pit).</a:t>
+              <a:t>population: only truly-present (row, phase) pairs are scored -- ~41k pairs for plag down to ~240 for andalusite; single-phase rows are excluded (nothing to size). current limits (tuned model): amphibole stays the flagship miss -- 65% of its (rock, support) PIT groups are mean-shifted (within-bulk bimodality collapses to the mean; mixture fix staged, #25) and tuning did not move its magnitude error; plag/afs/q are majority-shifted too (the support-conditioning signal, heads.md). full report: runs/mode_head/&lt;tag&gt;/ (magnitude_parity, magnitude_pit).</a:t>
             </a:r>
           </a:p>
         </p:txBody>
@@ -14126,7 +14126,7 @@
                   <a:srgbClr val="8A93A3"/>
                 </a:solidFill>
               </a:rPr>
-              <a:t>current limits: hard-zero oxides ride the eps floor (a quartz row is 'SiO2 + 10 floors'); ilmenite FeO/TiO2 stays the accuracy outlier; ~0.3% of corpus rows cannot self-close and set an unattainable closure floor there. full report: results/comp_head/&lt;tag&gt;/</a:t>
+              <a:t>current limits: hard-zero oxides ride the eps floor (a quartz row is 'SiO2 + 10 floors'); ilmenite FeO/TiO2 stays the accuracy outlier; ~0.3% of corpus rows cannot self-close and set an unattainable closure floor there. full report: runs/comp_head/&lt;tag&gt;/</a:t>
             </a:r>
           </a:p>
         </p:txBody>
@@ -16519,7 +16519,7 @@
                   <a:srgbClr val="8A93A3"/>
                 </a:solidFill>
               </a:rPr>
-              <a:t>current limits: axes are independent mixtures (no (T, P) correlation, deferred per ADR 006); T is a derived cooling endpoint, not a sampled axis; sampled-support P rows can blow up numerically (the inf rows are #31's starting point). full report: results/cond_head/&lt;tag&gt;/</a:t>
+              <a:t>current limits: axes are independent mixtures (no (T, P) correlation, deferred per ADR 006); T is a derived cooling endpoint, not a sampled axis; sampled-support P rows can blow up numerically (the inf rows are #31's starting point). full report: runs/cond_head/&lt;tag&gt;/</a:t>
             </a:r>
           </a:p>
         </p:txBody>

</xml_diff>

<commit_message>
ModeHead magnitude branch conditioned on the assemblage support (#25)
</commit_message>
<xml_diff>
--- a/slides/overview.pptx
+++ b/slides/overview.pptx
@@ -802,7 +802,7 @@
           <a:lstStyle/>
           <a:p>
             <a:r>
-              <a:t>Anatomy of the trained ModeHead (checkpoints/joint_heads_seed0): shared trunk 3 stacked Linear(-&gt;256)+GELU+dropout blocks, then two parallel linear branches -- presence logits (sigmoid -&gt; per-phase Bernoulli, BCE) and concentrations (softplus + eps -&gt; conditional Dirichlet, masked NLL on the true support). Param counts are pulled from the checkpoint (mode_hidden 256, mode_layers 3, the joint-HPO winner; fANOVA put architecture near zero, the gain came with the tuned environment). Loss boxes mirror the SSL slide: BCE is a proper scoring rule (per-rock minimum = within-bulk presence frequency, which is why intermediate p is signal); the Dirichlet NLL is masked to the label's present set (sub-composition property keeps it a proper density); λ_mag is the loss-weighting coefficient (config key magnitude_weight, 0.25 tuned) -- λ chosen over w to avoid clashing with layer weights and to match the λ_balance / λ_comp family. 'Trained jointly' is literal chain-rule math: L is one scalar, so one backward pass and one AdamW step update all params at once. Each branch's weights appear in only its own term (the other term's gradient is exactly zero there); the trunk appears in both, so its gradient is the sum -- λ_mag is the exchange rate between the two error signals shaping the shared features. NOT alternating epochs, NOT separate optimizers, NOT staged pretraining of one branch. The hurdle split exists because one full-simplex Dirichlet cannot be simultaneously confident about absences and honest about present-phase spread (shared concentration). CompHead/CondHead follow the same small-MLP-emitting-distribution-parameters pattern; their two-slide reports follow ModeHead's.</a:t>
+              <a:t>Anatomy of the trained ModeHead (checkpoints/joint_heads_supportmag_seed0): two parallel trunks of 3 stacked Linear(-&gt;256)+GELU+dropout blocks. The presence trunk reads h alone (it predicts the support, so it must not see it) -&gt; logits (sigmoid -&gt; per-phase Bernoulli, BCE). The magnitude trunk reads h concatenated with the 21-dim support vector -&gt; concentrations (softplus + eps -&gt; conditional Dirichlet, masked NLL on the same support) -- the chain rule CondHead already uses: teacher-forced true mask at train, sampled from the presence Bernoullis at inference. Support-conditioning (adopted 2026-07-22, #25) exists because the conditional truth is bimodal by support for path-sensitive phases (deep-wet-much-amp vs shallow-dry-little); a support-blind Dirichlet could only average the humps -- amp magnitude parity r went 0.715 -&gt; 0.876. Param counts are pulled from the checkpoint (mode_hidden 256, mode_layers 3 per trunk, the joint-HPO winner kept for isolation). Loss boxes mirror the SSL slide: BCE is a proper scoring rule (per-rock minimum = within-bulk presence frequency, which is why intermediate p is signal); the Dirichlet NLL is masked to the label's present set (sub-composition property keeps it a proper density); λ_mag is the loss-weighting coefficient (config key magnitude_weight, 0.25 tuned) -- λ chosen over w to avoid clashing with layer weights and to match the λ_balance / λ_comp family. 'Trained jointly' is one scalar L, one backward pass, one AdamW step; with the trunks split, the two ModeHead terms touch disjoint params -- λ_mag no longer arbitrates a shared trunk; its remaining role is balancing the Dirichlet term against the mass-balance closure (which also reads the magnitude alphas), with a second-order coupling via the per-head gradient clip pooling both trunks' norms. NOT alternating epochs, NOT separate optimizers, NOT staged pretraining of one branch. The hurdle split exists because one full-simplex Dirichlet cannot be simultaneously confident about absences and honest about present-phase spread (shared concentration). CompHead/CondHead follow the same small-MLP-emitting-distribution-parameters pattern; their two-slide reports follow ModeHead's.</a:t>
             </a:r>
           </a:p>
         </p:txBody>
@@ -942,7 +942,7 @@
           <a:lstStyle/>
           <a:p>
             <a:r>
-              <a:t>Eval-semantics slide for the magnitude branch, mirroring the presence branch's reliability worked example. Laid out as two tracks converging at a scoring node: the prediction track never sees the truth's modes; the truth contributes only its support to the slice (teacher-forced) and meets the prediction at scoring. Numbers illustrative but to scale: alpha sliced to the true 4-phase support gives Dirichlet means alpha_i/alpha0 and Beta marginals Beta(alpha_i, alpha0 - alpha_i); plag Beta(12,13) has mean 0.48, sd ~0.10, and truth 0.44 lands at CDF 0.34. alpha0 is the single shared confidence knob per row -- the reason per-phase spreads can't be tuned independently (see alpha_concentration.png). PIT histograms are the magnitude analog of reliability diagrams; parity plots are the point-estimate view. Scored by masked Dirichlet NLL (anatomy slide's L_magnitude). Worked numbers for the expansion box: this row scores -4.34 nats (normalizer -28.37 + shape +24.03); scaling alpha x4 improves to -5.26 when truth is near the peak but explodes to +17.9 when truth swaps to the other hump (plag/amp values exchanged) -- the mechanism that pins amphibole's alpha0 low and its mean in the middle.</a:t>
+              <a:t>Eval-semantics slide for the magnitude branch, mirroring the presence branch's reliability worked example. Laid out as two tracks converging at a scoring node: the prediction track never sees the truth's modes; the truth contributes its support twice (conditioning input to the magnitude trunk + the score's slice, both teacher-forced) and its modes meet the prediction only at scoring. Numbers illustrative but to scale: alpha sliced to the true 4-phase support gives Dirichlet means alpha_i/alpha0 and Beta marginals Beta(alpha_i, alpha0 - alpha_i); plag Beta(12,13) has mean 0.48, sd ~0.10, and truth 0.44 lands at CDF 0.34. alpha0 is the single shared confidence knob per row -- the reason per-phase spreads can't be tuned independently (see alpha_concentration.png). PIT histograms are the magnitude analog of reliability diagrams; parity plots are the point-estimate view. Scored by masked Dirichlet NLL (anatomy slide's L_magnitude). Worked numbers for the expansion box: this row scores -4.34 nats (normalizer -28.37 + shape +24.03); scaling alpha x4 improves to -5.26 when truth is near the peak but explodes to +17.9 when truth swaps to the other hump (plag/amp values exchanged) -- the mechanism that pinned the support-blind head's amphibole alpha0 low and its mean in the middle. Support-conditioning resolves the between-support humps; the within-support ones still punish confidence the same way (the mixture candidate's target).</a:t>
             </a:r>
           </a:p>
         </p:txBody>
@@ -1432,7 +1432,7 @@
           <a:lstStyle/>
           <a:p>
             <a:r>
-              <a:t>View 2 from heads.md, modernized to the locked corpus design: crystals-renormalized (no residual-melt row -- melt-fraction head dropped), composition shared across scenarios (CompHead reads h only), no inference-time mass-balance checkmark (closure is teacher-forced at training; the inference residual as OOD signal is an open rethink). Marginal view = projection of these scenarios; scenarios are the primary object. Open mechanism detail for #10/#13: coupling conditions to assemblage in a sampled scenario requires joint sampling across heads. Numbers illustrative.</a:t>
+              <a:t>View 2 from heads.md, modernized to the locked corpus design: crystals-renormalized (no residual-melt row -- melt-fraction head dropped), composition shared across scenarios (CompHead reads h only), no inference-time mass-balance checkmark (closure is teacher-forced at training; the inference residual as OOD signal is an open rethink). Marginal view = projection of these scenarios; scenarios are the primary object. The joint-sampling mechanism exists (two-step ancestral sampling: presence Bernoullis -&gt; support, then the support-conditioned magnitude Dirichlet and CondHead both condition on it -- scripts/view/scenario_view.py); per-scenario mode shares and conditions are genuinely re-predicted per support. Numbers illustrative.</a:t>
             </a:r>
           </a:p>
         </p:txBody>
@@ -8175,7 +8175,7 @@
                   <a:srgbClr val="1A2238"/>
                 </a:solidFill>
               </a:rPr>
-              <a:t>Inside ModeHead: a small MLP on the frozen h</a:t>
+              <a:t>Inside ModeHead: two small MLPs on the frozen h</a:t>
             </a:r>
           </a:p>
         </p:txBody>
@@ -8209,7 +8209,7 @@
                   <a:srgbClr val="8A93A3"/>
                 </a:solidFill>
               </a:rPr>
-              <a:t>ModeHead, the first head trained end-to-end -- two clean factors of the hurdle likelihood P(modal) = P(present) x P(modal | present)</a:t>
+              <a:t>ModeHead, the first head trained end-to-end -- two clean factors of the hurdle likelihood P(modal) = P(present) x P(modal | present), each with its own trunk: presence reads h alone; magnitude reads h + the mineral set it is sizing</a:t>
             </a:r>
           </a:p>
         </p:txBody>
@@ -8406,7 +8406,7 @@
                   <a:srgbClr val="1A2238"/>
                 </a:solidFill>
               </a:rPr>
-              <a:t>shared trunk</a:t>
+              <a:t>two parallel trunks</a:t>
             </a:r>
           </a:p>
           <a:p>
@@ -8417,7 +8417,7 @@
                   <a:srgbClr val="8A93A3"/>
                 </a:solidFill>
               </a:rPr>
-              <a:t>3 x [Linear -&gt; 256]</a:t>
+              <a:t>presence: 3 x [Linear -&gt; 256] on h</a:t>
             </a:r>
           </a:p>
           <a:p>
@@ -8428,7 +8428,7 @@
                   <a:srgbClr val="8A93A3"/>
                 </a:solidFill>
               </a:rPr>
-              <a:t>GELU + dropout each</a:t>
+              <a:t>magnitude: 3 x [Linear -&gt; 256]</a:t>
             </a:r>
           </a:p>
           <a:p>
@@ -8439,7 +8439,18 @@
                   <a:srgbClr val="8A93A3"/>
                 </a:solidFill>
               </a:rPr>
-              <a:t>197,376 params</a:t>
+              <a:t>on [h, support(21)] -- chain rule</a:t>
+            </a:r>
+          </a:p>
+          <a:p>
+            <a:pPr algn="ctr"/>
+            <a:r>
+              <a:rPr sz="1000" b="0">
+                <a:solidFill>
+                  <a:srgbClr val="8A93A3"/>
+                </a:solidFill>
+              </a:rPr>
+              <a:t>197,376 + 202,752 params</a:t>
             </a:r>
           </a:p>
         </p:txBody>
@@ -8794,7 +8805,7 @@
                   <a:srgbClr val="8A93A3"/>
                 </a:solidFill>
               </a:rPr>
-              <a:t>alpha_i, Dirichlet concentration</a:t>
+              <a:t>alpha_i, support-conditioned</a:t>
             </a:r>
           </a:p>
           <a:p>
@@ -8914,7 +8925,7 @@
                   <a:srgbClr val="8A93A3"/>
                 </a:solidFill>
               </a:rPr>
-              <a:t>how much of each,</a:t>
+              <a:t>how much, GIVEN</a:t>
             </a:r>
           </a:p>
           <a:p>
@@ -8925,7 +8936,7 @@
                   <a:srgbClr val="8A93A3"/>
                 </a:solidFill>
               </a:rPr>
-              <a:t>on the present set (NLL)</a:t>
+              <a:t>this mineral set (NLL)</a:t>
             </a:r>
           </a:p>
         </p:txBody>
@@ -8959,7 +8970,7 @@
                   <a:srgbClr val="1A2238"/>
                 </a:solidFill>
               </a:rPr>
-              <a:t>208,170 trainable params (trunk 197,376 + 2 x 5,397) -- ~6.4% of the frozen encoder; the 256 x 3 trunk is the joint-HPO winner (untuned 128 x 1 gave up 0.105 nats of assemblage NLL).</a:t>
+              <a:t>410,922 trainable params (trunks 197,376 + 202,752, outputs 2 x 5,397) -- ~12.7% of the frozen encoder; 256 x 3 per trunk is the joint-HPO winner, kept unchanged when the support-conditioned trunk was added (isolation, #25).</a:t>
             </a:r>
           </a:p>
         </p:txBody>
@@ -9188,7 +9199,7 @@
                   <a:srgbClr val="8A93A3"/>
                 </a:solidFill>
               </a:rPr>
-              <a:t>trained jointly: one backward pass; each branch gets only its own term's gradient, the shared trunk gets the SUM of both -- ∇L(trunk) = ∇L_pres + λ_mag ∇L_mag</a:t>
+              <a:t>one backward pass; the trunks are param-disjoint, so λ_mag no longer arbitrates a shared trunk -- it balances the Dirichlet term against the mass-balance closure on the magnitude trunk</a:t>
             </a:r>
           </a:p>
         </p:txBody>
@@ -10699,7 +10710,7 @@
                   <a:srgbClr val="8A93A3"/>
                 </a:solidFill>
               </a:rPr>
-              <a:t>alpha for all 21 phases,</a:t>
+              <a:t>alpha for all 21 phases, from</a:t>
             </a:r>
           </a:p>
           <a:p>
@@ -10710,7 +10721,7 @@
                   <a:srgbClr val="8A93A3"/>
                 </a:solidFill>
               </a:rPr>
-              <a:t>computed from the latent --</a:t>
+              <a:t>the latent + the row's support --</a:t>
             </a:r>
           </a:p>
           <a:p>
@@ -10721,7 +10732,7 @@
                   <a:srgbClr val="8A93A3"/>
                 </a:solidFill>
               </a:rPr>
-              <a:t>truth is not an input</a:t>
+              <a:t>the true MODES are not an input</a:t>
             </a:r>
           </a:p>
         </p:txBody>
@@ -11832,7 +11843,7 @@
                   <a:srgbClr val="1A2238"/>
                 </a:solidFill>
               </a:rPr>
-              <a:t>the truth plays two roles, never as a model input: its support slices alpha (teacher-forced at train/eval, sampled from the presence branch at inference; a Dirichlet sub-composition is itself a Dirichlet, so the sliced score is a proper density), and its modes appear only at the scoring step.</a:t>
+              <a:t>the truth's modes never enter the model; its support enters twice -- it CONDITIONS alpha (the magnitude trunk reads [h, support]; teacher-forced at train/eval, sampled from the presence branch at inference) and it slices the score to the present set (a Dirichlet sub-composition is itself a Dirichlet, so the sliced score is a proper density).</a:t>
             </a:r>
           </a:p>
         </p:txBody>
@@ -11866,7 +11877,7 @@
                   <a:srgbClr val="8A93A3"/>
                 </a:solidFill>
               </a:rPr>
-              <a:t>population: only truly-present (row, phase) pairs are scored -- ~41k pairs for plag down to ~240 for andalusite; single-phase rows are excluded (nothing to size). current limits (tuned model): amphibole stays the flagship miss -- 65% of its (rock, support) PIT groups are mean-shifted (within-bulk bimodality collapses to the mean; mixture fix staged, #25) and tuning did not move its magnitude error; plag/afs/q are majority-shifted too (the support-conditioning signal, heads.md). full report: runs/mode_head/&lt;tag&gt;/ (magnitude_parity, magnitude_pit).</a:t>
+              <a:t>population: only truly-present (row, phase) pairs are scored -- ~41k pairs for plag down to ~240 for andalusite; single-phase rows are excluded (nothing to size). current limits (support-conditioned model): amp parity r 0.876 (was 0.715 support-blind) and its mean-shifted PIT groups fell 65% -&gt; 41%; the surviving miss is the ~11% of amp groups bimodal WITHIN one support (mixture parameterization is the staged candidate, #25). full report: runs/mode_head/&lt;tag&gt;/ (magnitude_parity, magnitude_pit).</a:t>
             </a:r>
           </a:p>
         </p:txBody>

</xml_diff>

<commit_message>
overview deck corrected to the true production stack: every production claim points at joint_heads_supportmag_seed0 with its own stamped dials, instrument numbers, and param counts; the trial-22 story remains only as the dated, reversed adoption with traced-corpus measurements   attributed to their own instrument
</commit_message>
<xml_diff>
--- a/slides/overview.pptx
+++ b/slides/overview.pptx
@@ -663,7 +663,7 @@
           <a:lstStyle/>
           <a:p>
             <a:r>
-              <a:t>The three-stage training pipeline. Stage 1 is the SSL loop from the prior slide; stage 2 freezes; stage 3 trains the heads on the labeled equilibrium corpus. The production stack is checkpoints/pretrain_v3_logmse_std_seed0 (stage 1-2) + checkpoints/joint_heads_regen_tuned_seed0 (stage 3). Stage 3 is cheap by design -- ~900k head params against a 3.23M frozen encoder -- which is what makes re-supervising the heads against a different label source a retrain rather than a rebuild.</a:t>
+              <a:t>The three-stage training pipeline. Stage 1 is the SSL loop from the prior slide; stage 2 freezes; stage 3 trains the heads on the labeled equilibrium corpus. The production stack is checkpoints/pretrain_v3_logmse_std_seed0 (stage 1-2) + checkpoints/joint_heads_supportmag_seed0 (stage 3, old broad-draw corpus; the traced-corpus retrains were measured and not adopted). Stage 3 is cheap by design -- ~900k head params against a 3.23M frozen encoder -- which is what makes re-supervising the heads against a different label source a retrain rather than a rebuild.</a:t>
             </a:r>
           </a:p>
         </p:txBody>
@@ -803,7 +803,7 @@
           <a:lstStyle/>
           <a:p>
             <a:r>
-              <a:t>Anatomy of the trained ModeHead (checkpoints/joint_heads_regen_tuned_seed0): two parallel trunks of 3 stacked Linear(-&gt;256)+GELU+dropout blocks. The presence trunk reads h alone (it predicts the support, so it must not see it) -&gt; logits (sigmoid -&gt; per-phase Bernoulli, BCE). The magnitude trunk reads h concatenated with the 21-dim support vector -&gt; concentrations (softplus + eps -&gt; conditional Dirichlet, masked NLL on the same support) -- the chain rule CondHead already uses: teacher-forced true mask at train, sampled from the presence Bernoullis at inference. Support-conditioning (adopted 2026-07-22, #25) exists because the conditional truth is bimodal by support for path-sensitive phases (deep-wet-much-amp vs shallow-dry-little); a support-blind Dirichlet could only average the humps -- amp magnitude parity r went 0.715 -&gt; 0.876 when it landed (measured on the since-retired instrument; the current corpus reads 0.886). Param counts are pulled from the checkpoint (mode_hidden 256, mode_layers 3 per trunk, the joint-HPO winner kept through the weights-only retune). Loss boxes mirror the SSL slide: BCE is a proper scoring rule (per-rock minimum = within-bulk presence frequency, which is why intermediate p is signal); the Dirichlet NLL is masked to the label's present set (sub-composition property keeps it a proper density); λ_mag is the loss-weighting coefficient (config key magnitude_weight, 7.76 tuned) -- λ chosen over w to avoid clashing with layer weights and to match the λ_balance / λ_comp family. Note the reduction asymmetry: BCE means over the 21 phases while the Dirichlet NLL sums them, so 7.76 in the config is 163 against a per-phase-summed BCE. 'Trained jointly' is one scalar L, one backward pass, one AdamW step; with the trunks split, the two ModeHead terms touch disjoint params, coupled only second-order through the per-head gradient clip pooling both trunks' norms. NOT alternating epochs, NOT separate optimizers, NOT staged pretraining of one branch. The hurdle split exists because one full-simplex Dirichlet cannot be simultaneously confident about absences and honest about present-phase spread (shared concentration). CompHead/CondHead follow the same small-MLP-emitting-distribution-parameters pattern; their two-slide reports follow ModeHead's.</a:t>
+              <a:t>Anatomy of the trained ModeHead (checkpoints/joint_heads_supportmag_seed0, the production run): two parallel trunks of 3 stacked Linear(-&gt;256)+GELU+dropout blocks. The presence trunk reads h alone (it predicts the support, so it must not see it) -&gt; logits (sigmoid -&gt; per-phase Bernoulli, BCE). The magnitude trunk reads h concatenated with the 21-dim support vector -&gt; concentrations (softplus + eps -&gt; conditional Dirichlet, masked NLL on the same support) -- the chain rule CondHead already uses: teacher-forced true mask at train, sampled from the presence Bernoullis at inference. Support-conditioning (adopted 2026-07-22, #25) exists because the conditional truth is bimodal by support for path-sensitive phases (deep-wet-much-amp vs shallow-dry-little); a support-blind Dirichlet could only average the humps -- amp magnitude parity r went 0.715 -&gt; 0.876 when it landed (the traced-corpus retrains later read 0.886 on their own instrument). Param counts are pulled from the checkpoint (mode_hidden 256, mode_layers 3 per trunk, the joint-HPO winner). Loss boxes mirror the SSL slide: BCE is a proper scoring rule (per-rock minimum = within-bulk presence frequency, which is why intermediate p is signal); the Dirichlet NLL is masked to the label's present set (sub-composition property keeps it a proper density); λ_mag is the loss-weighting coefficient (config key magnitude_weight, 0.25 in production) -- λ chosen over w to avoid clashing with layer weights and to match the λ_balance / λ_comp family. Note the reduction asymmetry: BCE means over the 21 phases while the Dirichlet NLL sums them, so 0.25 in the config is ~5.3 against (effective lambda; the reversed trial-22 dials ran 7.76 = 163) a per-phase-summed BCE. 'Trained jointly' is one scalar L, one backward pass, one AdamW step; with the trunks split, the two ModeHead terms touch disjoint params, coupled only second-order through the per-head gradient clip pooling both trunks' norms. NOT alternating epochs, NOT separate optimizers, NOT staged pretraining of one branch. The hurdle split exists because one full-simplex Dirichlet cannot be simultaneously confident about absences and honest about present-phase spread (shared concentration). CompHead/CondHead follow the same small-MLP-emitting-distribution-parameters pattern; their two-slide reports follow ModeHead's.</a:t>
             </a:r>
           </a:p>
         </p:txBody>
@@ -873,7 +873,7 @@
           <a:lstStyle/>
           <a:p>
             <a:r>
-              <a:t>Worked example for the reliability diagram in runs/mode_head/&lt;tag&gt;/reliability.png. Numbers illustrative but to scale: three rocks predicted in [0.70, 0.80) -- a real bin edge of the 10 equal-width bins the code uses -- contribute 3 predictions x 256 labels = 768 (p, truth) pairs -- 3 predictions, not 768; each rock's single p is scored against its 256 labels. x = count-weighted mean p (0.740), y = pooled fraction of pairs with cpx present (547/768 = 0.712). ECE on the real panels is the count-weighted |x - y| over 10 such bins. The gray ghost dot shows the overconfident failure mode. Real population: the sealed valtest tier's val roster (887 assigned rocks, 871 contributing 222,717 rows at 128 draws x rungs 50/30, minus attrition). Fixed roster: panel numbers move only when the head retrains. Pair with figure 2 (p vs within-bulk frequency): reliability is aggregate honesty, the scatter is per-rock sharpness; a base-rate predictor passes the first and fails the second.</a:t>
+              <a:t>Worked example for the reliability diagram in runs/mode_head/&lt;tag&gt;/reliability.png. Numbers illustrative but to scale: three rocks predicted in [0.70, 0.80) -- a real bin edge of the 10 equal-width bins the code uses -- contribute 3 predictions x 256 labels = 768 (p, truth) pairs -- 3 predictions, not 768; each rock's single p is scored against its 256 labels. x = count-weighted mean p (0.740), y = pooled fraction of pairs with cpx present (547/768 = 0.712). ECE on the real panels is the count-weighted |x - y| over 10 such bins. The gray ghost dot shows the overconfident failure mode. Real population: the production instrument's val roster (221 assigned bulks, 218 contributing 55,576 rows at 128 draws x rungs 50/30, minus attrition). Fixed roster: panel numbers move only when the head retrains. Pair with figure 2 (p vs within-bulk frequency): reliability is aggregate honesty, the scatter is per-rock sharpness; a base-rate predictor passes the first and fails the second.</a:t>
             </a:r>
           </a:p>
         </p:txBody>
@@ -1013,7 +1013,7 @@
           <a:lstStyle/>
           <a:p>
             <a:r>
-              <a:t>Anatomy of CompHead (trains in the joint trainer, checkpoints/joint_heads_regen_tuned_seed0). Interface: h [256] in, alpha [21, 11] out; one training example is one (bulk, draw, rung) row; targets are per-phase oxide mass fractions from the rungs table (same-token instances merged by mass-weighted mean, feldspar split into plag/afs BEFORE averaging so the solvus pair never mixes), eps-clipped at comp_eps and renormalized. Param counts are exact (instantiated at d_model 256, hidden 128). The shared-concentration factorization is the locked heads.md parameterization: one c_p per phase blurs per-oxide error bars toward each other -- accepted because composition spreads are 10-30x tighter than modal spreads (the reason CompHead is bulk-controlled and unconditioned). L_comp's minimum: the Dirichlet matching the per-bulk composition distribution of each phase. L_closure is the one loss term coupling two heads (mode x comp product); squared-L2 is a constraint penalty, not a head likelihood, so the no-MSE rule for heads doesn't apply. Known limits: hard-zero oxides are clipped (a q row is 'SiO2 + 10 eps-floors'); ~0.3% of corpus rows don't self-close (melt immiscibility, dropped-phase mass, worst 5.2 wt%) and set an unattainable closure floor there; endmember bonus heads deferred (heads.md).</a:t>
+              <a:t>Anatomy of CompHead (trains in the joint trainer, checkpoints/joint_heads_supportmag_seed0, the production run). Interface: h [256] in, alpha [21, 11] out; one training example is one (bulk, draw, rung) row; targets are per-phase oxide mass fractions from the rungs table (same-token instances merged by mass-weighted mean, feldspar split into plag/afs BEFORE averaging so the solvus pair never mixes), eps-clipped at comp_eps and renormalized. Param counts are exact (instantiated at d_model 256, hidden 128). The shared-concentration factorization is the locked heads.md parameterization: one c_p per phase blurs per-oxide error bars toward each other -- accepted because composition spreads are 10-30x tighter than modal spreads (the reason CompHead is bulk-controlled and unconditioned). L_comp's minimum: the Dirichlet matching the per-bulk composition distribution of each phase. L_closure is the one loss term coupling two heads (mode x comp product); squared-L2 is a constraint penalty, not a head likelihood, so the no-MSE rule for heads doesn't apply. Known limits: hard-zero oxides are clipped (a q row is 'SiO2 + 10 eps-floors'); ~0.3% of corpus rows don't self-close (melt immiscibility, dropped-phase mass, worst 5.2 wt%) and set an unattainable closure floor there; endmember bonus heads deferred (heads.md).</a:t>
             </a:r>
           </a:p>
         </p:txBody>
@@ -1083,7 +1083,7 @@
           <a:lstStyle/>
           <a:p>
             <a:r>
-              <a:t>Eval-semantics slide for CompHead, mirroring the ModeHead magnitude worked example: two tracks converge at a scoring node; the truth contributes its support to the slice and meets the prediction only at scoring. Box numbers illustrative but to scale (a plag Dirichlet with alpha0 ~780 has SiO2 sd ~0.018); headline numbers are real, from runs/comp_head/joint_heads_regen_tuned_seed0/metrics.json. CompHead is the head the weights-only sweep did not move: against the same-corpus pre-sweep run (joint_heads_regen_seed0) NLL went -56.30 -&gt; -56.29, closure L2 0.0107 -&gt; 0.0109, An# parity mae 0.044 -&gt; 0.043 / r 0.957 -&gt; 0.959 -- all inside the 0.03-nat tie band, which is why the adoption argument rested on ModeHead. The alpha0 span is the durable story (comp_concentration.png): medians run ~170 for garnet to ~40,000 for quartz, ordered by how constrained each mineral's chemistry really is; the earlier untuned model compressed everything into 100-650, but that comparison was measured on the since-retired instrument. PIT here is per-oxide Beta marginals of the 11-simplex Dirichlet (same sub-composition property as the mode slice).</a:t>
+              <a:t>Eval-semantics slide for CompHead, mirroring the ModeHead magnitude worked example: two tracks converge at a scoring node; the truth contributes its support to the slice and meets the prediction only at scoring. Box numbers illustrative but to scale (a plag Dirichlet with alpha0 ~780 has SiO2 sd ~0.018); headline numbers are real, from runs/comp_head/joint_heads_supportmag_seed0/metrics.json (the production run). In the later traced-corpus sweep CompHead was the head the weights-only sweep did not move (NLL -56.30 -&gt; -56.29, inside the tie band) -- which is why that sweep's adoption argument rested on ModeHead, before the adoption itself was reversed 2026-08-03 on the real-rock evidence. The alpha0 span is the durable story (comp_concentration.png): medians run ~170 for garnet to ~40,000 for quartz, ordered by how constrained each mineral's chemistry really is; the earlier untuned model compressed everything into 100-650, but that comparison was measured on the since-retired instrument. PIT here is per-oxide Beta marginals of the 11-simplex Dirichlet (same sub-composition property as the mode slice).</a:t>
             </a:r>
           </a:p>
         </p:txBody>
@@ -1153,7 +1153,7 @@
           <a:lstStyle/>
           <a:p>
             <a:r>
-              <a:t>Anatomy of CondHead (trains in the joint trainer, checkpoints/joint_heads_regen_tuned_seed0). Interface: concat(h [256], presence [21]) in; (log_w, mu, sigma) each [3 axes, K] out; one training example is one (bulk, draw, rung) row with targets (T_end from the rung row; P_kbar, H2O from the draw). Param counts pulled from the checkpoint (cond_hidden 512, cond_layers 2, K=3): cond was the one head that wanted capacity -- starved at 128x1 under the shared tuned lr, fixed by the mini-sweep adoption. Support-conditioning is the locked chain-rule decision: independent heads assume a conditional independence the corpus violates by design -- the within-bulk label variance is driven by the shared hidden (P, H2O) path, and marginals forget which condition mode went with which support. Raw linear units are deliberate (no log transforms; negative mass is a diagnostic, not a bug -- mass_below_zero in the cond eval). init_output_bias seeds component means at target mean +/- 1 std and sigmas at the target std; without it Adam needs ~mu/lr steps to walk mu from 0 to ~900 C. lambda_cond nuance: L_cond's gradient reaches only CondHead's own weights (frozen encoder, separate trunks, teacher-forced input), and per-head clipping + Adam's per-parameter scaling make the constant nearly inert for optimization; per-head best selection (each head keeps its own raw-val best epoch) removed its old early-stopping lever too, leaving it a raw-unit scale absorber (mineralogy-first). Known limits: axes are independent mixtures (no (T, P) correlation, deferred per ADR 006); exposure bias measured, not yet mitigated (#31); T is a derived cooling endpoint, not a sampled axis, in the scenario view.</a:t>
+              <a:t>Anatomy of CondHead (trains in the joint trainer, checkpoints/joint_heads_supportmag_seed0, the production run). Interface: concat(h [256], presence [21]) in; (log_w, mu, sigma) each [3 axes, K] out; one training example is one (bulk, draw, rung) row with targets (T_end from the rung row; P_kbar, H2O from the draw). Param counts pulled from the checkpoint (cond_hidden 512, cond_layers 2, K=3): cond was the one head that wanted capacity -- starved at 128x1 under the shared tuned lr, fixed by the mini-sweep adoption. Support-conditioning is the locked chain-rule decision: independent heads assume a conditional independence the corpus violates by design -- the within-bulk label variance is driven by the shared hidden (P, H2O) path, and marginals forget which condition mode went with which support. Raw linear units are deliberate (no log transforms; negative mass is a diagnostic, not a bug -- mass_below_zero in the cond eval). init_output_bias seeds component means at target mean +/- 1 std and sigmas at the target std; without it Adam needs ~mu/lr steps to walk mu from 0 to ~900 C. lambda_cond nuance: L_cond's gradient reaches only CondHead's own weights (frozen encoder, separate trunks, teacher-forced input), and per-head clipping + Adam's per-parameter scaling make the constant nearly inert for optimization; per-head best selection (each head keeps its own raw-val best epoch) removed its old early-stopping lever too, leaving it a raw-unit scale absorber (mineralogy-first). Known limits: axes are independent mixtures (no (T, P) correlation, deferred per ADR 006); exposure bias measured, not yet mitigated (#31); T is a derived cooling endpoint, not a sampled axis, in the scenario view.</a:t>
             </a:r>
           </a:p>
         </p:txBody>
@@ -1223,7 +1223,7 @@
           <a:lstStyle/>
           <a:p>
             <a:r>
-              <a:t>Eval-semantics slide for CondHead. The two-pass protocol is the point: teacher-forced scoring isolates the head's conditional skill p(T,P,H2O | h, true support); sampled-support scoring measures the deployed chain with ModeHead's Bernoulli draws standing in for the truth (exposure_seed pins reproducibility). Mixture drawing illustrative but to scale for a bimodal amp/opx bulk (deep-wet vs shallow-dry is the flagship condition multimodality). Real numbers from runs/cond_head/joint_heads_regen_tuned_seed0/metrics.json against the same-corpus pre-sweep run: teacher-forced NLL 7.40 -&gt; 7.36 (T 4.762 -&gt; 4.727, P 1.562 -&gt; 1.558, H2O 1.080 -&gt; 1.072) while coverage drifted DOWN, 0.727/0.683/0.669 -&gt; 0.699/0.662/0.655, and the exposure delta widened on every axis (T 2.22 -&gt; 2.66, P 1.16 -&gt; 1.36, H2O 1.03 -&gt; 1.23) -- the sharper head is more wrong under mismatched supports, and slightly under-covering under matched ones. The sampled-support inf rows that used to appear here were a float32 underflow in the density guard, not a modelling failure; the per-axis NLL now goes through logsumexp, and those rows read 118-141 nats. Coverage is central-interval mass via the mixture CDF (PIT), same construction as the mode/comp calibration reads.</a:t>
+              <a:t>Eval-semantics slide for CondHead. The two-pass protocol is the point: teacher-forced scoring isolates the head's conditional skill p(T,P,H2O | h, true support); sampled-support scoring measures the deployed chain with ModeHead's Bernoulli draws standing in for the truth (exposure_seed pins reproducibility). Mixture drawing illustrative but to scale for a bimodal amp/opx bulk (deep-wet vs shallow-dry is the flagship condition multimodality). Real numbers from runs/cond_head/joint_heads_supportmag_seed0/metrics.json (the production run): teacher-forced per-axis NLL T 4.97 / P 1.82 / H2O 1.52, coverage-68 0.710/0.674/0.679, exposure delta T 4.00 / P 2.73 / H2O 2.40 nats with sampled coverage falling to 0.26/0.34/0.34. (The later traced-corpus sweep sharpened NLL slightly while coverage drifted down and the exposure delta widened -- one strand of the evidence behind the 2026-08-03 adoption reversal.) The sampled-support inf rows that used to appear here were a float32 underflow in the density guard, not a modelling failure; the per-axis NLL now goes through logsumexp, and those rows read 118-141 nats. Coverage is central-interval mass via the mixture CDF (PIT), same construction as the mode/comp calibration reads.</a:t>
             </a:r>
           </a:p>
         </p:txBody>
@@ -1363,7 +1363,7 @@
           <a:lstStyle/>
           <a:p>
             <a:r>
-              <a:t>The joint view the three anatomy slides decompose: every branch reads the same frozen 256-d h, and the four likelihood terms plus the closure penalty sum to one scalar. Two arrows are not plain feed-forward: the magnitude branch and CondHead take concat(h, support) -- the chain rule p(support | h) x p(rest | h, support), teacher-forced true mask at train, ModeHead-sampled at inference (exposure bias, #31). CompHead deliberately does NOT see the support: composition is bulk-controlled (heads.md). Closure is drawn as a joiner, not a fifth branch, because it has no parameters -- it multiplies ModeHead's support-masked Dirichlet mean by CompHead's Dirichlet mean and asks whether the reconstructed bulk matches the input; squared-L2 is a constraint penalty, not a head likelihood, so the no-MSE rule for heads does not apply. It is the one term coupling two heads. Weights and param counts are from the production run (checkpoints/joint_heads_regen_tuned_seed0, trial-22 dials adopted 2026-07-29). The reduction asymmetry in the last caption is a real footgun when transcribing the equation: BCE reduces over batch AND phases, the Dirichlet NLL over batch only, so magnitude_weight in the config is 1/21 of the coefficient you would write against a summed BCE. lambda_cond is small because L_cond is in raw units (T in the hundreds); it absorbs scale, it is not a statement about how much the conditions matter. Each head is snapshotted at its own best raw-val epoch and clipped separately, so the lambdas do not act as early-stopping levers. Not shown because they are not in the joint trainer: the auxiliary ClassHead and G_sys remain application slots, unimplemented.</a:t>
+              <a:t>The joint view the three anatomy slides decompose: every branch reads the same frozen 256-d h, and the four likelihood terms plus the closure penalty sum to one scalar. Two arrows are not plain feed-forward: the magnitude branch and CondHead take concat(h, support) -- the chain rule p(support | h) x p(rest | h, support), teacher-forced true mask at train, ModeHead-sampled at inference (exposure bias, #31). CompHead deliberately does NOT see the support: composition is bulk-controlled (heads.md). Closure is drawn as a joiner, not a fifth branch, because it has no parameters -- it multiplies ModeHead's support-masked Dirichlet mean by CompHead's Dirichlet mean and asks whether the reconstructed bulk matches the input; squared-L2 is a constraint penalty, not a head likelihood, so the no-MSE rule for heads does not apply. It is the one term coupling two heads. Weights and param counts are from the production run (checkpoints/joint_heads_supportmag_seed0; the trial-22 adoption of 2026-07-29 was reversed 2026-08-03 -- the traced-corpus retrains lose on real rocks). The reduction asymmetry in the last caption is a real footgun when transcribing the equation: BCE reduces over batch AND phases, the Dirichlet NLL over batch only, so magnitude_weight in the config is 1/21 of the coefficient you would write against a summed BCE. lambda_cond is small because L_cond is in raw units (T in the hundreds); it absorbs scale, it is not a statement about how much the conditions matter. Each head is snapshotted at its own best raw-val epoch and clipped separately, so the lambdas do not act as early-stopping levers. Not shown because they are not in the joint trainer: the auxiliary ClassHead and G_sys remain application slots, unimplemented.</a:t>
             </a:r>
           </a:p>
         </p:txBody>
@@ -1713,7 +1713,7 @@
           <a:lstStyle/>
           <a:p>
             <a:r>
-              <a:t>Status strip for the corpus regen, now fully landed -- the slide is a record, not a plan. Two generations have run: the first (2026-07-17, 10k train bulks x 48 broad-box draws) and the traced regen (2026-07-27) described here. Step 5 is cascade 1: heads retrained at the incumbent dials on the traced tiers, then a weights-only mini-HPO whose winner was adopted (joint_heads_regen_tuned_seed0). Cascade 2 -- swapping in the all-rock + redox encoder that was accepted 2026-07-28 -- has not run, which is why every architecture slide in this deck still shows the 22-token encoder. Candidate to retire or fold into the corpora slide at the next deck pass (owner call).</a:t>
+              <a:t>Status strip for the corpus regen, now fully landed -- the slide is a record, not a plan. Two generations have run: the first (2026-07-17, 10k train bulks x 48 broad-box draws) and the traced regen (2026-07-27) described here. Step 5 is cascade 1: heads retrained at the incumbent dials on the traced tiers, then a weights-only mini-HPO. Its winner (joint_heads_regen_tuned_seed0) was provisionally adopted 2026-07-29 and reversed 2026-08-03: both traced-corpus checkpoints lose to the old-corpus production model on real rocks after identical recalibration (sealed test joint NLL 0.478 / 0.769 / 1.371), so production remains joint_heads_supportmag_seed0 and the traced corpus is a measured non-production arm (its wins: quartz presence, assemblage ranking). Cascade 2 -- the all-rock + redox encoder (accepted 2026-07-28) on the old broad-draw corpus, baseline-first -- has not run, which is why every architecture slide in this deck still shows the 22-token encoder. Candidate to retire or fold into the corpora slide at the next deck pass (owner call).</a:t>
             </a:r>
           </a:p>
         </p:txBody>
@@ -9075,7 +9075,7 @@
                   <a:srgbClr val="8A93A3"/>
                 </a:solidFill>
               </a:rPr>
-              <a:t>dials (configs/heads/joint_heads.yaml): mode_hidden 256 . mode_layers 3 . dropout 0.160 . magnitude_weight 7.76 . alpha_eps 1e-6 . lr 3.36e-4 . weight_decay 1.59e-4 . batch 1024 . epochs 120 / per-head patience 10 -- fixed in code: GELU, AdamW, grad-clip 1.0</a:t>
+              <a:t>dials (stamped in the production checkpoint): mode_hidden 256 . mode_layers 3 . dropout 0.348 . magnitude_weight 0.25 . alpha_eps 1e-6 . lr 2.15e-4 . weight_decay 1.04e-5 . batch 1024 . epochs 120 / per-head patience 10 -- fixed in code: GELU, AdamW, grad-clip 1.0</a:t>
             </a:r>
           </a:p>
         </p:txBody>
@@ -9270,7 +9270,7 @@
                   <a:srgbClr val="8A93A3"/>
                 </a:solidFill>
               </a:rPr>
-              <a:t>one backward pass; the trunks are param-disjoint, so λ_mag no longer arbitrates a shared trunk -- it sets how hard the Dirichlet term pulls relative to the presence term, and the sweep pushed it 31x up to 7.76</a:t>
+              <a:t>one backward pass; the trunks are param-disjoint, so λ_mag no longer arbitrates a shared trunk -- it sets how hard the Dirichlet term pulls relative to the presence term; production runs 0.25</a:t>
             </a:r>
           </a:p>
         </p:txBody>
@@ -10562,7 +10562,7 @@
                   <a:srgbClr val="1A2238"/>
                 </a:solidFill>
               </a:rPr>
-              <a:t>3 rocks shown; the real figure pools the val-roster rocks only -- 871 rocks x ~256 rows = 222,717 (p, truth) pairs per mineral panel, partitioned across the 10 bins (the gray bars). Training rocks are excluded because a head that memorized them would grade itself calibrated. And since all ~256 rows of a rock share one prediction, a panel holds only 871 distinct p values, each stamped ~256x -- the effective sample size is rocks, not rows. The population is the fixed val roster of the sealed valtest tier (128 draws/rock at rungs 50+30), so panels are comparable across retrains.</a:t>
+              <a:t>3 rocks shown; the real figure pools the val-roster rocks only -- 218 rocks x ~255 rows = 55,576 (p, truth) pairs per mineral panel, partitioned across the 10 bins (the gray bars). Training rocks are excluded because a head that memorized them would grade itself calibrated. And since all ~255 rows of a rock share one prediction, a panel holds only 218 distinct p values, each stamped ~256x -- the effective sample size is rocks, not rows. The population is the fixed val roster of the sealed valtest tier (128 draws/rock at rungs 50+30), so panels are comparable across retrains.</a:t>
             </a:r>
           </a:p>
         </p:txBody>
@@ -10596,7 +10596,7 @@
                   <a:srgbClr val="8A93A3"/>
                 </a:solidFill>
               </a:rPr>
-              <a:t>BCE's per-rock minimum is the true fraction, so an honest head lands on the diagonal by construction. current limits (production model): intermediate-frequency presence is the miss mode -- where a mineral grows on 10-50% of a rock's paths, recall runs 0.09-0.35, against 0.86-1.00 where it grows on &gt;90%; the rare phases (mu, ep, ky) are never called at all; spinel is the worst-calibrated panel (ECE 0.040). full report: runs/mode_head/&lt;tag&gt;/</a:t>
+              <a:t>BCE's per-rock minimum is the true fraction, so an honest head lands on the diagonal by construction. current limits (production model): intermediate-frequency presence is the miss mode -- where a mineral grows on 10-50% of a rock's paths, recall runs 0.00-0.41, against 0.76-1.00 where it grows on &gt;90%; the rarest phases are essentially never called; spinel is the worst-calibrated panel (ECE 0.072). full report: runs/mode_head/&lt;tag&gt;/</a:t>
             </a:r>
           </a:p>
         </p:txBody>
@@ -11948,7 +11948,7 @@
                   <a:srgbClr val="8A93A3"/>
                 </a:solidFill>
               </a:rPr>
-              <a:t>population: only truly-present (row, phase) pairs are scored -- ~177k pairs for plag down to ~340 for kyanite; single-phase rows are excluded (nothing to size). current limits (production model): amp parity r 0.886 teacher-forced but 0.580 on self-sampled supports; 47% of its PIT groups still sit mean-shifted and 11.5% are two-sided -- bimodal WITHIN one support (mixture parameterization is the staged candidate, #25). full report: runs/mode_head/&lt;tag&gt;/ (magnitude_parity, magnitude_pit).</a:t>
+              <a:t>population: only truly-present (row, phase) pairs are scored -- ~41k pairs for plag down to a few hundred for the rarest phases; single-phase rows are excluded (nothing to size). current limits (production model): amp parity r 0.876 teacher-forced but 0.539 on self-sampled supports; the interrogation also measured amp bimodal WITHIN one support (mixture parameterization is the staged candidate, #25). full report: runs/mode_head/&lt;tag&gt;/ (magnitude_parity, magnitude_pit).</a:t>
             </a:r>
           </a:p>
         </p:txBody>
@@ -12852,7 +12852,7 @@
                   <a:srgbClr val="8A93A3"/>
                 </a:solidFill>
               </a:rPr>
-              <a:t>dials (configs/heads/joint_heads.yaml): comp_hidden null -&gt; 128 . comp_layers 1 (mini-sweep verdict: capacity above 128 x 1 hurts comp) . dropout 0.160 . alpha_eps 1e-6 . comp_eps 1e-4 (hard-zero clip on targets) . lambda_comp 1.0 . lambda_balance 0.0118 -- fixed in code: GELU, AdamW, per-head grad-clip 1.0</a:t>
+              <a:t>dials (configs/heads/joint_heads.yaml): comp_hidden null -&gt; 128 . comp_layers 1 (mini-sweep verdict: capacity above 128 x 1 hurts comp) . dropout 0.348 . alpha_eps 1e-6 . comp_eps 1e-4 (hard-zero clip on targets) . lambda_comp 1.0 . lambda_balance 54.5 -- fixed in code: GELU, AdamW, per-head grad-clip 1.0</a:t>
             </a:r>
           </a:p>
         </p:txBody>
@@ -14140,7 +14140,7 @@
                   <a:srgbClr val="1A2238"/>
                 </a:solidFill>
               </a:rPr>
-              <a:t>population: only truly-present (row, phase) pairs -- 161k for cpx down to ~340 for kyanite. headline (val roster, production): comp NLL -56.29 nats per present (row, phase); majors' PIT tails sit near the nominal 10% (cpx 0.040/0.055).</a:t>
+              <a:t>population: only truly-present (row, phase) pairs -- 42k for cpx down to ~240 for andalusite. headline (val roster, production): comp NLL -53.90 nats per present (row, phase); majors' PIT tails sit near the nominal 10% (cpx 0.048/0.054).</a:t>
             </a:r>
           </a:p>
         </p:txBody>
@@ -14174,7 +14174,7 @@
                   <a:srgbClr val="1A2238"/>
                 </a:solidFill>
               </a:rPr>
-              <a:t>confidence spans ~2.5 decades and tracks real mineralogy: near-stoichiometric phases earn median alpha0 ~40,000 (q), ~36,000 (ru), ~19,000 (sph) while wide solid solutions stay soft -- garnet ~170, spinel ~240, ilmenite ~480. mass balance closes to 1.1% mean L2 with signed per-oxide residuals centered on zero; plag An# parity r = 0.96.</a:t>
+              <a:t>confidence spans decades and tracks real mineralogy: near-stoichiometric phases (q, ru, sph) earn far higher median alpha0 than wide solid solutions (garnet, spinel, ilmenite) -- span measured on the traced-corpus retrain. mass balance closes to 1.3% mean L2 with signed per-oxide residuals centered on zero; plag An# parity r = 0.93.</a:t>
             </a:r>
           </a:p>
         </p:txBody>
@@ -15355,7 +15355,7 @@
                   <a:srgbClr val="8A93A3"/>
                 </a:solidFill>
               </a:rPr>
-              <a:t>dials (configs/heads/joint_heads.yaml): cond_n_components 3 . cond_sigma_eps 1e-3 . cond_hidden 512 . cond_layers 2 (adopted from the architecture mini-sweep) . dropout 0.160 . lambda_cond 0.01 -- fixed in code: GELU, AdamW, per-head grad-clip 1.0, linear units (no log transform of T/P/H2O)</a:t>
+              <a:t>dials (configs/heads/joint_heads.yaml): cond_n_components 3 . cond_sigma_eps 1e-3 . cond_hidden 512 . cond_layers 2 (adopted from the architecture mini-sweep) . dropout 0.348 . lambda_cond 0.01 -- fixed in code: GELU, AdamW, per-head grad-clip 1.0, linear units (no log transform of T/P/H2O)</a:t>
             </a:r>
           </a:p>
         </p:txBody>
@@ -16412,7 +16412,7 @@
                   <a:srgbClr val="8A93A3"/>
                 </a:solidFill>
               </a:rPr>
-              <a:t>68% band catches truth on 69.9% of rows (T),</a:t>
+              <a:t>68% band catches truth on 71.0% of rows (T),</a:t>
             </a:r>
           </a:p>
           <a:p>
@@ -16423,7 +16423,7 @@
                   <a:srgbClr val="8A93A3"/>
                 </a:solidFill>
               </a:rPr>
-              <a:t>66.2% (P), 65.5% (H2O) . NLL 7.36 nats/row</a:t>
+              <a:t>67.4% (P), 67.9% (H2O) . NLL 8.31 nats/row</a:t>
             </a:r>
           </a:p>
         </p:txBody>
@@ -16488,7 +16488,7 @@
                   <a:srgbClr val="8A93A3"/>
                 </a:solidFill>
               </a:rPr>
-              <a:t>coverage falls to 33% (T), 44% (P), 45% (H2O) . NLL +1.2 to +2.7</a:t>
+              <a:t>coverage falls to 26% (T), 34% (P), 34% (H2O) . NLL +2.4 to +4.0</a:t>
             </a:r>
           </a:p>
           <a:p>
@@ -16499,7 +16499,7 @@
                   <a:srgbClr val="8A93A3"/>
                 </a:solidFill>
               </a:rPr>
-              <a:t>nats/axis -- sharper under truth = more wrong under mismatch</a:t>
+              <a:t>nats/axis -- sharp under truth = more wrong under mismatch</a:t>
             </a:r>
           </a:p>
         </p:txBody>
@@ -16533,7 +16533,7 @@
                   <a:srgbClr val="1A2238"/>
                 </a:solidFill>
               </a:rPr>
-              <a:t>the gap is a deliberate debt: the head trains and is graded teacher-forced (mineralogy-first -- conditions are the bonus product), and tuning made the head sharper, which widened the gap. It is measured, tracked (#31, P3), and untouched by design until the mineralogy heads are done.</a:t>
+              <a:t>the gap is a deliberate debt: the head trains and is graded teacher-forced (mineralogy-first -- conditions are the bonus product). It is measured, tracked (#31, P3), and untouched by design until the mineralogy heads are done.</a:t>
             </a:r>
           </a:p>
         </p:txBody>
@@ -16567,7 +16567,7 @@
                   <a:srgbClr val="1A2238"/>
                 </a:solidFill>
               </a:rPr>
-              <a:t>population: all 222,717 val-roster rows, both scoring passes on the same rows with a fixed sampling seed. per-axis NLL (production, teacher-forced): T 4.73, P 1.56, H2O 1.07 -- summed 7.36.</a:t>
+              <a:t>population: all 55,576 val-roster rows, both scoring passes on the same rows with a fixed sampling seed. per-axis NLL (production, teacher-forced): T 4.97, P 1.82, H2O 1.52 -- summed 8.31.</a:t>
             </a:r>
           </a:p>
         </p:txBody>
@@ -18821,7 +18821,7 @@
                   <a:srgbClr val="8A93A3"/>
                 </a:solidFill>
               </a:rPr>
-              <a:t>λ_mag 7.76 . λ_comp 1.0 . λ_cond 0.01 . λ_bal 0.0118 (joint HPO, ADR 006) -- one scalar, one backward pass, one AdamW step; the branches share no weights, so each λ balances terms rather than arbitrating a trunk</a:t>
+              <a:t>λ_mag 0.25 . λ_comp 1.0 . λ_cond 0.01 . λ_bal 54.5 (joint HPO, ADR 006) -- one scalar, one backward pass, one AdamW step; the branches share no weights, so each λ balances terms rather than arbitrating a trunk</a:t>
             </a:r>
           </a:p>
         </p:txBody>
@@ -18855,7 +18855,7 @@
                   <a:srgbClr val="1A2238"/>
                 </a:solidFill>
               </a:rPr>
-              <a:t>895,169 params on the frozen 3.23M encoder (~28%): mode 410,922 . comp 65,404 . cond 418,843 -- from checkpoints/joint_heads_regen_tuned_seed0/heads_best.pt</a:t>
+              <a:t>895,169 params on the frozen 3.23M encoder (~28%): mode 410,922 . comp 65,404 . cond 418,843 -- from checkpoints/joint_heads_supportmag_seed0/heads_best.pt</a:t>
             </a:r>
           </a:p>
         </p:txBody>
@@ -18889,7 +18889,7 @@
                   <a:srgbClr val="8A93A3"/>
                 </a:solidFill>
               </a:rPr>
-              <a:t>dials (configs/heads/joint_heads.yaml): dropout 0.160 . lr 3.36e-4 . weight_decay 1.59e-4 . batch 1024 . epochs 120 / patience 10 -- in code: GELU, AdamW, grad-clip 1.0 per head</a:t>
+              <a:t>dials (stamped in the production checkpoint): dropout 0.348 . lr 2.15e-4 . weight_decay 1.04e-5 . batch 1024 . epochs 120 / patience 10 -- in code: GELU, AdamW, grad-clip 1.0 per head</a:t>
             </a:r>
           </a:p>
         </p:txBody>
@@ -18923,7 +18923,7 @@
                   <a:srgbClr val="C0392B"/>
                 </a:solidFill>
               </a:rPr>
-              <a:t>L_presence is meaned over the 21 phases while L_magnitude sums them, so against a per-phase-SUM BCE the same weight reads 21 x 7.76 = 163</a:t>
+              <a:t>L_presence is meaned over the 21 phases while L_magnitude sums them, so against a per-phase-SUM BCE the same weight reads 21 x 0.25 = ~5.3 (the reversed trial-22 dials ran 21 x 7.76 = 163)</a:t>
             </a:r>
           </a:p>
         </p:txBody>
@@ -25686,7 +25686,7 @@
                   <a:srgbClr val="1A2238"/>
                 </a:solidFill>
               </a:rPr>
-              <a:t>retrained + re-tuned</a:t>
+              <a:t>measured, not adopted</a:t>
             </a:r>
           </a:p>
           <a:p>
@@ -25697,7 +25697,7 @@
                   <a:srgbClr val="8A93A3"/>
                 </a:solidFill>
               </a:rPr>
-              <a:t>on the traced tiers;</a:t>
+              <a:t>traced heads lost on</a:t>
             </a:r>
           </a:p>
           <a:p>
@@ -25708,7 +25708,18 @@
                   <a:srgbClr val="8A93A3"/>
                 </a:solidFill>
               </a:rPr>
-              <a:t>encoder swap is next</a:t>
+              <a:t>real rocks; encoder</a:t>
+            </a:r>
+          </a:p>
+          <a:p>
+            <a:pPr algn="ctr"/>
+            <a:r>
+              <a:rPr sz="900" b="0">
+                <a:solidFill>
+                  <a:srgbClr val="8A93A3"/>
+                </a:solidFill>
+              </a:rPr>
+              <a:t>swap is next</a:t>
             </a:r>
           </a:p>
         </p:txBody>
@@ -25820,7 +25831,7 @@
                   <a:srgbClr val="1A2238"/>
                 </a:solidFill>
               </a:rPr>
-              <a:t>the corpus was regenerated end to end in July 2026: 3.5x the bulks (scaling said bulks are where the nats are, and draws flatten past ~24), a trace-conditional (P, H2O) proposal replacing the broad box, and a valtest roster grown to 2,000 bulks by extension -- prior val/test assignments are frozen, so committed rows never move between splits. Test stays sealed.</a:t>
+              <a:t>the corpus was regenerated end to end in July 2026: 3.5x the bulks (scaling said bulks are where the nats are, and draws flatten past ~24), a trace-conditional (P, H2O) proposal replacing the broad box, and a valtest roster grown to 2,000 bulks by extension -- prior val/test assignments are frozen, so committed rows never move between splits.</a:t>
             </a:r>
           </a:p>
         </p:txBody>

</xml_diff>

<commit_message>
overview deck: current-vs-proposed canonical-output section -- existing output slides kickered CURRENT, new proposal slide for the ModeHead dirichlet layer (mixture) showing truth / current single-Dirichlet / proposed K=2 amp marginals, the gate, component coincidence on   unimodal phases, and the K=1 drop path; numbers illustrative, marked built-not-trained
</commit_message>
<xml_diff>
--- a/slides/overview.pptx
+++ b/slides/overview.pptx
@@ -27,6 +27,7 @@
     <p:sldId id="275" r:id="rId27"/>
     <p:sldId id="276" r:id="rId28"/>
     <p:sldId id="277" r:id="rId29"/>
+    <p:sldId id="278" r:id="rId30"/>
   </p:sldIdLst>
   <p:sldSz cx="12191695" cy="6858000" type="screen4x3"/>
   <p:notesSz cx="6858000" cy="9144000"/>
@@ -1504,6 +1505,76 @@
           <a:p>
             <a:r>
               <a:t>View 2 from heads.md, modernized to the locked corpus design: crystals-renormalized (no residual-melt row -- melt-fraction head dropped), composition shared across scenarios (CompHead reads h only), no inference-time mass-balance checkmark (closure is teacher-forced at training; the inference residual as OOD signal is an open rethink). Marginal view = projection of these scenarios; scenarios are the primary object. The joint-sampling mechanism exists (two-step ancestral sampling: presence Bernoullis -&gt; support, then the support-conditioned magnitude Dirichlet and CondHead both condition on it -- scripts/view/scenario_view.py); per-scenario mode shares and conditions are genuinely re-predicted per support. Numbers illustrative.</a:t>
+            </a:r>
+          </a:p>
+        </p:txBody>
+      </p:sp>
+      <p:sp>
+        <p:nvSpPr>
+          <p:cNvPr id="4" name="Slide Number Placeholder 3"/>
+          <p:cNvSpPr>
+            <a:spLocks noGrp="1"/>
+          </p:cNvSpPr>
+          <p:nvPr>
+            <p:ph type="sldNum" idx="5" sz="quarter"/>
+          </p:nvPr>
+        </p:nvSpPr>
+        <p:spPr/>
+      </p:sp>
+    </p:spTree>
+  </p:cSld>
+  <p:clrMapOvr>
+    <a:masterClrMapping/>
+  </p:clrMapOvr>
+</p:notes>
+</file>
+
+<file path=ppt/notesSlides/notesSlide23.xml><?xml version="1.0" encoding="utf-8"?>
+<p:notes xmlns:a="http://schemas.openxmlformats.org/drawingml/2006/main" xmlns:p="http://schemas.openxmlformats.org/presentationml/2006/main" xmlns:r="http://schemas.openxmlformats.org/officeDocument/2006/relationships">
+  <p:cSld>
+    <p:spTree>
+      <p:nvGrpSpPr>
+        <p:cNvPr id="1" name=""/>
+        <p:cNvGrpSpPr/>
+        <p:nvPr/>
+      </p:nvGrpSpPr>
+      <p:grpSpPr>
+        <a:xfrm>
+          <a:off x="0" y="0"/>
+          <a:ext cx="0" cy="0"/>
+          <a:chOff x="0" y="0"/>
+          <a:chExt cx="0" cy="0"/>
+        </a:xfrm>
+      </p:grpSpPr>
+      <p:sp>
+        <p:nvSpPr>
+          <p:cNvPr id="2" name="Slide Image Placeholder 1"/>
+          <p:cNvSpPr>
+            <a:spLocks noGrp="1"/>
+          </p:cNvSpPr>
+          <p:nvPr>
+            <p:ph type="sldImg" idx="2"/>
+          </p:nvPr>
+        </p:nvSpPr>
+        <p:spPr/>
+      </p:sp>
+      <p:sp>
+        <p:nvSpPr>
+          <p:cNvPr id="3" name="Notes Placeholder 2"/>
+          <p:cNvSpPr>
+            <a:spLocks noGrp="1"/>
+          </p:cNvSpPr>
+          <p:nvPr>
+            <p:ph type="body" idx="3" sz="quarter"/>
+          </p:nvPr>
+        </p:nvSpPr>
+        <p:spPr/>
+        <p:txBody>
+          <a:bodyPr/>
+          <a:lstStyle/>
+          <a:p>
+            <a:r>
+              <a:t>Proposal slide for the ModeHead dirichlet layer (mixture), built 2026-08-04 behind the K=1-identity `mode_n_components` dial -- no trained checkpoint yet, so the canonical output is unchanged; drawn so the contrast with the two current-output slides is visual. Motivating measurements: 45% of sampled bulks bimodal in conditional amp proportion (2026-07-17 corpus exam), 34% of testable bimodal bulks still bimodal within their dominant support (the part support-conditioning cannot represent); amp two-sided PIT groups 0.026 -&gt; 0.114 when support-conditioning landed (truth escaping both tails = mean parked between humps); real-rock residual heavier-tailed than any Beta at the fitted mean. Design locked with the owner: K=2 fixed (not an HPO dial yet), assemblage-level components (one gate choosing whole alpha vectors -- on a simplex a per-phase mixture is not even coherent, and the humps co-vary through the shared hidden (P, H2O) path, cf. the 51% amp&lt;-&gt;opx switch), no gate regularizer in the first build (gate entropy is a read-after diagnostic; collapse = H~0 everywhere plus identical components), all-rock encoder with the allrock-tuned dials, control = joint_heads_allrock_tuned_seed0 as trained. Loss is logsumexp(log w_k + log Dir_k) on the present support -- CondHead's GMM pattern moved onto the Dirichlet. Build gate: K=1 under the new code must reproduce production metrics to float precision before any K=2 run. Old broad-draw corpus; verdict on the real-rock benchmark, val only, test untouched.</a:t>
             </a:r>
           </a:p>
         </p:txBody>
@@ -18975,7 +19046,7 @@
                   <a:srgbClr val="2E5BFF"/>
                 </a:solidFill>
               </a:rPr>
-              <a:t>HEADS</a:t>
+              <a:t>HEADS -- CURRENT CANONICAL OUTPUT</a:t>
             </a:r>
           </a:p>
         </p:txBody>
@@ -21286,7 +21357,7 @@
                   <a:srgbClr val="2E5BFF"/>
                 </a:solidFill>
               </a:rPr>
-              <a:t>HEADS</a:t>
+              <a:t>HEADS -- CURRENT CANONICAL OUTPUT</a:t>
             </a:r>
           </a:p>
         </p:txBody>
@@ -21641,6 +21712,1536 @@
                 </a:solidFill>
               </a:rPr>
               <a:t>per-phase composition (An#, Mg#) is bulk-controlled -- one shared band across scenarios, not re-predicted per scenario. Each scenario is a falsifiable hypothesis: amphibole in thin section selects A, and with it A's conditions.</a:t>
+            </a:r>
+          </a:p>
+        </p:txBody>
+      </p:sp>
+    </p:spTree>
+  </p:cSld>
+  <p:clrMapOvr>
+    <a:masterClrMapping/>
+  </p:clrMapOvr>
+</p:sld>
+</file>
+
+<file path=ppt/slides/slide23.xml><?xml version="1.0" encoding="utf-8"?>
+<p:sld xmlns:a="http://schemas.openxmlformats.org/drawingml/2006/main" xmlns:p="http://schemas.openxmlformats.org/presentationml/2006/main" xmlns:r="http://schemas.openxmlformats.org/officeDocument/2006/relationships">
+  <p:cSld>
+    <p:spTree>
+      <p:nvGrpSpPr>
+        <p:cNvPr id="1" name=""/>
+        <p:cNvGrpSpPr/>
+        <p:nvPr/>
+      </p:nvGrpSpPr>
+      <p:grpSpPr/>
+      <p:sp>
+        <p:nvSpPr>
+          <p:cNvPr id="2" name="TextBox 1"/>
+          <p:cNvSpPr txBox="1"/>
+          <p:nvPr/>
+        </p:nvSpPr>
+        <p:spPr>
+          <a:xfrm>
+            <a:off x="502920" y="274320"/>
+            <a:ext cx="10972800" cy="365760"/>
+          </a:xfrm>
+          <a:prstGeom prst="rect">
+            <a:avLst/>
+          </a:prstGeom>
+          <a:noFill/>
+        </p:spPr>
+        <p:txBody>
+          <a:bodyPr wrap="square">
+            <a:spAutoFit/>
+          </a:bodyPr>
+          <a:lstStyle/>
+          <a:p>
+            <a:pPr algn="l"/>
+            <a:r>
+              <a:rPr sz="1300" b="1">
+                <a:solidFill>
+                  <a:srgbClr val="2E5BFF"/>
+                </a:solidFill>
+              </a:rPr>
+              <a:t>HEADS -- PROPOSED CANONICAL OUTPUT (K=2 DISTRIBUTIONS)</a:t>
+            </a:r>
+          </a:p>
+        </p:txBody>
+      </p:sp>
+      <p:sp>
+        <p:nvSpPr>
+          <p:cNvPr id="3" name="TextBox 2"/>
+          <p:cNvSpPr txBox="1"/>
+          <p:nvPr/>
+        </p:nvSpPr>
+        <p:spPr>
+          <a:xfrm>
+            <a:off x="502920" y="603504"/>
+            <a:ext cx="11155680" cy="731520"/>
+          </a:xfrm>
+          <a:prstGeom prst="rect">
+            <a:avLst/>
+          </a:prstGeom>
+          <a:noFill/>
+        </p:spPr>
+        <p:txBody>
+          <a:bodyPr wrap="square">
+            <a:spAutoFit/>
+          </a:bodyPr>
+          <a:lstStyle/>
+          <a:p>
+            <a:pPr algn="l"/>
+            <a:r>
+              <a:rPr sz="2600" b="1">
+                <a:solidFill>
+                  <a:srgbClr val="1A2238"/>
+                </a:solidFill>
+              </a:rPr>
+              <a:t>Proposed: the ModeHead dirichlet layer (mixture) -- built, not yet trained</a:t>
+            </a:r>
+          </a:p>
+        </p:txBody>
+      </p:sp>
+      <p:sp>
+        <p:nvSpPr>
+          <p:cNvPr id="4" name="TextBox 3"/>
+          <p:cNvSpPr txBox="1"/>
+          <p:nvPr/>
+        </p:nvSpPr>
+        <p:spPr>
+          <a:xfrm>
+            <a:off x="502920" y="1051560"/>
+            <a:ext cx="11155680" cy="731520"/>
+          </a:xfrm>
+          <a:prstGeom prst="rect">
+            <a:avLst/>
+          </a:prstGeom>
+          <a:noFill/>
+        </p:spPr>
+        <p:txBody>
+          <a:bodyPr wrap="square">
+            <a:spAutoFit/>
+          </a:bodyPr>
+          <a:lstStyle/>
+          <a:p>
+            <a:pPr algn="l"/>
+            <a:r>
+              <a:rPr sz="1300" b="0">
+                <a:solidFill>
+                  <a:srgbClr val="8A93A3"/>
+                </a:solidFill>
+              </a:rPr>
+              <a:t>same bulk, same h, same presence Bernoullis -- only the 'how much, given this mineral set' answer changes: two full-assemblage components chosen by a gate, instead of one Dirichlet per (rock, support)</a:t>
+            </a:r>
+          </a:p>
+        </p:txBody>
+      </p:sp>
+      <p:sp>
+        <p:nvSpPr>
+          <p:cNvPr id="5" name="TextBox 4"/>
+          <p:cNvSpPr txBox="1"/>
+          <p:nvPr/>
+        </p:nvSpPr>
+        <p:spPr>
+          <a:xfrm>
+            <a:off x="502920" y="1645920"/>
+            <a:ext cx="11155680" cy="731520"/>
+          </a:xfrm>
+          <a:prstGeom prst="rect">
+            <a:avLst/>
+          </a:prstGeom>
+          <a:noFill/>
+        </p:spPr>
+        <p:txBody>
+          <a:bodyPr wrap="square">
+            <a:spAutoFit/>
+          </a:bodyPr>
+          <a:lstStyle/>
+          <a:p>
+            <a:pPr algn="l"/>
+            <a:r>
+              <a:rPr sz="1200" b="0">
+                <a:solidFill>
+                  <a:srgbClr val="1A2238"/>
+                </a:solidFill>
+              </a:rPr>
+              <a:t>amphibole's conditional share, one fixed support (same minerals present, path deep-wet or shallow-dry):</a:t>
+            </a:r>
+          </a:p>
+        </p:txBody>
+      </p:sp>
+      <p:sp>
+        <p:nvSpPr>
+          <p:cNvPr id="6" name="Freeform 5"/>
+          <p:cNvSpPr/>
+          <p:nvPr/>
+        </p:nvSpPr>
+        <p:spPr>
+          <a:xfrm>
+            <a:off x="822960" y="2148840"/>
+            <a:ext cx="2926080" cy="1188720"/>
+          </a:xfrm>
+          <a:custGeom>
+            <a:avLst/>
+            <a:gdLst/>
+            <a:ahLst/>
+            <a:cxnLst/>
+            <a:rect l="l" t="t" r="r" b="b"/>
+            <a:pathLst>
+              <a:path w="2926080" h="1188720">
+                <a:moveTo>
+                  <a:pt x="0" y="1188720"/>
+                </a:moveTo>
+                <a:lnTo>
+                  <a:pt x="0" y="1175468"/>
+                </a:lnTo>
+                <a:lnTo>
+                  <a:pt x="60960" y="1146313"/>
+                </a:lnTo>
+                <a:lnTo>
+                  <a:pt x="121920" y="1074642"/>
+                </a:lnTo>
+                <a:lnTo>
+                  <a:pt x="182880" y="930747"/>
+                </a:lnTo>
+                <a:lnTo>
+                  <a:pt x="243840" y="698322"/>
+                </a:lnTo>
+                <a:lnTo>
+                  <a:pt x="304800" y="405067"/>
+                </a:lnTo>
+                <a:lnTo>
+                  <a:pt x="365760" y="136029"/>
+                </a:lnTo>
+                <a:lnTo>
+                  <a:pt x="426720" y="0"/>
+                </a:lnTo>
+                <a:lnTo>
+                  <a:pt x="487680" y="60327"/>
+                </a:lnTo>
+                <a:lnTo>
+                  <a:pt x="548640" y="288305"/>
+                </a:lnTo>
+                <a:lnTo>
+                  <a:pt x="609600" y="584729"/>
+                </a:lnTo>
+                <a:lnTo>
+                  <a:pt x="670560" y="848116"/>
+                </a:lnTo>
+                <a:lnTo>
+                  <a:pt x="731520" y="1027149"/>
+                </a:lnTo>
+                <a:lnTo>
+                  <a:pt x="792480" y="1123853"/>
+                </a:lnTo>
+                <a:lnTo>
+                  <a:pt x="853440" y="1165256"/>
+                </a:lnTo>
+                <a:lnTo>
+                  <a:pt x="914400" y="1176628"/>
+                </a:lnTo>
+                <a:lnTo>
+                  <a:pt x="975360" y="1170496"/>
+                </a:lnTo>
+                <a:lnTo>
+                  <a:pt x="1036320" y="1146969"/>
+                </a:lnTo>
+                <a:lnTo>
+                  <a:pt x="1097280" y="1097886"/>
+                </a:lnTo>
+                <a:lnTo>
+                  <a:pt x="1158239" y="1012517"/>
+                </a:lnTo>
+                <a:lnTo>
+                  <a:pt x="1219200" y="885597"/>
+                </a:lnTo>
+                <a:lnTo>
+                  <a:pt x="1280160" y="726470"/>
+                </a:lnTo>
+                <a:lnTo>
+                  <a:pt x="1341120" y="563869"/>
+                </a:lnTo>
+                <a:lnTo>
+                  <a:pt x="1402080" y="440005"/>
+                </a:lnTo>
+                <a:lnTo>
+                  <a:pt x="1463040" y="393483"/>
+                </a:lnTo>
+                <a:lnTo>
+                  <a:pt x="1524000" y="440005"/>
+                </a:lnTo>
+                <a:lnTo>
+                  <a:pt x="1584960" y="563869"/>
+                </a:lnTo>
+                <a:lnTo>
+                  <a:pt x="1645920" y="726470"/>
+                </a:lnTo>
+                <a:lnTo>
+                  <a:pt x="1706880" y="885598"/>
+                </a:lnTo>
+                <a:lnTo>
+                  <a:pt x="1767840" y="1012523"/>
+                </a:lnTo>
+                <a:lnTo>
+                  <a:pt x="1828800" y="1097934"/>
+                </a:lnTo>
+                <a:lnTo>
+                  <a:pt x="1889760" y="1147255"/>
+                </a:lnTo>
+                <a:lnTo>
+                  <a:pt x="1950720" y="1171932"/>
+                </a:lnTo>
+                <a:lnTo>
+                  <a:pt x="2011680" y="1182695"/>
+                </a:lnTo>
+                <a:lnTo>
+                  <a:pt x="2072640" y="1186803"/>
+                </a:lnTo>
+                <a:lnTo>
+                  <a:pt x="2133600" y="1188179"/>
+                </a:lnTo>
+                <a:lnTo>
+                  <a:pt x="2194560" y="1188584"/>
+                </a:lnTo>
+                <a:lnTo>
+                  <a:pt x="2255520" y="1188690"/>
+                </a:lnTo>
+                <a:lnTo>
+                  <a:pt x="2316480" y="1188714"/>
+                </a:lnTo>
+                <a:lnTo>
+                  <a:pt x="2377440" y="1188718"/>
+                </a:lnTo>
+                <a:lnTo>
+                  <a:pt x="2438400" y="1188719"/>
+                </a:lnTo>
+                <a:lnTo>
+                  <a:pt x="2499360" y="1188719"/>
+                </a:lnTo>
+                <a:lnTo>
+                  <a:pt x="2560320" y="1188719"/>
+                </a:lnTo>
+                <a:lnTo>
+                  <a:pt x="2621280" y="1188719"/>
+                </a:lnTo>
+                <a:lnTo>
+                  <a:pt x="2682240" y="1188719"/>
+                </a:lnTo>
+                <a:lnTo>
+                  <a:pt x="2743200" y="1188719"/>
+                </a:lnTo>
+                <a:lnTo>
+                  <a:pt x="2804160" y="1188719"/>
+                </a:lnTo>
+                <a:lnTo>
+                  <a:pt x="2865120" y="1188719"/>
+                </a:lnTo>
+                <a:lnTo>
+                  <a:pt x="2926080" y="1188719"/>
+                </a:lnTo>
+                <a:lnTo>
+                  <a:pt x="2926080" y="1188720"/>
+                </a:lnTo>
+                <a:close/>
+              </a:path>
+            </a:pathLst>
+          </a:custGeom>
+          <a:solidFill>
+            <a:srgbClr val="C3E3DF"/>
+          </a:solidFill>
+          <a:ln w="25400">
+            <a:solidFill>
+              <a:srgbClr val="2A9D8F"/>
+            </a:solidFill>
+          </a:ln>
+          <a:effectLst/>
+        </p:spPr>
+        <p:style>
+          <a:lnRef idx="1">
+            <a:schemeClr val="accent1"/>
+          </a:lnRef>
+          <a:fillRef idx="3">
+            <a:schemeClr val="accent1"/>
+          </a:fillRef>
+          <a:effectRef idx="2">
+            <a:schemeClr val="accent1"/>
+          </a:effectRef>
+          <a:fontRef idx="minor">
+            <a:schemeClr val="lt1"/>
+          </a:fontRef>
+        </p:style>
+        <p:txBody>
+          <a:bodyPr rtlCol="0" anchor="ctr"/>
+          <a:lstStyle/>
+          <a:p>
+            <a:pPr algn="ctr"/>
+          </a:p>
+        </p:txBody>
+      </p:sp>
+      <p:cxnSp>
+        <p:nvCxnSpPr>
+          <p:cNvPr id="7" name="Connector 6"/>
+          <p:cNvCxnSpPr/>
+          <p:nvPr/>
+        </p:nvCxnSpPr>
+        <p:spPr>
+          <a:xfrm>
+            <a:off x="822960" y="3337560"/>
+            <a:ext cx="2926080" cy="0"/>
+          </a:xfrm>
+          <a:prstGeom prst="bentConnector3">
+            <a:avLst/>
+          </a:prstGeom>
+          <a:ln w="12700">
+            <a:solidFill>
+              <a:srgbClr val="8A93A3"/>
+            </a:solidFill>
+          </a:ln>
+          <a:effectLst/>
+        </p:spPr>
+        <p:style>
+          <a:lnRef idx="2">
+            <a:schemeClr val="accent1"/>
+          </a:lnRef>
+          <a:fillRef idx="0">
+            <a:schemeClr val="accent1"/>
+          </a:fillRef>
+          <a:effectRef idx="1">
+            <a:schemeClr val="accent1"/>
+          </a:effectRef>
+          <a:fontRef idx="minor">
+            <a:schemeClr val="tx1"/>
+          </a:fontRef>
+        </p:style>
+      </p:cxnSp>
+      <p:sp>
+        <p:nvSpPr>
+          <p:cNvPr id="8" name="TextBox 7"/>
+          <p:cNvSpPr txBox="1"/>
+          <p:nvPr/>
+        </p:nvSpPr>
+        <p:spPr>
+          <a:xfrm>
+            <a:off x="640080" y="3383280"/>
+            <a:ext cx="3291840" cy="365760"/>
+          </a:xfrm>
+          <a:prstGeom prst="rect">
+            <a:avLst/>
+          </a:prstGeom>
+          <a:noFill/>
+        </p:spPr>
+        <p:txBody>
+          <a:bodyPr wrap="square">
+            <a:spAutoFit/>
+          </a:bodyPr>
+          <a:lstStyle/>
+          <a:p>
+            <a:pPr algn="ctr"/>
+            <a:r>
+              <a:rPr sz="1200" b="1">
+                <a:solidFill>
+                  <a:srgbClr val="1A2238"/>
+                </a:solidFill>
+              </a:rPr>
+              <a:t>truth across paths: two humps</a:t>
+            </a:r>
+          </a:p>
+        </p:txBody>
+      </p:sp>
+      <p:sp>
+        <p:nvSpPr>
+          <p:cNvPr id="9" name="Freeform 8"/>
+          <p:cNvSpPr/>
+          <p:nvPr/>
+        </p:nvSpPr>
+        <p:spPr>
+          <a:xfrm>
+            <a:off x="4617720" y="2148840"/>
+            <a:ext cx="2926080" cy="1188720"/>
+          </a:xfrm>
+          <a:custGeom>
+            <a:avLst/>
+            <a:gdLst/>
+            <a:ahLst/>
+            <a:cxnLst/>
+            <a:rect l="l" t="t" r="r" b="b"/>
+            <a:pathLst>
+              <a:path w="2926080" h="1188720">
+                <a:moveTo>
+                  <a:pt x="0" y="1188720"/>
+                </a:moveTo>
+                <a:lnTo>
+                  <a:pt x="0" y="1005295"/>
+                </a:lnTo>
+                <a:lnTo>
+                  <a:pt x="60960" y="951098"/>
+                </a:lnTo>
+                <a:lnTo>
+                  <a:pt x="121920" y="886769"/>
+                </a:lnTo>
+                <a:lnTo>
+                  <a:pt x="182880" y="812356"/>
+                </a:lnTo>
+                <a:lnTo>
+                  <a:pt x="243840" y="728567"/>
+                </a:lnTo>
+                <a:lnTo>
+                  <a:pt x="304800" y="636872"/>
+                </a:lnTo>
+                <a:lnTo>
+                  <a:pt x="365760" y="539550"/>
+                </a:lnTo>
+                <a:lnTo>
+                  <a:pt x="426720" y="439654"/>
+                </a:lnTo>
+                <a:lnTo>
+                  <a:pt x="487680" y="340899"/>
+                </a:lnTo>
+                <a:lnTo>
+                  <a:pt x="548640" y="247457"/>
+                </a:lnTo>
+                <a:lnTo>
+                  <a:pt x="609600" y="163682"/>
+                </a:lnTo>
+                <a:lnTo>
+                  <a:pt x="670560" y="93778"/>
+                </a:lnTo>
+                <a:lnTo>
+                  <a:pt x="731520" y="41452"/>
+                </a:lnTo>
+                <a:lnTo>
+                  <a:pt x="792479" y="9591"/>
+                </a:lnTo>
+                <a:lnTo>
+                  <a:pt x="853440" y="0"/>
+                </a:lnTo>
+                <a:lnTo>
+                  <a:pt x="914400" y="13225"/>
+                </a:lnTo>
+                <a:lnTo>
+                  <a:pt x="975360" y="48512"/>
+                </a:lnTo>
+                <a:lnTo>
+                  <a:pt x="1036320" y="103869"/>
+                </a:lnTo>
+                <a:lnTo>
+                  <a:pt x="1097280" y="176259"/>
+                </a:lnTo>
+                <a:lnTo>
+                  <a:pt x="1158240" y="261871"/>
+                </a:lnTo>
+                <a:lnTo>
+                  <a:pt x="1219200" y="356455"/>
+                </a:lnTo>
+                <a:lnTo>
+                  <a:pt x="1280160" y="455664"/>
+                </a:lnTo>
+                <a:lnTo>
+                  <a:pt x="1341120" y="555382"/>
+                </a:lnTo>
+                <a:lnTo>
+                  <a:pt x="1402080" y="651990"/>
+                </a:lnTo>
+                <a:lnTo>
+                  <a:pt x="1463040" y="742552"/>
+                </a:lnTo>
+                <a:lnTo>
+                  <a:pt x="1524000" y="824919"/>
+                </a:lnTo>
+                <a:lnTo>
+                  <a:pt x="1584960" y="897748"/>
+                </a:lnTo>
+                <a:lnTo>
+                  <a:pt x="1645920" y="960444"/>
+                </a:lnTo>
+                <a:lnTo>
+                  <a:pt x="1706880" y="1013052"/>
+                </a:lnTo>
+                <a:lnTo>
+                  <a:pt x="1767840" y="1056118"/>
+                </a:lnTo>
+                <a:lnTo>
+                  <a:pt x="1828800" y="1090539"/>
+                </a:lnTo>
+                <a:lnTo>
+                  <a:pt x="1889760" y="1117414"/>
+                </a:lnTo>
+                <a:lnTo>
+                  <a:pt x="1950720" y="1137922"/>
+                </a:lnTo>
+                <a:lnTo>
+                  <a:pt x="2011680" y="1153223"/>
+                </a:lnTo>
+                <a:lnTo>
+                  <a:pt x="2072640" y="1164389"/>
+                </a:lnTo>
+                <a:lnTo>
+                  <a:pt x="2133600" y="1172361"/>
+                </a:lnTo>
+                <a:lnTo>
+                  <a:pt x="2194560" y="1177931"/>
+                </a:lnTo>
+                <a:lnTo>
+                  <a:pt x="2255520" y="1181741"/>
+                </a:lnTo>
+                <a:lnTo>
+                  <a:pt x="2316480" y="1184291"/>
+                </a:lnTo>
+                <a:lnTo>
+                  <a:pt x="2377440" y="1185963"/>
+                </a:lnTo>
+                <a:lnTo>
+                  <a:pt x="2438400" y="1187037"/>
+                </a:lnTo>
+                <a:lnTo>
+                  <a:pt x="2499360" y="1187712"/>
+                </a:lnTo>
+                <a:lnTo>
+                  <a:pt x="2560320" y="1188128"/>
+                </a:lnTo>
+                <a:lnTo>
+                  <a:pt x="2621280" y="1188378"/>
+                </a:lnTo>
+                <a:lnTo>
+                  <a:pt x="2682240" y="1188527"/>
+                </a:lnTo>
+                <a:lnTo>
+                  <a:pt x="2743200" y="1188613"/>
+                </a:lnTo>
+                <a:lnTo>
+                  <a:pt x="2804160" y="1188661"/>
+                </a:lnTo>
+                <a:lnTo>
+                  <a:pt x="2865120" y="1188688"/>
+                </a:lnTo>
+                <a:lnTo>
+                  <a:pt x="2926080" y="1188703"/>
+                </a:lnTo>
+                <a:lnTo>
+                  <a:pt x="2926080" y="1188720"/>
+                </a:lnTo>
+                <a:close/>
+              </a:path>
+            </a:pathLst>
+          </a:custGeom>
+          <a:solidFill>
+            <a:srgbClr val="EDC7C3"/>
+          </a:solidFill>
+          <a:ln w="25400">
+            <a:solidFill>
+              <a:srgbClr val="C0392B"/>
+            </a:solidFill>
+          </a:ln>
+          <a:effectLst/>
+        </p:spPr>
+        <p:style>
+          <a:lnRef idx="1">
+            <a:schemeClr val="accent1"/>
+          </a:lnRef>
+          <a:fillRef idx="3">
+            <a:schemeClr val="accent1"/>
+          </a:fillRef>
+          <a:effectRef idx="2">
+            <a:schemeClr val="accent1"/>
+          </a:effectRef>
+          <a:fontRef idx="minor">
+            <a:schemeClr val="lt1"/>
+          </a:fontRef>
+        </p:style>
+        <p:txBody>
+          <a:bodyPr rtlCol="0" anchor="ctr"/>
+          <a:lstStyle/>
+          <a:p>
+            <a:pPr algn="ctr"/>
+          </a:p>
+        </p:txBody>
+      </p:sp>
+      <p:cxnSp>
+        <p:nvCxnSpPr>
+          <p:cNvPr id="10" name="Connector 9"/>
+          <p:cNvCxnSpPr/>
+          <p:nvPr/>
+        </p:nvCxnSpPr>
+        <p:spPr>
+          <a:xfrm>
+            <a:off x="4617720" y="3337560"/>
+            <a:ext cx="2926080" cy="0"/>
+          </a:xfrm>
+          <a:prstGeom prst="bentConnector3">
+            <a:avLst/>
+          </a:prstGeom>
+          <a:ln w="12700">
+            <a:solidFill>
+              <a:srgbClr val="8A93A3"/>
+            </a:solidFill>
+          </a:ln>
+          <a:effectLst/>
+        </p:spPr>
+        <p:style>
+          <a:lnRef idx="2">
+            <a:schemeClr val="accent1"/>
+          </a:lnRef>
+          <a:fillRef idx="0">
+            <a:schemeClr val="accent1"/>
+          </a:fillRef>
+          <a:effectRef idx="1">
+            <a:schemeClr val="accent1"/>
+          </a:effectRef>
+          <a:fontRef idx="minor">
+            <a:schemeClr val="tx1"/>
+          </a:fontRef>
+        </p:style>
+      </p:cxnSp>
+      <p:sp>
+        <p:nvSpPr>
+          <p:cNvPr id="11" name="TextBox 10"/>
+          <p:cNvSpPr txBox="1"/>
+          <p:nvPr/>
+        </p:nvSpPr>
+        <p:spPr>
+          <a:xfrm>
+            <a:off x="4434840" y="3383280"/>
+            <a:ext cx="3291840" cy="365760"/>
+          </a:xfrm>
+          <a:prstGeom prst="rect">
+            <a:avLst/>
+          </a:prstGeom>
+          <a:noFill/>
+        </p:spPr>
+        <p:txBody>
+          <a:bodyPr wrap="square">
+            <a:spAutoFit/>
+          </a:bodyPr>
+          <a:lstStyle/>
+          <a:p>
+            <a:pPr algn="ctr"/>
+            <a:r>
+              <a:rPr sz="1200" b="1">
+                <a:solidFill>
+                  <a:srgbClr val="1A2238"/>
+                </a:solidFill>
+              </a:rPr>
+              <a:t>current: one Dirichlet -- mean in the valley</a:t>
+            </a:r>
+          </a:p>
+        </p:txBody>
+      </p:sp>
+      <p:sp>
+        <p:nvSpPr>
+          <p:cNvPr id="12" name="Freeform 11"/>
+          <p:cNvSpPr/>
+          <p:nvPr/>
+        </p:nvSpPr>
+        <p:spPr>
+          <a:xfrm>
+            <a:off x="8412480" y="2148840"/>
+            <a:ext cx="2926079" cy="1188720"/>
+          </a:xfrm>
+          <a:custGeom>
+            <a:avLst/>
+            <a:gdLst/>
+            <a:ahLst/>
+            <a:cxnLst/>
+            <a:rect l="l" t="t" r="r" b="b"/>
+            <a:pathLst>
+              <a:path w="2926079" h="1188720">
+                <a:moveTo>
+                  <a:pt x="0" y="1188720"/>
+                </a:moveTo>
+                <a:lnTo>
+                  <a:pt x="0" y="1159801"/>
+                </a:lnTo>
+                <a:lnTo>
+                  <a:pt x="60960" y="1113093"/>
+                </a:lnTo>
+                <a:lnTo>
+                  <a:pt x="121919" y="1017380"/>
+                </a:lnTo>
+                <a:lnTo>
+                  <a:pt x="182879" y="852419"/>
+                </a:lnTo>
+                <a:lnTo>
+                  <a:pt x="243840" y="616866"/>
+                </a:lnTo>
+                <a:lnTo>
+                  <a:pt x="304800" y="346299"/>
+                </a:lnTo>
+                <a:lnTo>
+                  <a:pt x="365760" y="113590"/>
+                </a:lnTo>
+                <a:lnTo>
+                  <a:pt x="426720" y="0"/>
+                </a:lnTo>
+                <a:lnTo>
+                  <a:pt x="487680" y="50080"/>
+                </a:lnTo>
+                <a:lnTo>
+                  <a:pt x="548639" y="243826"/>
+                </a:lnTo>
+                <a:lnTo>
+                  <a:pt x="609599" y="509388"/>
+                </a:lnTo>
+                <a:lnTo>
+                  <a:pt x="670560" y="765499"/>
+                </a:lnTo>
+                <a:lnTo>
+                  <a:pt x="731520" y="959944"/>
+                </a:lnTo>
+                <a:lnTo>
+                  <a:pt x="792480" y="1080416"/>
+                </a:lnTo>
+                <a:lnTo>
+                  <a:pt x="853440" y="1140830"/>
+                </a:lnTo>
+                <a:lnTo>
+                  <a:pt x="914400" y="1161159"/>
+                </a:lnTo>
+                <a:lnTo>
+                  <a:pt x="975360" y="1154423"/>
+                </a:lnTo>
+                <a:lnTo>
+                  <a:pt x="1036319" y="1123358"/>
+                </a:lnTo>
+                <a:lnTo>
+                  <a:pt x="1097279" y="1063366"/>
+                </a:lnTo>
+                <a:lnTo>
+                  <a:pt x="1158239" y="968598"/>
+                </a:lnTo>
+                <a:lnTo>
+                  <a:pt x="1219200" y="839313"/>
+                </a:lnTo>
+                <a:lnTo>
+                  <a:pt x="1280160" y="688143"/>
+                </a:lnTo>
+                <a:lnTo>
+                  <a:pt x="1341120" y="541568"/>
+                </a:lnTo>
+                <a:lnTo>
+                  <a:pt x="1402080" y="433754"/>
+                </a:lnTo>
+                <a:lnTo>
+                  <a:pt x="1463039" y="393962"/>
+                </a:lnTo>
+                <a:lnTo>
+                  <a:pt x="1524000" y="433754"/>
+                </a:lnTo>
+                <a:lnTo>
+                  <a:pt x="1584960" y="541568"/>
+                </a:lnTo>
+                <a:lnTo>
+                  <a:pt x="1645920" y="688144"/>
+                </a:lnTo>
+                <a:lnTo>
+                  <a:pt x="1706880" y="839322"/>
+                </a:lnTo>
+                <a:lnTo>
+                  <a:pt x="1767840" y="968653"/>
+                </a:lnTo>
+                <a:lnTo>
+                  <a:pt x="1828800" y="1063643"/>
+                </a:lnTo>
+                <a:lnTo>
+                  <a:pt x="1889760" y="1124572"/>
+                </a:lnTo>
+                <a:lnTo>
+                  <a:pt x="1950719" y="1159032"/>
+                </a:lnTo>
+                <a:lnTo>
+                  <a:pt x="2011679" y="1176322"/>
+                </a:lnTo>
+                <a:lnTo>
+                  <a:pt x="2072640" y="1184047"/>
+                </a:lnTo>
+                <a:lnTo>
+                  <a:pt x="2133600" y="1187131"/>
+                </a:lnTo>
+                <a:lnTo>
+                  <a:pt x="2194560" y="1188232"/>
+                </a:lnTo>
+                <a:lnTo>
+                  <a:pt x="2255520" y="1188585"/>
+                </a:lnTo>
+                <a:lnTo>
+                  <a:pt x="2316480" y="1188686"/>
+                </a:lnTo>
+                <a:lnTo>
+                  <a:pt x="2377439" y="1188712"/>
+                </a:lnTo>
+                <a:lnTo>
+                  <a:pt x="2438400" y="1188718"/>
+                </a:lnTo>
+                <a:lnTo>
+                  <a:pt x="2499360" y="1188719"/>
+                </a:lnTo>
+                <a:lnTo>
+                  <a:pt x="2560320" y="1188719"/>
+                </a:lnTo>
+                <a:lnTo>
+                  <a:pt x="2621280" y="1188719"/>
+                </a:lnTo>
+                <a:lnTo>
+                  <a:pt x="2682240" y="1188719"/>
+                </a:lnTo>
+                <a:lnTo>
+                  <a:pt x="2743200" y="1188719"/>
+                </a:lnTo>
+                <a:lnTo>
+                  <a:pt x="2804160" y="1188719"/>
+                </a:lnTo>
+                <a:lnTo>
+                  <a:pt x="2865119" y="1188719"/>
+                </a:lnTo>
+                <a:lnTo>
+                  <a:pt x="2926079" y="1188719"/>
+                </a:lnTo>
+                <a:lnTo>
+                  <a:pt x="2926079" y="1188720"/>
+                </a:lnTo>
+                <a:close/>
+              </a:path>
+            </a:pathLst>
+          </a:custGeom>
+          <a:solidFill>
+            <a:srgbClr val="F8DDC7"/>
+          </a:solidFill>
+          <a:ln w="25400">
+            <a:solidFill>
+              <a:srgbClr val="E8883A"/>
+            </a:solidFill>
+          </a:ln>
+          <a:effectLst/>
+        </p:spPr>
+        <p:style>
+          <a:lnRef idx="1">
+            <a:schemeClr val="accent1"/>
+          </a:lnRef>
+          <a:fillRef idx="3">
+            <a:schemeClr val="accent1"/>
+          </a:fillRef>
+          <a:effectRef idx="2">
+            <a:schemeClr val="accent1"/>
+          </a:effectRef>
+          <a:fontRef idx="minor">
+            <a:schemeClr val="lt1"/>
+          </a:fontRef>
+        </p:style>
+        <p:txBody>
+          <a:bodyPr rtlCol="0" anchor="ctr"/>
+          <a:lstStyle/>
+          <a:p>
+            <a:pPr algn="ctr"/>
+          </a:p>
+        </p:txBody>
+      </p:sp>
+      <p:cxnSp>
+        <p:nvCxnSpPr>
+          <p:cNvPr id="13" name="Connector 12"/>
+          <p:cNvCxnSpPr/>
+          <p:nvPr/>
+        </p:nvCxnSpPr>
+        <p:spPr>
+          <a:xfrm>
+            <a:off x="8412480" y="3337560"/>
+            <a:ext cx="2926079" cy="0"/>
+          </a:xfrm>
+          <a:prstGeom prst="bentConnector3">
+            <a:avLst/>
+          </a:prstGeom>
+          <a:ln w="12700">
+            <a:solidFill>
+              <a:srgbClr val="8A93A3"/>
+            </a:solidFill>
+          </a:ln>
+          <a:effectLst/>
+        </p:spPr>
+        <p:style>
+          <a:lnRef idx="2">
+            <a:schemeClr val="accent1"/>
+          </a:lnRef>
+          <a:fillRef idx="0">
+            <a:schemeClr val="accent1"/>
+          </a:fillRef>
+          <a:effectRef idx="1">
+            <a:schemeClr val="accent1"/>
+          </a:effectRef>
+          <a:fontRef idx="minor">
+            <a:schemeClr val="tx1"/>
+          </a:fontRef>
+        </p:style>
+      </p:cxnSp>
+      <p:sp>
+        <p:nvSpPr>
+          <p:cNvPr id="14" name="TextBox 13"/>
+          <p:cNvSpPr txBox="1"/>
+          <p:nvPr/>
+        </p:nvSpPr>
+        <p:spPr>
+          <a:xfrm>
+            <a:off x="8229600" y="3383280"/>
+            <a:ext cx="3291840" cy="365760"/>
+          </a:xfrm>
+          <a:prstGeom prst="rect">
+            <a:avLst/>
+          </a:prstGeom>
+          <a:noFill/>
+        </p:spPr>
+        <p:txBody>
+          <a:bodyPr wrap="square">
+            <a:spAutoFit/>
+          </a:bodyPr>
+          <a:lstStyle/>
+          <a:p>
+            <a:pPr algn="ctr"/>
+            <a:r>
+              <a:rPr sz="1200" b="1">
+                <a:solidFill>
+                  <a:srgbClr val="1A2238"/>
+                </a:solidFill>
+              </a:rPr>
+              <a:t>proposed: K=2 -- mass on the humps</a:t>
+            </a:r>
+          </a:p>
+        </p:txBody>
+      </p:sp>
+      <p:sp>
+        <p:nvSpPr>
+          <p:cNvPr id="15" name="Rounded Rectangle 14"/>
+          <p:cNvSpPr/>
+          <p:nvPr/>
+        </p:nvSpPr>
+        <p:spPr>
+          <a:xfrm>
+            <a:off x="822960" y="4114800"/>
+            <a:ext cx="3291840" cy="1371600"/>
+          </a:xfrm>
+          <a:prstGeom prst="roundRect">
+            <a:avLst/>
+          </a:prstGeom>
+          <a:solidFill>
+            <a:srgbClr val="EAE8FB"/>
+          </a:solidFill>
+          <a:ln w="25400">
+            <a:solidFill>
+              <a:srgbClr val="6C5CE7"/>
+            </a:solidFill>
+          </a:ln>
+          <a:effectLst/>
+        </p:spPr>
+        <p:style>
+          <a:lnRef idx="1">
+            <a:schemeClr val="accent1"/>
+          </a:lnRef>
+          <a:fillRef idx="3">
+            <a:schemeClr val="accent1"/>
+          </a:fillRef>
+          <a:effectRef idx="2">
+            <a:schemeClr val="accent1"/>
+          </a:effectRef>
+          <a:fontRef idx="minor">
+            <a:schemeClr val="lt1"/>
+          </a:fontRef>
+        </p:style>
+        <p:txBody>
+          <a:bodyPr rtlCol="0" anchor="ctr" wrap="square"/>
+          <a:lstStyle/>
+          <a:p>
+            <a:pPr algn="ctr"/>
+            <a:r>
+              <a:rPr sz="1200" b="1">
+                <a:solidFill>
+                  <a:srgbClr val="1A2238"/>
+                </a:solidFill>
+              </a:rPr>
+              <a:t>gate (the new piece)</a:t>
+            </a:r>
+          </a:p>
+          <a:p>
+            <a:pPr algn="ctr"/>
+            <a:r>
+              <a:rPr sz="900" b="0">
+                <a:solidFill>
+                  <a:srgbClr val="8A93A3"/>
+                </a:solidFill>
+              </a:rPr>
+              <a:t>w = [0.60, 0.40] for this rock</a:t>
+            </a:r>
+          </a:p>
+          <a:p>
+            <a:pPr algn="ctr"/>
+            <a:r>
+              <a:rPr sz="900" b="0">
+                <a:solidFill>
+                  <a:srgbClr val="8A93A3"/>
+                </a:solidFill>
+              </a:rPr>
+              <a:t>softmax over 2 logits from the</a:t>
+            </a:r>
+          </a:p>
+          <a:p>
+            <a:pPr algn="ctr"/>
+            <a:r>
+              <a:rPr sz="900" b="0">
+                <a:solidFill>
+                  <a:srgbClr val="8A93A3"/>
+                </a:solidFill>
+              </a:rPr>
+              <a:t>magnitude trunk on [h, support]</a:t>
+            </a:r>
+          </a:p>
+          <a:p>
+            <a:pPr algn="ctr"/>
+            <a:r>
+              <a:rPr sz="900" b="0">
+                <a:solidFill>
+                  <a:srgbClr val="8A93A3"/>
+                </a:solidFill>
+              </a:rPr>
+              <a:t>H(w) -&gt; 0 = commits to one answer</a:t>
+            </a:r>
+          </a:p>
+        </p:txBody>
+      </p:sp>
+      <p:sp>
+        <p:nvSpPr>
+          <p:cNvPr id="16" name="Freeform 15"/>
+          <p:cNvSpPr/>
+          <p:nvPr/>
+        </p:nvSpPr>
+        <p:spPr>
+          <a:xfrm>
+            <a:off x="4617720" y="4434840"/>
+            <a:ext cx="2926080" cy="1005839"/>
+          </a:xfrm>
+          <a:custGeom>
+            <a:avLst/>
+            <a:gdLst/>
+            <a:ahLst/>
+            <a:cxnLst/>
+            <a:rect l="l" t="t" r="r" b="b"/>
+            <a:pathLst>
+              <a:path w="2926080" h="1005839">
+                <a:moveTo>
+                  <a:pt x="0" y="1005839"/>
+                </a:moveTo>
+                <a:lnTo>
+                  <a:pt x="0" y="1005838"/>
+                </a:lnTo>
+                <a:lnTo>
+                  <a:pt x="60960" y="1005836"/>
+                </a:lnTo>
+                <a:lnTo>
+                  <a:pt x="121920" y="1005827"/>
+                </a:lnTo>
+                <a:lnTo>
+                  <a:pt x="182880" y="1005804"/>
+                </a:lnTo>
+                <a:lnTo>
+                  <a:pt x="243840" y="1005740"/>
+                </a:lnTo>
+                <a:lnTo>
+                  <a:pt x="304800" y="1005578"/>
+                </a:lnTo>
+                <a:lnTo>
+                  <a:pt x="365760" y="1005188"/>
+                </a:lnTo>
+                <a:lnTo>
+                  <a:pt x="426720" y="1004299"/>
+                </a:lnTo>
+                <a:lnTo>
+                  <a:pt x="487680" y="1002387"/>
+                </a:lnTo>
+                <a:lnTo>
+                  <a:pt x="548640" y="998506"/>
+                </a:lnTo>
+                <a:lnTo>
+                  <a:pt x="609600" y="991075"/>
+                </a:lnTo>
+                <a:lnTo>
+                  <a:pt x="670560" y="977663"/>
+                </a:lnTo>
+                <a:lnTo>
+                  <a:pt x="731520" y="954876"/>
+                </a:lnTo>
+                <a:lnTo>
+                  <a:pt x="792479" y="918469"/>
+                </a:lnTo>
+                <a:lnTo>
+                  <a:pt x="853440" y="863867"/>
+                </a:lnTo>
+                <a:lnTo>
+                  <a:pt x="914400" y="787180"/>
+                </a:lnTo>
+                <a:lnTo>
+                  <a:pt x="975360" y="686640"/>
+                </a:lnTo>
+                <a:lnTo>
+                  <a:pt x="1036320" y="564183"/>
+                </a:lnTo>
+                <a:lnTo>
+                  <a:pt x="1097280" y="426629"/>
+                </a:lnTo>
+                <a:lnTo>
+                  <a:pt x="1158240" y="285865"/>
+                </a:lnTo>
+                <a:lnTo>
+                  <a:pt x="1219200" y="157584"/>
+                </a:lnTo>
+                <a:lnTo>
+                  <a:pt x="1280160" y="58588"/>
+                </a:lnTo>
+                <a:lnTo>
+                  <a:pt x="1341120" y="3228"/>
+                </a:lnTo>
+                <a:lnTo>
+                  <a:pt x="1402080" y="0"/>
+                </a:lnTo>
+                <a:lnTo>
+                  <a:pt x="1463040" y="49408"/>
+                </a:lnTo>
+                <a:lnTo>
+                  <a:pt x="1524000" y="143838"/>
+                </a:lnTo>
+                <a:lnTo>
+                  <a:pt x="1584960" y="269478"/>
+                </a:lnTo>
+                <a:lnTo>
+                  <a:pt x="1645920" y="409624"/>
+                </a:lnTo>
+                <a:lnTo>
+                  <a:pt x="1706880" y="548284"/>
+                </a:lnTo>
+                <a:lnTo>
+                  <a:pt x="1767840" y="673016"/>
+                </a:lnTo>
+                <a:lnTo>
+                  <a:pt x="1828800" y="776377"/>
+                </a:lnTo>
+                <a:lnTo>
+                  <a:pt x="1889760" y="855892"/>
+                </a:lnTo>
+                <a:lnTo>
+                  <a:pt x="1950720" y="912965"/>
+                </a:lnTo>
+                <a:lnTo>
+                  <a:pt x="2011680" y="951316"/>
+                </a:lnTo>
+                <a:lnTo>
+                  <a:pt x="2072640" y="975501"/>
+                </a:lnTo>
+                <a:lnTo>
+                  <a:pt x="2133600" y="989839"/>
+                </a:lnTo>
+                <a:lnTo>
+                  <a:pt x="2194560" y="997841"/>
+                </a:lnTo>
+                <a:lnTo>
+                  <a:pt x="2255520" y="1002050"/>
+                </a:lnTo>
+                <a:lnTo>
+                  <a:pt x="2316480" y="1004138"/>
+                </a:lnTo>
+                <a:lnTo>
+                  <a:pt x="2377440" y="1005115"/>
+                </a:lnTo>
+                <a:lnTo>
+                  <a:pt x="2438400" y="1005547"/>
+                </a:lnTo>
+                <a:lnTo>
+                  <a:pt x="2499360" y="1005728"/>
+                </a:lnTo>
+                <a:lnTo>
+                  <a:pt x="2560320" y="1005799"/>
+                </a:lnTo>
+                <a:lnTo>
+                  <a:pt x="2621280" y="1005826"/>
+                </a:lnTo>
+                <a:lnTo>
+                  <a:pt x="2682240" y="1005835"/>
+                </a:lnTo>
+                <a:lnTo>
+                  <a:pt x="2743200" y="1005838"/>
+                </a:lnTo>
+                <a:lnTo>
+                  <a:pt x="2804160" y="1005839"/>
+                </a:lnTo>
+                <a:lnTo>
+                  <a:pt x="2865120" y="1005839"/>
+                </a:lnTo>
+                <a:lnTo>
+                  <a:pt x="2926080" y="1005839"/>
+                </a:lnTo>
+                <a:lnTo>
+                  <a:pt x="2926080" y="1005839"/>
+                </a:lnTo>
+                <a:close/>
+              </a:path>
+            </a:pathLst>
+          </a:custGeom>
+          <a:solidFill>
+            <a:srgbClr val="BCEAE5"/>
+          </a:solidFill>
+          <a:ln w="25400">
+            <a:solidFill>
+              <a:srgbClr val="12B5A5"/>
+            </a:solidFill>
+          </a:ln>
+          <a:effectLst/>
+        </p:spPr>
+        <p:style>
+          <a:lnRef idx="1">
+            <a:schemeClr val="accent1"/>
+          </a:lnRef>
+          <a:fillRef idx="3">
+            <a:schemeClr val="accent1"/>
+          </a:fillRef>
+          <a:effectRef idx="2">
+            <a:schemeClr val="accent1"/>
+          </a:effectRef>
+          <a:fontRef idx="minor">
+            <a:schemeClr val="lt1"/>
+          </a:fontRef>
+        </p:style>
+        <p:txBody>
+          <a:bodyPr rtlCol="0" anchor="ctr"/>
+          <a:lstStyle/>
+          <a:p>
+            <a:pPr algn="ctr"/>
+          </a:p>
+        </p:txBody>
+      </p:sp>
+      <p:cxnSp>
+        <p:nvCxnSpPr>
+          <p:cNvPr id="17" name="Connector 16"/>
+          <p:cNvCxnSpPr/>
+          <p:nvPr/>
+        </p:nvCxnSpPr>
+        <p:spPr>
+          <a:xfrm>
+            <a:off x="4617720" y="5440679"/>
+            <a:ext cx="2926080" cy="0"/>
+          </a:xfrm>
+          <a:prstGeom prst="bentConnector3">
+            <a:avLst/>
+          </a:prstGeom>
+          <a:ln w="12700">
+            <a:solidFill>
+              <a:srgbClr val="8A93A3"/>
+            </a:solidFill>
+          </a:ln>
+          <a:effectLst/>
+        </p:spPr>
+        <p:style>
+          <a:lnRef idx="2">
+            <a:schemeClr val="accent1"/>
+          </a:lnRef>
+          <a:fillRef idx="0">
+            <a:schemeClr val="accent1"/>
+          </a:fillRef>
+          <a:effectRef idx="1">
+            <a:schemeClr val="accent1"/>
+          </a:effectRef>
+          <a:fontRef idx="minor">
+            <a:schemeClr val="tx1"/>
+          </a:fontRef>
+        </p:style>
+      </p:cxnSp>
+      <p:sp>
+        <p:nvSpPr>
+          <p:cNvPr id="18" name="TextBox 17"/>
+          <p:cNvSpPr txBox="1"/>
+          <p:nvPr/>
+        </p:nvSpPr>
+        <p:spPr>
+          <a:xfrm>
+            <a:off x="4434840" y="5486399"/>
+            <a:ext cx="3291840" cy="365760"/>
+          </a:xfrm>
+          <a:prstGeom prst="rect">
+            <a:avLst/>
+          </a:prstGeom>
+          <a:noFill/>
+        </p:spPr>
+        <p:txBody>
+          <a:bodyPr wrap="square">
+            <a:spAutoFit/>
+          </a:bodyPr>
+          <a:lstStyle/>
+          <a:p>
+            <a:pPr algn="ctr"/>
+            <a:r>
+              <a:rPr sz="1200" b="1">
+                <a:solidFill>
+                  <a:srgbClr val="1A2238"/>
+                </a:solidFill>
+              </a:rPr>
+              <a:t>plag: components coincide -- unimodal phases unchanged</a:t>
+            </a:r>
+          </a:p>
+        </p:txBody>
+      </p:sp>
+      <p:sp>
+        <p:nvSpPr>
+          <p:cNvPr id="19" name="Rounded Rectangle 18"/>
+          <p:cNvSpPr/>
+          <p:nvPr/>
+        </p:nvSpPr>
+        <p:spPr>
+          <a:xfrm>
+            <a:off x="8229600" y="4114800"/>
+            <a:ext cx="3383280" cy="1371600"/>
+          </a:xfrm>
+          <a:prstGeom prst="roundRect">
+            <a:avLst/>
+          </a:prstGeom>
+          <a:solidFill>
+            <a:srgbClr val="E1F1EF"/>
+          </a:solidFill>
+          <a:ln w="25400">
+            <a:solidFill>
+              <a:srgbClr val="2A9D8F"/>
+            </a:solidFill>
+          </a:ln>
+          <a:effectLst/>
+        </p:spPr>
+        <p:style>
+          <a:lnRef idx="1">
+            <a:schemeClr val="accent1"/>
+          </a:lnRef>
+          <a:fillRef idx="3">
+            <a:schemeClr val="accent1"/>
+          </a:fillRef>
+          <a:effectRef idx="2">
+            <a:schemeClr val="accent1"/>
+          </a:effectRef>
+          <a:fontRef idx="minor">
+            <a:schemeClr val="lt1"/>
+          </a:fontRef>
+        </p:style>
+        <p:txBody>
+          <a:bodyPr rtlCol="0" anchor="ctr" wrap="square"/>
+          <a:lstStyle/>
+          <a:p>
+            <a:pPr algn="ctr"/>
+            <a:r>
+              <a:rPr sz="1200" b="1">
+                <a:solidFill>
+                  <a:srgbClr val="1A2238"/>
+                </a:solidFill>
+              </a:rPr>
+              <a:t>scenario view gains one field</a:t>
+            </a:r>
+          </a:p>
+          <a:p>
+            <a:pPr algn="ctr"/>
+            <a:r>
+              <a:rPr sz="900" b="0">
+                <a:solidFill>
+                  <a:srgbClr val="8A93A3"/>
+                </a:solidFill>
+              </a:rPr>
+              <a:t>a sample = support -&gt; component</a:t>
+            </a:r>
+          </a:p>
+          <a:p>
+            <a:pPr algn="ctr"/>
+            <a:r>
+              <a:rPr sz="900" b="0">
+                <a:solidFill>
+                  <a:srgbClr val="8A93A3"/>
+                </a:solidFill>
+              </a:rPr>
+              <a:t>-&gt; abundances; each scenario now</a:t>
+            </a:r>
+          </a:p>
+          <a:p>
+            <a:pPr algn="ctr"/>
+            <a:r>
+              <a:rPr sz="900" b="0">
+                <a:solidFill>
+                  <a:srgbClr val="8A93A3"/>
+                </a:solidFill>
+              </a:rPr>
+              <a:t>commits to a hump instead of</a:t>
+            </a:r>
+          </a:p>
+          <a:p>
+            <a:pPr algn="ctr"/>
+            <a:r>
+              <a:rPr sz="900" b="0">
+                <a:solidFill>
+                  <a:srgbClr val="8A93A3"/>
+                </a:solidFill>
+              </a:rPr>
+              <a:t>predicting the valley</a:t>
+            </a:r>
+          </a:p>
+        </p:txBody>
+      </p:sp>
+      <p:sp>
+        <p:nvSpPr>
+          <p:cNvPr id="20" name="TextBox 19"/>
+          <p:cNvSpPr txBox="1"/>
+          <p:nvPr/>
+        </p:nvSpPr>
+        <p:spPr>
+          <a:xfrm>
+            <a:off x="502920" y="5715000"/>
+            <a:ext cx="11155680" cy="731520"/>
+          </a:xfrm>
+          <a:prstGeom prst="rect">
+            <a:avLst/>
+          </a:prstGeom>
+          <a:noFill/>
+        </p:spPr>
+        <p:txBody>
+          <a:bodyPr wrap="square">
+            <a:spAutoFit/>
+          </a:bodyPr>
+          <a:lstStyle/>
+          <a:p>
+            <a:pPr algn="l"/>
+            <a:r>
+              <a:rPr sz="1100" b="0">
+                <a:solidFill>
+                  <a:srgbClr val="1A2238"/>
+                </a:solidFill>
+              </a:rPr>
+              <a:t>unchanged: presence branch, CompHead, CondHead, closure. K=1 is the current head exactly (same parameters, same loss), so production checkpoints load untouched and the drop path is one deleted code branch.</a:t>
+            </a:r>
+          </a:p>
+        </p:txBody>
+      </p:sp>
+      <p:sp>
+        <p:nvSpPr>
+          <p:cNvPr id="21" name="TextBox 20"/>
+          <p:cNvSpPr txBox="1"/>
+          <p:nvPr/>
+        </p:nvSpPr>
+        <p:spPr>
+          <a:xfrm>
+            <a:off x="502920" y="6309360"/>
+            <a:ext cx="11155680" cy="731520"/>
+          </a:xfrm>
+          <a:prstGeom prst="rect">
+            <a:avLst/>
+          </a:prstGeom>
+          <a:noFill/>
+        </p:spPr>
+        <p:txBody>
+          <a:bodyPr wrap="square">
+            <a:spAutoFit/>
+          </a:bodyPr>
+          <a:lstStyle/>
+          <a:p>
+            <a:pPr algn="l"/>
+            <a:r>
+              <a:rPr sz="1000" b="0">
+                <a:solidFill>
+                  <a:srgbClr val="8A93A3"/>
+                </a:solidFill>
+              </a:rPr>
+              <a:t>kept only if better on real rocks: recalibrated val paired NLL vs the same-dials single-Dirichlet control; PIT/coverage break an NLL tie. distribution numbers illustrative.</a:t>
             </a:r>
           </a:p>
         </p:txBody>

</xml_diff>

<commit_message>
mixture verdict: kept as a dial, K=1 stays canonical -- trained K=2 wins the corpus on both axes (amp two-sided PIT 0.120 -> 0.023) but leans against the K=1 control on recalibrated real-rock val (-0.365 [-0.864, +0.118], all magnitude); attribution measured: instrument   passes 61% of the gap, real amp population is one-humped at matched chemistry with the corpus's full width (the second hump is the broad (P,H2O) prior's), one gate-offset recalibration parameter recovers ~60% to a tie, never a win; journal x2, roadmap step-2 closed / step-3 active, deck   slide re-kickered with the verdict; contrast matrix now supportmag/tuned/mixture (prior version in git history)
</commit_message>
<xml_diff>
--- a/slides/overview.pptx
+++ b/slides/overview.pptx
@@ -1574,7 +1574,7 @@
           <a:lstStyle/>
           <a:p>
             <a:r>
-              <a:t>Proposal slide for the ModeHead dirichlet layer (mixture), built 2026-08-04 behind the K=1-identity `mode_n_components` dial -- no trained checkpoint yet, so the canonical output is unchanged; drawn so the contrast with the two current-output slides is visual. Motivating measurements: 45% of sampled bulks bimodal in conditional amp proportion (2026-07-17 corpus exam), 34% of testable bimodal bulks still bimodal within their dominant support (the part support-conditioning cannot represent); amp two-sided PIT groups 0.026 -&gt; 0.114 when support-conditioning landed (truth escaping both tails = mean parked between humps); real-rock residual heavier-tailed than any Beta at the fitted mean. Design locked with the owner: K=2 fixed (not an HPO dial yet), assemblage-level components (one gate choosing whole alpha vectors -- on a simplex a per-phase mixture is not even coherent, and the humps co-vary through the shared hidden (P, H2O) path, cf. the 51% amp&lt;-&gt;opx switch), no gate regularizer in the first build (gate entropy is a read-after diagnostic; collapse = H~0 everywhere plus identical components), all-rock encoder with the allrock-tuned dials, control = joint_heads_allrock_tuned_seed0 as trained. Loss is logsumexp(log w_k + log Dir_k) on the present support -- CondHead's GMM pattern moved onto the Dirichlet. Build gate: K=1 under the new code must reproduce production metrics to float precision before any K=2 run. Old broad-draw corpus; verdict on the real-rock benchmark, val only, test untouched.</a:t>
+              <a:t>Slide for the ModeHead dirichlet layer (mixture), built and evaluated 2026-08-04 behind the K=1-identity `mode_n_components` dial. VERDICT (owner, same day): kept as a dial, K=1 stays the canonical output -- the trained K=2 posts the best corpus numbers on record on both axes (teacher-forced -3.0819 vs control -2.6713, sampled-support -2.1161 vs -1.9620) and collapses the targeted amp two-sided PIT residue, but the recalibrated real-rock val contrast leans against the same-dials control (1.642 vs 1.277, -0.365 [-0.864, +0.118], all in the magnitude term) and the gate hedges near 50/50 rather than switching. Attribution (journal 2026-08-04, second entry): the 7-group instrument passes 61% of the corpus advantage; the real amp population at matched chemistry has the same total spread but ONE hump (GMM BIC 39% vs 100% of matched corpus bulks); a single gate-offset recalibration parameter recovers ~60% of the penalty, to a tie, never a win. Drawn so the contrast with the two current-output slides is visual. Motivating measurements: 45% of sampled bulks bimodal in conditional amp proportion (2026-07-17 corpus exam), 34% of testable bimodal bulks still bimodal within their dominant support (the part support-conditioning cannot represent); amp two-sided PIT groups 0.026 -&gt; 0.114 when support-conditioning landed (truth escaping both tails = mean parked between humps); real-rock residual heavier-tailed than any Beta at the fitted mean. Design locked with the owner: K=2 fixed (not an HPO dial yet), assemblage-level components (one gate choosing whole alpha vectors -- on a simplex a per-phase mixture is not even coherent, and the humps co-vary through the shared hidden (P, H2O) path, cf. the 51% amp&lt;-&gt;opx switch), no gate regularizer in the first build (gate entropy is a read-after diagnostic; collapse = H~0 everywhere plus identical components), all-rock encoder with the allrock-tuned dials, control = joint_heads_allrock_tuned_seed0 as trained. Loss is logsumexp(log w_k + log Dir_k) on the present support -- CondHead's GMM pattern moved onto the Dirichlet. Build gate: K=1 under the new code must reproduce production metrics to float precision before any K=2 run. Old broad-draw corpus; verdict on the real-rock benchmark, val only, test untouched.</a:t>
             </a:r>
           </a:p>
         </p:txBody>
@@ -21763,7 +21763,7 @@
                   <a:srgbClr val="2E5BFF"/>
                 </a:solidFill>
               </a:rPr>
-              <a:t>HEADS -- PROPOSED CANONICAL OUTPUT (K=2 DISTRIBUTIONS)</a:t>
+              <a:t>HEADS -- K=2 MIXTURE: EVALUATED, KEPT AS A DIAL (K=1 STAYS CANONICAL)</a:t>
             </a:r>
           </a:p>
         </p:txBody>
@@ -21797,7 +21797,7 @@
                   <a:srgbClr val="1A2238"/>
                 </a:solidFill>
               </a:rPr>
-              <a:t>Proposed: the ModeHead dirichlet layer (mixture) -- built, not yet trained</a:t>
+              <a:t>The ModeHead dirichlet layer (mixture) -- trained 2026-08-04; wins the corpus, leans against on real rocks</a:t>
             </a:r>
           </a:p>
         </p:txBody>
@@ -23241,7 +23241,7 @@
                   <a:srgbClr val="8A93A3"/>
                 </a:solidFill>
               </a:rPr>
-              <a:t>kept only if better on real rocks: recalibrated val paired NLL vs the same-dials single-Dirichlet control; PIT/coverage break an NLL tie. distribution numbers illustrative.</a:t>
+              <a:t>verdict 2026-08-04: corpus best-on-record on both axes, amp two-sided PIT 0.120 -&gt; 0.023, but recalibrated real-rock val leans against the K=1 control (-0.365 [-0.864, +0.118]) -- the real amp population is one-humped at matched chemistry; the second hump belongs to the broad hidden-(P, H2O) prior. kept as the `mode_n_components` dial, K=1 default. drawings illustrative.</a:t>
             </a:r>
           </a:p>
         </p:txBody>

</xml_diff>

<commit_message>
delete the recalibrator's presence silica slopes and take silica out of the layer entirely (#67 item 1): forward is (logits7, alpha7[, log_w]), mlp trunk reads 2n features, counts 21/119/1061/121; ablation script, its result, and its three tests removed; deck slide regenerated
</commit_message>
<xml_diff>
--- a/slides/overview.pptx
+++ b/slides/overview.pptx
@@ -1505,7 +1505,7 @@
           <a:lstStyle/>
           <a:p>
             <a:r>
-              <a:t>Anatomy of the sim-to-real recalibrator (cnmineral.models.real_rock_recalibrator.RealRockRecalibrator). This is the one component that is NOT a head on h: it reads the frozen ModeHead's own outputs, which is why it does not use the head_anatomy_slide template. Interface: (p7 logits, alpha7, SiO2 wt%) in, corrected (logits, alpha, gate log-weights) out. It acts in coarsened 7-group space rather than the model's 21 phases because that is where real modal labels live, where the residuals were measured, and where the three tiers nest exactly. Presence is corrected in logit space (that is where Platt scaling lives); magnitude multiplicatively on the concentrations -- multiplicative matters, because coarsening leaves exact zeros wherever a group has no member phase on the support, alpha*exp(c) keeps those zeros, and an additive correction in log space would turn them into -inf. Param counts instantiated from the module, exact: vector 23, matrix 121, mlp 1095, tailed 123; the 5.07M denominator is the frozen encoder (3,234,699 trainable) plus heads (1,830,337). The SiO2 slopes shown are the PRESENCE-side ones on q and amp, which stay; a magnitude-side location slope was built alongside the tailed tier, measured +0.007 [-0.004, +0.016] nats, and excised as three dead parameters (journal 2026-08-06). The contamination is parameterized as an offset from a -3.0 prior logit so weight decay shrinks toward 'rare contamination' (eps ~0.05) rather than the eps = 0.5 a raw logit would decay to; k = 1 at init collapses the mixture, preserving identity-at-init. Splits are clustered by eruption unit, not by rock, because rocks from one unit are not independent samples.</a:t>
+              <a:t>Anatomy of the sim-to-real recalibrator (cnmineral.models.real_rock_recalibrator.RealRockRecalibrator). This is the one component that is NOT a head on h: it reads the frozen ModeHead's own outputs, which is why it does not use the head_anatomy_slide template. Interface: (p7 logits, alpha7) in, corrected (logits, alpha, gate log-weights) out. It acts in coarsened 7-group space rather than the model's 21 phases because that is where real modal labels live, where the residuals were measured, and where the three tiers nest exactly. Presence is corrected in logit space (that is where Platt scaling lives); magnitude multiplicatively on the concentrations -- multiplicative matters, because coarsening leaves exact zeros wherever a group has no member phase on the support, alpha*exp(c) keeps those zeros, and an additive correction in log space would turn them into -inf. Param counts instantiated from the module, exact: vector 21, matrix 119, mlp 1061, tailed 121; the 5.07M denominator is the frozen encoder (3,234,699 trainable) plus heads (1,830,337). Silica is not an input: a magnitude-side location slope was built alongside the tailed tier, measured +0.007 [-0.004, +0.016] nats, and excised (journal 2026-08-06); the presence-side slopes on q and amp measured +0.002 nats (journal 2026-08-18) and were removed after submission (journal 2026-09-02). The contamination is parameterized as an offset from a -3.0 prior logit so weight decay shrinks toward 'rare contamination' (eps ~0.05) rather than the eps = 0.5 a raw logit would decay to; k = 1 at init collapses the mixture, preserving identity-at-init. Splits are clustered by eruption unit, not by rock, because rocks from one unit are not independent samples.</a:t>
             </a:r>
           </a:p>
         </p:txBody>
@@ -20357,7 +20357,7 @@
                   <a:srgbClr val="1A2238"/>
                 </a:solidFill>
               </a:rPr>
-              <a:t>Inside the recalibrator: 123 numbers between corpus and real rock</a:t>
+              <a:t>Inside the recalibrator: 121 numbers between corpus and real rock</a:t>
             </a:r>
           </a:p>
         </p:txBody>
@@ -20702,17 +20702,6 @@
               <a:t>scale, offset, 7x7 mix</a:t>
             </a:r>
           </a:p>
-          <a:p>
-            <a:pPr algn="ctr"/>
-            <a:r>
-              <a:rPr sz="900" b="0">
-                <a:solidFill>
-                  <a:srgbClr val="8A93A3"/>
-                </a:solidFill>
-              </a:rPr>
-              <a:t>+ SiO2 slope on q, amp</a:t>
-            </a:r>
-          </a:p>
         </p:txBody>
       </p:sp>
       <p:sp>
@@ -21295,7 +21284,7 @@
                   <a:srgbClr val="1A2238"/>
                 </a:solidFill>
               </a:rPr>
-              <a:t>123 trainable params on a frozen 5.07M stack (0.002%): 7 presence scales + 7 offsets + 7 magnitude offsets + 2 SiO2 slopes + two 7x7 mixes + 2 contamination params. The tiers nest -- vector (23) in matrix (121), and tailed = matrix + 2. Identity at initialization, so an unfit recalibrator reproduces the zero-shot number exactly and every gain reads as nats recovered.</a:t>
+              <a:t>121 trainable params on a frozen 5.07M stack (0.002%): 7 presence scales + 7 offsets + 7 magnitude offsets + two 7x7 mixes + 2 contamination params. The tiers nest -- vector (21) in matrix (119), and tailed = matrix + 2. Identity at initialization, so an unfit recalibrator reproduces the zero-shot number exactly and every gain reads as nats recovered.</a:t>
             </a:r>
           </a:p>
         </p:txBody>

</xml_diff>

<commit_message>
delete the K=2 ModeHead mixture (#67 item 4): head, config, loss and sampler plumbing, interrogation branches, checkpoint, and eight tests go; the mixture-shaped scoring contract stays for the tailed tier and measured heads; deck slide marked removed
</commit_message>
<xml_diff>
--- a/slides/overview.pptx
+++ b/slides/overview.pptx
@@ -875,7 +875,7 @@
           <a:lstStyle/>
           <a:p>
             <a:r>
-              <a:t>Eval-semantics slide for the magnitude branch, mirroring the presence branch's reliability worked example. Laid out as two tracks converging at a scoring node: the prediction track never sees the truth's modes; the truth contributes its support twice (conditioning input to the magnitude trunk + the score's slice, both teacher-forced) and its modes meet the prediction only at scoring. Numbers illustrative but to scale: alpha sliced to the true 4-phase support gives Dirichlet means alpha_i/alpha0 and Beta marginals Beta(alpha_i, alpha0 - alpha_i); plag Beta(12,13) has mean 0.48, sd ~0.10, and truth 0.44 lands at CDF 0.34. alpha0 is the single shared confidence knob per row -- the reason per-phase spreads can't be tuned independently (see alpha_concentration.png). PIT histograms are the magnitude analog of reliability diagrams; parity plots are the point-estimate view. Scored by masked Dirichlet NLL (anatomy slide's L_magnitude). Worked numbers for the expansion box: this row scores -4.34 nats (normalizer -28.37 + shape +24.03); scaling alpha x4 improves to -5.26 when truth is near the peak but explodes to +17.9 when truth swaps to the other hump (plag/amp values exchanged) -- the mechanism that pinned the support-blind head's amphibole alpha0 low and its mean in the middle. Support-conditioning resolves the between-support humps; the within-support ones still punish confidence the same way (the mixture candidate's target). The 0.715 -&gt; 0.876 amp parity jump that justified support-conditioning was measured when the support-conditioned trunk landed (#25); the production model reads 0.876 on the same axis, and 0.538 under sampled support. Retunes since have moved sharpness rather than conditioning, which is also why every sampled-support number is worse than its teacher-forced twin -- the head specialized to the true support.</a:t>
+              <a:t>Eval-semantics slide for the magnitude branch, mirroring the presence branch's reliability worked example. Laid out as two tracks converging at a scoring node: the prediction track never sees the truth's modes; the truth contributes its support twice (conditioning input to the magnitude trunk + the score's slice, both teacher-forced) and its modes meet the prediction only at scoring. Numbers illustrative but to scale: alpha sliced to the true 4-phase support gives Dirichlet means alpha_i/alpha0 and Beta marginals Beta(alpha_i, alpha0 - alpha_i); plag Beta(12,13) has mean 0.48, sd ~0.10, and truth 0.44 lands at CDF 0.34. alpha0 is the single shared confidence knob per row -- the reason per-phase spreads can't be tuned independently (see alpha_concentration.png). PIT histograms are the magnitude analog of reliability diagrams; parity plots are the point-estimate view. Scored by masked Dirichlet NLL (anatomy slide's L_magnitude). Worked numbers for the expansion box: this row scores -4.34 nats (normalizer -28.37 + shape +24.03); scaling alpha x4 improves to -5.26 when truth is near the peak but explodes to +17.9 when truth swaps to the other hump (plag/amp values exchanged) -- the mechanism that pinned the support-blind head's amphibole alpha0 low and its mean in the middle. Support-conditioning resolves the between-support humps; the within-support ones still punish confidence the same way (a K=2 mixture targeted them and was removed, journal 2026-09-02). The 0.715 -&gt; 0.876 amp parity jump that justified support-conditioning was measured when the support-conditioned trunk landed (#25); the production model reads 0.876 on the same axis, and 0.538 under sampled support. Retunes since have moved sharpness rather than conditioning, which is also why every sampled-support number is worse than its teacher-forced twin -- the head specialized to the true support.</a:t>
             </a:r>
           </a:p>
         </p:txBody>
@@ -1645,7 +1645,7 @@
           <a:lstStyle/>
           <a:p>
             <a:r>
-              <a:t>Slide for the ModeHead dirichlet layer (mixture), built and evaluated 2026-08-04 behind the K=1-identity `mode_n_components` dial. VERDICT (owner, same day): kept as a dial, K=1 stays the canonical output -- the trained K=2 posts the best corpus numbers on record on both axes (teacher-forced -3.0819 vs control -2.6713, sampled-support -2.1161 vs -1.9620) and collapses the targeted amp two-sided PIT residue, but the recalibrated real-rock val contrast leans against the same-dials control (1.642 vs 1.277, -0.365 [-0.864, +0.118], all in the magnitude term) and the gate hedges near 50/50 rather than switching. Attribution (journal 2026-08-04, second entry): the 7-group instrument passes 61% of the corpus advantage; the real amp population at matched chemistry has the same total spread but ONE hump (GMM BIC 39% vs 100% of matched corpus bulks); a single gate-offset recalibration parameter recovers ~60% of the penalty, to a tie, never a win. Drawn so the contrast with the two current-output slides is visual. Motivating measurements: 45% of sampled bulks bimodal in conditional amp proportion (2026-07-17 corpus exam), 34% of testable bimodal bulks still bimodal within their dominant support (the part support-conditioning cannot represent); amp two-sided PIT groups 0.026 -&gt; 0.114 when support-conditioning landed (truth escaping both tails = mean parked between humps); real-rock residual heavier-tailed than any Beta at the fitted mean. Design locked with the owner: K=2 fixed (not an HPO dial yet), assemblage-level components (one gate choosing whole alpha vectors -- on a simplex a per-phase mixture is not even coherent, and the humps co-vary through the shared hidden (P, H2O) path, cf. the 51% amp&lt;-&gt;opx switch), no gate regularizer in the first build (gate entropy is a read-after diagnostic; collapse = H~0 everywhere plus identical components), all-rock encoder with the allrock-tuned dials, control = joint_heads_allrock_tuned_seed0 as trained. Loss is logsumexp(log w_k + log Dir_k) on the present support -- CondHead's GMM pattern moved onto the Dirichlet. Build gate: K=1 under the new code must reproduce production metrics to float precision before any K=2 run. Old broad-draw corpus; verdict on the real-rock benchmark, val only, test untouched.</a:t>
+              <a:t>Slide for the ModeHead dirichlet layer (mixture), built and evaluated 2026-08-04 behind a K=1-identity dial and deleted 2026-09-02 (#67 item 4; explorations/archive/mode_mixture is the record). VERDICT (owner, 2026-08-04): kept as a dial, K=1 stays the canonical output -- the trained K=2 posts the best corpus numbers on record on both axes (teacher-forced -3.0819 vs control -2.6713, sampled-support -2.1161 vs -1.9620) and collapses the targeted amp two-sided PIT residue, but the recalibrated real-rock val contrast leans against the same-dials control (1.642 vs 1.277, -0.365 [-0.864, +0.118], all in the magnitude term) and the gate hedges near 50/50 rather than switching. Attribution (journal 2026-08-04, second entry): the 7-group instrument passes 61% of the corpus advantage; the real amp population at matched chemistry has the same total spread but ONE hump (GMM BIC 39% vs 100% of matched corpus bulks); a single gate-offset recalibration parameter recovers ~60% of the penalty, to a tie, never a win. Drawn so the contrast with the two current-output slides is visual. Motivating measurements: 45% of sampled bulks bimodal in conditional amp proportion (2026-07-17 corpus exam), 34% of testable bimodal bulks still bimodal within their dominant support (the part support-conditioning cannot represent); amp two-sided PIT groups 0.026 -&gt; 0.114 when support-conditioning landed (truth escaping both tails = mean parked between humps); real-rock residual heavier-tailed than any Beta at the fitted mean. Design locked with the owner: K=2 fixed (not an HPO dial yet), assemblage-level components (one gate choosing whole alpha vectors -- on a simplex a per-phase mixture is not even coherent, and the humps co-vary through the shared hidden (P, H2O) path, cf. the 51% amp&lt;-&gt;opx switch), no gate regularizer in the first build (gate entropy is a read-after diagnostic; collapse = H~0 everywhere plus identical components), all-rock encoder with the allrock-tuned dials, control = joint_heads_allrock_tuned_seed0 as trained. Loss is logsumexp(log w_k + log Dir_k) on the present support -- CondHead's GMM pattern moved onto the Dirichlet. Build gate: K=1 under the new code must reproduce production metrics to float precision before any K=2 run. Old broad-draw corpus; verdict on the real-rock benchmark, val only, test untouched.</a:t>
             </a:r>
           </a:p>
         </p:txBody>
@@ -10545,7 +10545,7 @@
                   <a:srgbClr val="8A93A3"/>
                 </a:solidFill>
               </a:rPr>
-              <a:t>population: only truly-present (row, phase) pairs are scored -- ~41k pairs for plag down to a few hundred for the rarest phases; single-phase rows are excluded (nothing to size). current limits (production model): amp parity r 0.876 teacher-forced but 0.539 on self-sampled supports; the interrogation also measured amp bimodal WITHIN one support (mixture parameterization is the staged candidate, #25). full report: runs/mode_head/&lt;tag&gt;/ (magnitude_parity, magnitude_pit).</a:t>
+              <a:t>population: only truly-present (row, phase) pairs are scored -- ~41k pairs for plag down to a few hundred for the rarest phases; single-phase rows are excluded (nothing to size). current limits (production model): amp parity r 0.876 teacher-forced but 0.539 on self-sampled supports; the interrogation also measured amp bimodal WITHIN one support (a K=2 Dirichlet mixture was tried for them and removed: real amphibole at matched chemistry is one-humped, journal 2026-08-04). full report: runs/mode_head/&lt;tag&gt;/ (magnitude_parity, magnitude_pit).</a:t>
             </a:r>
           </a:p>
         </p:txBody>
@@ -22775,7 +22775,7 @@
                   <a:srgbClr val="2E5BFF"/>
                 </a:solidFill>
               </a:rPr>
-              <a:t>HEADS -- K=2 MIXTURE: EVALUATED, KEPT AS A DIAL (K=1 STAYS CANONICAL)</a:t>
+              <a:t>HEADS -- K=2 MIXTURE: EVALUATED AND REMOVED (K=1 IS THE HEAD)</a:t>
             </a:r>
           </a:p>
         </p:txBody>
@@ -22809,7 +22809,7 @@
                   <a:srgbClr val="1A2238"/>
                 </a:solidFill>
               </a:rPr>
-              <a:t>The ModeHead dirichlet layer (mixture) -- trained 2026-08-04; wins the corpus, leans against on real rocks</a:t>
+              <a:t>The ModeHead dirichlet layer (mixture) -- trained 2026-08-04; wins the corpus, leans against on real rocks; deleted 2026-09-02</a:t>
             </a:r>
           </a:p>
         </p:txBody>
@@ -23711,7 +23711,7 @@
                   <a:srgbClr val="1A2238"/>
                 </a:solidFill>
               </a:rPr>
-              <a:t>proposed: K=2 -- mass on the humps</a:t>
+              <a:t>tried: K=2 -- mass on the humps</a:t>
             </a:r>
           </a:p>
         </p:txBody>
@@ -24219,7 +24219,7 @@
                   <a:srgbClr val="1A2238"/>
                 </a:solidFill>
               </a:rPr>
-              <a:t>unchanged: presence branch, CompHead, CondHead, closure. K=1 is the current head exactly (same parameters, same loss), so production checkpoints load untouched and the drop path is one deleted code branch.</a:t>
+              <a:t>unchanged: presence branch, CompHead, CondHead, closure. K=1 is the head (same parameters, same loss); the K=2 branch was one code path and was deleted 2026-09-02 (#67 item 4).</a:t>
             </a:r>
           </a:p>
         </p:txBody>
@@ -24253,7 +24253,7 @@
                   <a:srgbClr val="8A93A3"/>
                 </a:solidFill>
               </a:rPr>
-              <a:t>verdict 2026-08-04: corpus best-on-record on both axes, amp two-sided PIT 0.120 -&gt; 0.023, but recalibrated real-rock val leans against the K=1 control (-0.365 [-0.864, +0.118]) -- the real amp population is one-humped at matched chemistry; the second hump belongs to the broad hidden-(P, H2O) prior. kept as the `mode_n_components` dial, K=1 default. drawings illustrative.</a:t>
+              <a:t>verdict 2026-08-04: corpus best-on-record on both axes, amp two-sided PIT 0.120 -&gt; 0.023, but recalibrated real-rock val leans against the K=1 control (-0.365 [-0.864, +0.118]) -- the real amp population is one-humped at matched chemistry; the second hump belongs to the broad hidden-(P, H2O) prior. removed 2026-09-02; the archived exploration is the record. drawings illustrative.</a:t>
             </a:r>
           </a:p>
         </p:txBody>

</xml_diff>

<commit_message>
delete the tailed recalibrator tier and promote matrix (119 parameters) to canonical, since its margin was the amphibole pin's cost (journal 2026-09-03). Tier, contamination branch, curve arm, point-count responsibility read and two tests go, the acceptance script becomes the vector-vs-matrix read, the curve is re-run without the arm on the recorded constants, and the deck's recalibrator slides are rewritten and regenerated.
</commit_message>
<xml_diff>
--- a/slides/overview.pptx
+++ b/slides/overview.pptx
@@ -595,7 +595,7 @@
           <a:lstStyle/>
           <a:p>
             <a:r>
-              <a:t>The three-stage training pipeline. Stage 1 is the SSL loop from the prior slide; stage 2 freezes; stage 3 trains the heads on the labeled equilibrium corpus. The production stack is checkpoints/pretrain_allrock_redox_seed0 (stage 1-2, all-rock 23-token, canonical 2026-08-05) + checkpoints/joint_heads_allrock_tuned_seed0 (stage 3, old broad-draw corpus; the traced-corpus retrains were measured and not adopted). Stage 3 is cheap by design -- 1.83M head params against a 3.23M frozen encoder -- which is what makes re-supervising the heads against a different label source a retrain rather than a rebuild. A fourth stage exists downstream for real rocks: a 123-parameter recalibrator fit on measured modes, two slides on from here.</a:t>
+              <a:t>The three-stage training pipeline. Stage 1 is the SSL loop from the prior slide; stage 2 freezes; stage 3 trains the heads on the labeled equilibrium corpus. The production stack is checkpoints/pretrain_allrock_redox_seed0 (stage 1-2, all-rock 23-token, canonical 2026-08-05) + checkpoints/joint_heads_allrock_tuned_seed0 (stage 3, old broad-draw corpus; the traced-corpus retrains were measured and not adopted). Stage 3 is cheap by design -- 1.83M head params against a 3.23M frozen encoder -- which is what makes re-supervising the heads against a different label source a retrain rather than a rebuild. A fourth stage exists downstream for real rocks: a 119-parameter recalibrator fit on measured modes, two slides on from here.</a:t>
             </a:r>
           </a:p>
         </p:txBody>
@@ -1505,7 +1505,7 @@
           <a:lstStyle/>
           <a:p>
             <a:r>
-              <a:t>Anatomy of the sim-to-real recalibrator (cnmineral.models.real_rock_recalibrator.RealRockRecalibrator). This is the one component that is NOT a head on h: it reads the frozen ModeHead's own outputs, which is why it does not use the head_anatomy_slide template. Interface: (p7 logits, alpha7) in, corrected (logits, alpha, gate log-weights) out. It acts in coarsened 7-group space rather than the model's 21 phases because that is where real modal labels live, where the residuals were measured, and where the three tiers nest exactly. Presence is corrected in logit space (that is where Platt scaling lives); magnitude multiplicatively on the concentrations -- multiplicative matters, because coarsening leaves exact zeros wherever a group has no member phase on the support, alpha*exp(c) keeps those zeros, and an additive correction in log space would turn them into -inf. Param counts instantiated from the module, exact: vector 21, matrix 119, mlp 1061, tailed 121; the 5.07M denominator is the frozen encoder (3,234,699 trainable) plus heads (1,830,337). Silica is not an input: a magnitude-side location slope was built alongside the tailed tier, measured +0.007 [-0.004, +0.016] nats, and excised (journal 2026-08-06); the presence-side slopes on q and amp measured +0.002 nats (journal 2026-08-18) and were removed after submission (journal 2026-09-02). The contamination is parameterized as an offset from a -3.0 prior logit so weight decay shrinks toward 'rare contamination' (eps ~0.05) rather than the eps = 0.5 a raw logit would decay to; k = 1 at init collapses the mixture, preserving identity-at-init. Splits are clustered by eruption unit, not by rock, because rocks from one unit are not independent samples.</a:t>
+              <a:t>Anatomy of the sim-to-real recalibrator (cnmineral.models.real_rock_recalibrator.RealRockRecalibrator). This is the one component that is NOT a head on h: it reads the frozen ModeHead's own outputs, which is why it does not use the head_anatomy_slide template. Interface: (p7 logits, alpha7) in, corrected (logits, alpha, gate log-weights) out. It acts in coarsened 7-group space rather than the model's 21 phases because that is where real modal labels live, where the residuals were measured, and where the three tiers nest exactly. Presence is corrected in logit space (that is where Platt scaling lives); magnitude multiplicatively on the concentrations -- multiplicative matters, because coarsening leaves exact zeros wherever a group has no member phase on the support, alpha*exp(c) keeps those zeros, and an additive correction in log space would turn them into -inf. Param counts instantiated from the module, exact: vector 21, matrix 119, mlp 1061; the 5.07M denominator is the frozen encoder (3,234,699 trainable) plus heads (1,830,337). Silica is not an input: a magnitude-side location slope was built, measured +0.007 [-0.004, +0.016] nats, and excised (journal 2026-08-06); the presence-side slopes on q and amp measured +0.002 nats (journal 2026-08-18) and were removed after submission (journal 2026-09-02). The submitted layer was matrix plus a two-parameter precision contamination ('tailed', 121 params, val 1.277 -&gt; 0.972); that margin was traced to the amphibole pin (unpinned matrix scores 0.688 on the same rocks and the contaminant sits at its identity), so the tier was deleted (journal 2026-09-03). Splits are clustered by eruption unit, not by rock, because rocks from one unit are not independent samples.</a:t>
             </a:r>
           </a:p>
         </p:txBody>
@@ -1575,7 +1575,7 @@
           <a:lstStyle/>
           <a:p>
             <a:r>
-              <a:t>Eval-semantics slide for the recalibrator. All levels are val-only (111 rocks, 39 eruption units) with the layer fit on the 368-rock train roster; the test slice is untouched. Levels from tailed_acceptance.json: zero-shot joint 13.444 (dirichlet 7.630 + bernoulli 5.813), vector 3.761, matrix 1.277, tailed 0.972. The matrix-minus-tailed contrast is +0.30445 [+0.04942, +0.65876] over 39 units; the bernoulli component of that contrast is exactly 0.0 because tailed forks from matrix and leaves the presence branch untouched -- worth saying out loud, since a reader may expect the usual both-terms-move pattern. Fitted contamination eps 0.05209, k 0.50665. Curve numbers from curve_val.json (10 whole-unit draws per budget, budgets 25-400, paired across tiers, weight decay re-selected on this checkpoint): per-budget median dirichlet for tailed runs 0.324 at 25, -0.753 at 50, -1.154 at 100, -1.814 at 200, -1.924 at full train, against a 7.630 zero-shot -- so the 9.55-nat gain is 7.630 minus -1.924. The distribution drawings are illustrative but to scale for k = 0.507: halving the concentration roughly doubles the variance, so the contaminating component is ~1.4x wider at the same mean. Note the 111-rock val zero-shot (13.444) is NOT the 640-rock headline zero-shot (11.638 in results/real_rock_ledger.yaml) -- different populations, and mixing them is the easiest mistake to make here. Internal reference, deliberately not on the slide: the climatology baseline reads val joint 2.175 against tailed's 0.965.</a:t>
+              <a:t>Eval-semantics slide for the recalibrator. All levels are val-only (106 rocks, 39 eruption units) with the layer fit on the 372-rock train roster, rebuilt 2026-09-02 without the silica-containment rule and with unit spellings canonicalized; the test slice is untouched. Levels from acceptance.json: zero-shot joint 11.293 (dirichlet 5.284 + bernoulli 6.009), vector 1.417, matrix 0.829. The vector-minus-matrix contrast is +0.588 [+0.248, +0.943] over 39 units, dirichlet +0.397 [+0.114, +0.690], bernoulli +0.191 [+0.038, +0.370]. History: the submitted layer was 'tailed' (matrix + 2-param precision contamination), 1.277 -&gt; 0.972 on the old 111-rock val slice with amphibole's magnitude correction pinned at zero; bisected on identical rocks, unpinning alone takes matrix to 0.688 and leaves the contaminant at its identity (k 0.99), so the 0.30 was the pin's cost and the tier was deleted (journal 2026-09-03). Curve numbers from curve_val.json (10 whole-unit draws per budget, budgets 25-400, paired across arms, weight decay re-selected on this roster: vector 0.01, matrix 1.0): per-budget median dirichlet for matrix runs 1.656 at 25, -1.079 at 50, -1.841 at 100, -2.021 at 200, -2.133 at full train, against a 5.284 zero-shot -- so the 7.4-nat gain is 5.284 minus -2.133. Note the 106-rock val zero-shot (11.293) is NOT the 640-rock headline zero-shot (11.638 in results/real_rock_ledger.yaml) -- different populations, and mixing them is the easiest mistake to make here. Internal reference, deliberately not on the slide: the climatology baseline reads val joint 2.286 against matrix's 0.829.</a:t>
             </a:r>
           </a:p>
         </p:txBody>
@@ -20357,7 +20357,7 @@
                   <a:srgbClr val="1A2238"/>
                 </a:solidFill>
               </a:rPr>
-              <a:t>Inside the recalibrator: 121 numbers between corpus and real rock</a:t>
+              <a:t>Inside the recalibrator: 119 numbers between corpus and real rock</a:t>
             </a:r>
           </a:p>
         </p:txBody>
@@ -20611,8 +20611,8 @@
         </p:nvCxnSpPr>
         <p:spPr>
           <a:xfrm flipV="1">
-            <a:off x="5577840" y="2263140"/>
-            <a:ext cx="365760" cy="800100"/>
+            <a:off x="5577840" y="2583179"/>
+            <a:ext cx="365760" cy="480061"/>
           </a:xfrm>
           <a:prstGeom prst="bentConnector3">
             <a:avLst/>
@@ -20647,7 +20647,7 @@
         </p:nvSpPr>
         <p:spPr>
           <a:xfrm>
-            <a:off x="5943600" y="1783080"/>
+            <a:off x="5943600" y="2103120"/>
             <a:ext cx="3657600" cy="960120"/>
           </a:xfrm>
           <a:prstGeom prst="roundRect">
@@ -20712,7 +20712,7 @@
         </p:nvSpPr>
         <p:spPr>
           <a:xfrm>
-            <a:off x="9692640" y="2107692"/>
+            <a:off x="9692640" y="2427732"/>
             <a:ext cx="320040" cy="310896"/>
           </a:xfrm>
           <a:prstGeom prst="rightArrow">
@@ -20756,7 +20756,7 @@
         </p:nvSpPr>
         <p:spPr>
           <a:xfrm>
-            <a:off x="10104120" y="1828800"/>
+            <a:off x="10104120" y="2148839"/>
             <a:ext cx="1691640" cy="868680"/>
           </a:xfrm>
           <a:prstGeom prst="roundRect">
@@ -20822,7 +20822,7 @@
         <p:spPr>
           <a:xfrm>
             <a:off x="5577840" y="3063240"/>
-            <a:ext cx="365760" cy="388620"/>
+            <a:ext cx="365760" cy="982980"/>
           </a:xfrm>
           <a:prstGeom prst="bentConnector3">
             <a:avLst/>
@@ -20857,7 +20857,7 @@
         </p:nvSpPr>
         <p:spPr>
           <a:xfrm>
-            <a:off x="5943600" y="2971800"/>
+            <a:off x="5943600" y="3566160"/>
             <a:ext cx="3657600" cy="960120"/>
           </a:xfrm>
           <a:prstGeom prst="roundRect">
@@ -20933,7 +20933,7 @@
         </p:nvSpPr>
         <p:spPr>
           <a:xfrm>
-            <a:off x="9692640" y="3296412"/>
+            <a:off x="9692640" y="3890772"/>
             <a:ext cx="320040" cy="310896"/>
           </a:xfrm>
           <a:prstGeom prst="rightArrow">
@@ -20977,7 +20977,7 @@
         </p:nvSpPr>
         <p:spPr>
           <a:xfrm>
-            <a:off x="10104120" y="3017520"/>
+            <a:off x="10104120" y="3611879"/>
             <a:ext cx="1691640" cy="868680"/>
           </a:xfrm>
           <a:prstGeom prst="roundRect">
@@ -21034,230 +21034,9 @@
           </a:p>
         </p:txBody>
       </p:sp>
-      <p:cxnSp>
-        <p:nvCxnSpPr>
-          <p:cNvPr id="16" name="Connector 15"/>
-          <p:cNvCxnSpPr/>
-          <p:nvPr/>
-        </p:nvCxnSpPr>
-        <p:spPr>
-          <a:xfrm>
-            <a:off x="5577840" y="3063240"/>
-            <a:ext cx="365760" cy="1577340"/>
-          </a:xfrm>
-          <a:prstGeom prst="bentConnector3">
-            <a:avLst/>
-          </a:prstGeom>
-          <a:ln w="17780">
-            <a:solidFill>
-              <a:srgbClr val="8A93A3"/>
-            </a:solidFill>
-          </a:ln>
-          <a:effectLst/>
-        </p:spPr>
-        <p:style>
-          <a:lnRef idx="2">
-            <a:schemeClr val="accent1"/>
-          </a:lnRef>
-          <a:fillRef idx="0">
-            <a:schemeClr val="accent1"/>
-          </a:fillRef>
-          <a:effectRef idx="1">
-            <a:schemeClr val="accent1"/>
-          </a:effectRef>
-          <a:fontRef idx="minor">
-            <a:schemeClr val="tx1"/>
-          </a:fontRef>
-        </p:style>
-      </p:cxnSp>
-      <p:sp>
-        <p:nvSpPr>
-          <p:cNvPr id="17" name="Rounded Rectangle 16"/>
-          <p:cNvSpPr/>
-          <p:nvPr/>
-        </p:nvSpPr>
-        <p:spPr>
-          <a:xfrm>
-            <a:off x="5943600" y="4160520"/>
-            <a:ext cx="3657600" cy="960120"/>
-          </a:xfrm>
-          <a:prstGeom prst="roundRect">
-            <a:avLst/>
-          </a:prstGeom>
-          <a:solidFill>
-            <a:srgbClr val="EAE8FB"/>
-          </a:solidFill>
-          <a:ln w="25400">
-            <a:solidFill>
-              <a:srgbClr val="6C5CE7"/>
-            </a:solidFill>
-          </a:ln>
-          <a:effectLst/>
-        </p:spPr>
-        <p:style>
-          <a:lnRef idx="1">
-            <a:schemeClr val="accent1"/>
-          </a:lnRef>
-          <a:fillRef idx="3">
-            <a:schemeClr val="accent1"/>
-          </a:fillRef>
-          <a:effectRef idx="2">
-            <a:schemeClr val="accent1"/>
-          </a:effectRef>
-          <a:fontRef idx="minor">
-            <a:schemeClr val="lt1"/>
-          </a:fontRef>
-        </p:style>
-        <p:txBody>
-          <a:bodyPr rtlCol="0" anchor="ctr" wrap="square"/>
-          <a:lstStyle/>
-          <a:p>
-            <a:pPr algn="ctr"/>
-            <a:r>
-              <a:rPr sz="1200" b="1">
-                <a:solidFill>
-                  <a:srgbClr val="1A2238"/>
-                </a:solidFill>
-              </a:rPr>
-              <a:t>tail: precision contamination</a:t>
-            </a:r>
-          </a:p>
-          <a:p>
-            <a:pPr algn="ctr"/>
-            <a:r>
-              <a:rPr sz="900" b="0">
-                <a:solidFill>
-                  <a:srgbClr val="8A93A3"/>
-                </a:solidFill>
-              </a:rPr>
-              <a:t>weight eps on a second alpha x k</a:t>
-            </a:r>
-          </a:p>
-          <a:p>
-            <a:pPr algn="ctr"/>
-            <a:r>
-              <a:rPr sz="900" b="0">
-                <a:solidFill>
-                  <a:srgbClr val="8A93A3"/>
-                </a:solidFill>
-              </a:rPr>
-              <a:t>component -- same mean, fatter tail</a:t>
-            </a:r>
-          </a:p>
-        </p:txBody>
-      </p:sp>
-      <p:sp>
-        <p:nvSpPr>
-          <p:cNvPr id="18" name="Right Arrow 17"/>
-          <p:cNvSpPr/>
-          <p:nvPr/>
-        </p:nvSpPr>
-        <p:spPr>
-          <a:xfrm>
-            <a:off x="9692640" y="4485132"/>
-            <a:ext cx="320040" cy="310896"/>
-          </a:xfrm>
-          <a:prstGeom prst="rightArrow">
-            <a:avLst/>
-          </a:prstGeom>
-          <a:solidFill>
-            <a:srgbClr val="1A2238"/>
-          </a:solidFill>
-          <a:ln>
-            <a:noFill/>
-          </a:ln>
-          <a:effectLst/>
-        </p:spPr>
-        <p:style>
-          <a:lnRef idx="1">
-            <a:schemeClr val="accent1"/>
-          </a:lnRef>
-          <a:fillRef idx="3">
-            <a:schemeClr val="accent1"/>
-          </a:fillRef>
-          <a:effectRef idx="2">
-            <a:schemeClr val="accent1"/>
-          </a:effectRef>
-          <a:fontRef idx="minor">
-            <a:schemeClr val="lt1"/>
-          </a:fontRef>
-        </p:style>
-        <p:txBody>
-          <a:bodyPr rtlCol="0" anchor="ctr"/>
-          <a:lstStyle/>
-          <a:p>
-            <a:pPr algn="ctr"/>
-          </a:p>
-        </p:txBody>
-      </p:sp>
-      <p:sp>
-        <p:nvSpPr>
-          <p:cNvPr id="19" name="Rounded Rectangle 18"/>
-          <p:cNvSpPr/>
-          <p:nvPr/>
-        </p:nvSpPr>
-        <p:spPr>
-          <a:xfrm>
-            <a:off x="10104120" y="4206240"/>
-            <a:ext cx="1691640" cy="868680"/>
-          </a:xfrm>
-          <a:prstGeom prst="roundRect">
-            <a:avLst/>
-          </a:prstGeom>
-          <a:solidFill>
-            <a:srgbClr val="FFFFFF"/>
-          </a:solidFill>
-          <a:ln w="12700">
-            <a:solidFill>
-              <a:srgbClr val="C8CDD6"/>
-            </a:solidFill>
-          </a:ln>
-          <a:effectLst/>
-        </p:spPr>
-        <p:style>
-          <a:lnRef idx="1">
-            <a:schemeClr val="accent1"/>
-          </a:lnRef>
-          <a:fillRef idx="3">
-            <a:schemeClr val="accent1"/>
-          </a:fillRef>
-          <a:effectRef idx="2">
-            <a:schemeClr val="accent1"/>
-          </a:effectRef>
-          <a:fontRef idx="minor">
-            <a:schemeClr val="lt1"/>
-          </a:fontRef>
-        </p:style>
-        <p:txBody>
-          <a:bodyPr rtlCol="0" anchor="ctr" wrap="square"/>
-          <a:lstStyle/>
-          <a:p>
-            <a:pPr algn="ctr"/>
-            <a:r>
-              <a:rPr sz="1100" b="1">
-                <a:solidFill>
-                  <a:srgbClr val="8A93A3"/>
-                </a:solidFill>
-              </a:rPr>
-              <a:t>2-component</a:t>
-            </a:r>
-          </a:p>
-          <a:p>
-            <a:pPr algn="ctr"/>
-            <a:r>
-              <a:rPr sz="800" b="0">
-                <a:solidFill>
-                  <a:srgbClr val="8A93A3"/>
-                </a:solidFill>
-              </a:rPr>
-              <a:t>mixture out</a:t>
-            </a:r>
-          </a:p>
-        </p:txBody>
-      </p:sp>
-      <p:sp>
-        <p:nvSpPr>
-          <p:cNvPr id="20" name="TextBox 19"/>
+      <p:sp>
+        <p:nvSpPr>
+          <p:cNvPr id="16" name="TextBox 15"/>
           <p:cNvSpPr txBox="1"/>
           <p:nvPr/>
         </p:nvSpPr>
@@ -21284,14 +21063,14 @@
                   <a:srgbClr val="1A2238"/>
                 </a:solidFill>
               </a:rPr>
-              <a:t>121 trainable params on a frozen 5.07M stack (0.002%): 7 presence scales + 7 offsets + 7 magnitude offsets + two 7x7 mixes + 2 contamination params. The tiers nest -- vector (21) in matrix (119), and tailed = matrix + 2. Identity at initialization, so an unfit recalibrator reproduces the zero-shot number exactly and every gain reads as nats recovered.</a:t>
-            </a:r>
-          </a:p>
-        </p:txBody>
-      </p:sp>
-      <p:sp>
-        <p:nvSpPr>
-          <p:cNvPr id="21" name="TextBox 20"/>
+              <a:t>119 trainable params on a frozen 5.07M stack (0.002%): 7 presence scales + 7 offsets + 7 magnitude offsets + two 7x7 mixes. The tiers nest -- vector (21) in matrix (119) in mlp (1061, a comparison arm that never repaid its capacity). Identity at initialization, so an unfit recalibrator reproduces the zero-shot number exactly and every gain reads as nats recovered.</a:t>
+            </a:r>
+          </a:p>
+        </p:txBody>
+      </p:sp>
+      <p:sp>
+        <p:nvSpPr>
+          <p:cNvPr id="17" name="TextBox 16"/>
           <p:cNvSpPr txBox="1"/>
           <p:nvPr/>
         </p:nvSpPr>
@@ -21318,14 +21097,14 @@
                   <a:srgbClr val="8A93A3"/>
                 </a:solidFill>
               </a:rPr>
-              <a:t>dials: Adam, lr 0.05, 400 epochs, no per-draw early stopping by design . weight decay picked on val per tier (vector 0.1, matrix 1.0, tailed 1.0) . every group's correction is fit; amphibole's is not interpretable (the mapping audit's density band straddles zero there), which the audit says, not the layer.</a:t>
-            </a:r>
-          </a:p>
-        </p:txBody>
-      </p:sp>
-      <p:sp>
-        <p:nvSpPr>
-          <p:cNvPr id="22" name="TextBox 21"/>
+              <a:t>dials: Adam, lr 0.05, 400 epochs, no per-draw early stopping by design . weight decay picked on val per tier (vector 0.01, matrix 1.0) . every group's correction is fit; amphibole's is not interpretable (the mapping audit's density band straddles zero there), which the audit says, not the layer.</a:t>
+            </a:r>
+          </a:p>
+        </p:txBody>
+      </p:sp>
+      <p:sp>
+        <p:nvSpPr>
+          <p:cNvPr id="18" name="TextBox 17"/>
           <p:cNvSpPr txBox="1"/>
           <p:nvPr/>
         </p:nvSpPr>
@@ -21352,7 +21131,7 @@
                   <a:srgbClr val="8A93A3"/>
                 </a:solidFill>
               </a:rPr>
-              <a:t>ground truth: measured modal data, eruption-v2 benchmark. 640 least-altered rocks split by eruption unit -- 368 train (the fit) / 111 val (every number on the next slide) / 161 test, sealed.</a:t>
+              <a:t>ground truth: measured modal data, eruption-v2 benchmark. 640 least-altered rocks split by eruption unit -- 372 train (the fit) / 106 val (every number on the next slide) / 162 test, sealed.</a:t>
             </a:r>
           </a:p>
         </p:txBody>
@@ -21438,7 +21217,7 @@
                   <a:srgbClr val="1A2238"/>
                 </a:solidFill>
               </a:rPr>
-              <a:t>What 123 parameters buy, and how many labelled rocks it takes</a:t>
+              <a:t>What 119 parameters buy, and how many labelled rocks it takes</a:t>
             </a:r>
           </a:p>
         </p:txBody>
@@ -21472,7 +21251,7 @@
                   <a:srgbClr val="8A93A3"/>
                 </a:solidFill>
               </a:rPr>
-              <a:t>every level below is joint NLL on the same 111 val rocks, lower better; contrasts are paired and clustered on the 39 eruption units, because rocks from one eruption are not independent.</a:t>
+              <a:t>every level below is joint NLL on the same 106 val rocks, lower better; contrasts are paired and clustered on the 39 eruption units, because rocks from one eruption are not independent.</a:t>
             </a:r>
           </a:p>
         </p:txBody>
@@ -21604,7 +21383,7 @@
                   <a:srgbClr val="8A93A3"/>
                 </a:solidFill>
               </a:rPr>
-              <a:t>13.44</a:t>
+              <a:t>11.29</a:t>
             </a:r>
           </a:p>
         </p:txBody>
@@ -21658,7 +21437,7 @@
                   <a:srgbClr val="1A2238"/>
                 </a:solidFill>
               </a:rPr>
-              <a:t>vector (23)</a:t>
+              <a:t>vector (21)</a:t>
             </a:r>
           </a:p>
         </p:txBody>
@@ -21672,7 +21451,7 @@
         <p:spPr>
           <a:xfrm>
             <a:off x="3017520" y="2578608"/>
-            <a:ext cx="1381397" cy="365760"/>
+            <a:ext cx="621046" cy="365760"/>
           </a:xfrm>
           <a:prstGeom prst="rect">
             <a:avLst/>
@@ -21715,7 +21494,7 @@
         </p:nvSpPr>
         <p:spPr>
           <a:xfrm>
-            <a:off x="4490357" y="2596896"/>
+            <a:off x="3730006" y="2596896"/>
             <a:ext cx="1371600" cy="731520"/>
           </a:xfrm>
           <a:prstGeom prst="rect">
@@ -21736,7 +21515,7 @@
                   <a:srgbClr val="12B5A5"/>
                 </a:solidFill>
               </a:rPr>
-              <a:t>3.76</a:t>
+              <a:t>1.42</a:t>
             </a:r>
           </a:p>
         </p:txBody>
@@ -21790,7 +21569,7 @@
                   <a:srgbClr val="1A2238"/>
                 </a:solidFill>
               </a:rPr>
-              <a:t>matrix (121)</a:t>
+              <a:t>matrix (119)</a:t>
             </a:r>
           </a:p>
         </p:txBody>
@@ -21804,7 +21583,7 @@
         <p:spPr>
           <a:xfrm>
             <a:off x="3017520" y="3236976"/>
-            <a:ext cx="470262" cy="365760"/>
+            <a:ext cx="363006" cy="365760"/>
           </a:xfrm>
           <a:prstGeom prst="rect">
             <a:avLst/>
@@ -21847,7 +21626,7 @@
         </p:nvSpPr>
         <p:spPr>
           <a:xfrm>
-            <a:off x="3579222" y="3255264"/>
+            <a:off x="3471966" y="3255264"/>
             <a:ext cx="1371600" cy="731520"/>
           </a:xfrm>
           <a:prstGeom prst="rect">
@@ -21868,119 +21647,21 @@
                   <a:srgbClr val="E8883A"/>
                 </a:solidFill>
               </a:rPr>
-              <a:t>1.28</a:t>
-            </a:r>
-          </a:p>
-        </p:txBody>
-      </p:sp>
-      <p:sp>
-        <p:nvSpPr>
-          <p:cNvPr id="14" name="Rounded Rectangle 13"/>
-          <p:cNvSpPr/>
-          <p:nvPr/>
-        </p:nvSpPr>
-        <p:spPr>
-          <a:xfrm>
-            <a:off x="502920" y="3803904"/>
-            <a:ext cx="2377440" cy="548640"/>
-          </a:xfrm>
-          <a:prstGeom prst="roundRect">
-            <a:avLst/>
-          </a:prstGeom>
-          <a:solidFill>
-            <a:srgbClr val="E1F1EF"/>
-          </a:solidFill>
-          <a:ln w="25400">
-            <a:solidFill>
-              <a:srgbClr val="2A9D8F"/>
-            </a:solidFill>
-          </a:ln>
-          <a:effectLst/>
-        </p:spPr>
-        <p:style>
-          <a:lnRef idx="1">
-            <a:schemeClr val="accent1"/>
-          </a:lnRef>
-          <a:fillRef idx="3">
-            <a:schemeClr val="accent1"/>
-          </a:fillRef>
-          <a:effectRef idx="2">
-            <a:schemeClr val="accent1"/>
-          </a:effectRef>
-          <a:fontRef idx="minor">
-            <a:schemeClr val="lt1"/>
-          </a:fontRef>
-        </p:style>
-        <p:txBody>
-          <a:bodyPr rtlCol="0" anchor="ctr" wrap="square"/>
-          <a:lstStyle/>
-          <a:p>
-            <a:pPr algn="ctr"/>
-            <a:r>
-              <a:rPr sz="1300" b="1">
-                <a:solidFill>
-                  <a:srgbClr val="1A2238"/>
-                </a:solidFill>
-              </a:rPr>
-              <a:t>tailed (123)</a:t>
-            </a:r>
-          </a:p>
-        </p:txBody>
-      </p:sp>
-      <p:sp>
-        <p:nvSpPr>
-          <p:cNvPr id="15" name="Rectangle 14"/>
-          <p:cNvSpPr/>
-          <p:nvPr/>
-        </p:nvSpPr>
-        <p:spPr>
-          <a:xfrm>
-            <a:off x="3017520" y="3895344"/>
-            <a:ext cx="356371" cy="365760"/>
-          </a:xfrm>
-          <a:prstGeom prst="rect">
-            <a:avLst/>
-          </a:prstGeom>
-          <a:solidFill>
-            <a:srgbClr val="2A9D8F"/>
-          </a:solidFill>
-          <a:ln>
-            <a:noFill/>
-          </a:ln>
-          <a:effectLst/>
-        </p:spPr>
-        <p:style>
-          <a:lnRef idx="1">
-            <a:schemeClr val="accent1"/>
-          </a:lnRef>
-          <a:fillRef idx="3">
-            <a:schemeClr val="accent1"/>
-          </a:fillRef>
-          <a:effectRef idx="2">
-            <a:schemeClr val="accent1"/>
-          </a:effectRef>
-          <a:fontRef idx="minor">
-            <a:schemeClr val="lt1"/>
-          </a:fontRef>
-        </p:style>
-        <p:txBody>
-          <a:bodyPr rtlCol="0" anchor="ctr"/>
-          <a:lstStyle/>
-          <a:p>
-            <a:pPr algn="ctr"/>
-          </a:p>
-        </p:txBody>
-      </p:sp>
-      <p:sp>
-        <p:nvSpPr>
-          <p:cNvPr id="16" name="TextBox 15"/>
+              <a:t>0.83</a:t>
+            </a:r>
+          </a:p>
+        </p:txBody>
+      </p:sp>
+      <p:sp>
+        <p:nvSpPr>
+          <p:cNvPr id="14" name="TextBox 13"/>
           <p:cNvSpPr txBox="1"/>
           <p:nvPr/>
         </p:nvSpPr>
         <p:spPr>
           <a:xfrm>
-            <a:off x="3465331" y="3913632"/>
-            <a:ext cx="1371600" cy="731520"/>
+            <a:off x="502920" y="3931920"/>
+            <a:ext cx="7680960" cy="731520"/>
           </a:xfrm>
           <a:prstGeom prst="rect">
             <a:avLst/>
@@ -21995,650 +21676,26 @@
           <a:p>
             <a:pPr algn="l"/>
             <a:r>
-              <a:rPr sz="1200" b="0">
-                <a:solidFill>
-                  <a:srgbClr val="2A9D8F"/>
-                </a:solidFill>
-              </a:rPr>
-              <a:t>0.97</a:t>
-            </a:r>
-          </a:p>
-        </p:txBody>
-      </p:sp>
-      <p:sp>
-        <p:nvSpPr>
-          <p:cNvPr id="17" name="TextBox 16"/>
-          <p:cNvSpPr txBox="1"/>
-          <p:nvPr/>
-        </p:nvSpPr>
-        <p:spPr>
-          <a:xfrm>
-            <a:off x="502920" y="4526280"/>
-            <a:ext cx="7680960" cy="731520"/>
-          </a:xfrm>
-          <a:prstGeom prst="rect">
-            <a:avLst/>
-          </a:prstGeom>
-          <a:noFill/>
-        </p:spPr>
-        <p:txBody>
-          <a:bodyPr wrap="square">
-            <a:spAutoFit/>
-          </a:bodyPr>
-          <a:lstStyle/>
-          <a:p>
-            <a:pPr algn="l"/>
-            <a:r>
               <a:rPr sz="1100" b="0">
                 <a:solidFill>
                   <a:srgbClr val="1A2238"/>
                 </a:solidFill>
               </a:rPr>
-              <a:t>matrix -&gt; tailed is +0.304 [+0.049, +0.659] nats, ALL of it in the Dirichlet term -- the two tiers share a presence branch, so that contrast is exactly 0.000. Fitted eps 0.052, k 0.507: about 5% of the mass moves to a component with half the concentration, same mean.</a:t>
-            </a:r>
-          </a:p>
-        </p:txBody>
-      </p:sp>
-      <p:sp>
-        <p:nvSpPr>
-          <p:cNvPr id="18" name="Freeform 17"/>
+              <a:t>vector -&gt; matrix is +0.59 [+0.25, +0.94] nats, on both terms (Dirichlet +0.40, Bernoulli +0.19): the 7x7 coupling pays. Every group's correction is fit. With amphibole's pinned at zero (the layer through 2026-09-02) matrix scored 1.28 here and a two-parameter heavy-tail term won 0.30 of it back -- the pin's own cost, measured on identical rocks -- so that tier is gone.</a:t>
+            </a:r>
+          </a:p>
+        </p:txBody>
+      </p:sp>
+      <p:sp>
+        <p:nvSpPr>
+          <p:cNvPr id="15" name="Rounded Rectangle 14"/>
           <p:cNvSpPr/>
           <p:nvPr/>
         </p:nvSpPr>
         <p:spPr>
           <a:xfrm>
-            <a:off x="8503920" y="1965960"/>
-            <a:ext cx="3108960" cy="1143000"/>
-          </a:xfrm>
-          <a:custGeom>
-            <a:avLst/>
-            <a:gdLst/>
-            <a:ahLst/>
-            <a:cxnLst/>
-            <a:rect l="l" t="t" r="r" b="b"/>
-            <a:pathLst>
-              <a:path w="3108960" h="1143000">
-                <a:moveTo>
-                  <a:pt x="0" y="1143000"/>
-                </a:moveTo>
-                <a:lnTo>
-                  <a:pt x="0" y="1142999"/>
-                </a:lnTo>
-                <a:lnTo>
-                  <a:pt x="64770" y="1142999"/>
-                </a:lnTo>
-                <a:lnTo>
-                  <a:pt x="129540" y="1142999"/>
-                </a:lnTo>
-                <a:lnTo>
-                  <a:pt x="194310" y="1142998"/>
-                </a:lnTo>
-                <a:lnTo>
-                  <a:pt x="259080" y="1142992"/>
-                </a:lnTo>
-                <a:lnTo>
-                  <a:pt x="323850" y="1142972"/>
-                </a:lnTo>
-                <a:lnTo>
-                  <a:pt x="388620" y="1142903"/>
-                </a:lnTo>
-                <a:lnTo>
-                  <a:pt x="453390" y="1142691"/>
-                </a:lnTo>
-                <a:lnTo>
-                  <a:pt x="518160" y="1142084"/>
-                </a:lnTo>
-                <a:lnTo>
-                  <a:pt x="582930" y="1140484"/>
-                </a:lnTo>
-                <a:lnTo>
-                  <a:pt x="647700" y="1136600"/>
-                </a:lnTo>
-                <a:lnTo>
-                  <a:pt x="712470" y="1127929"/>
-                </a:lnTo>
-                <a:lnTo>
-                  <a:pt x="777240" y="1110147"/>
-                </a:lnTo>
-                <a:lnTo>
-                  <a:pt x="842010" y="1076700"/>
-                </a:lnTo>
-                <a:lnTo>
-                  <a:pt x="906780" y="1019135"/>
-                </a:lnTo>
-                <a:lnTo>
-                  <a:pt x="971550" y="928774"/>
-                </a:lnTo>
-                <a:lnTo>
-                  <a:pt x="1036320" y="800007"/>
-                </a:lnTo>
-                <a:lnTo>
-                  <a:pt x="1101090" y="634621"/>
-                </a:lnTo>
-                <a:lnTo>
-                  <a:pt x="1165860" y="445442"/>
-                </a:lnTo>
-                <a:lnTo>
-                  <a:pt x="1230630" y="256942"/>
-                </a:lnTo>
-                <a:lnTo>
-                  <a:pt x="1295400" y="101081"/>
-                </a:lnTo>
-                <a:lnTo>
-                  <a:pt x="1360170" y="8785"/>
-                </a:lnTo>
-                <a:lnTo>
-                  <a:pt x="1424940" y="0"/>
-                </a:lnTo>
-                <a:lnTo>
-                  <a:pt x="1489710" y="76681"/>
-                </a:lnTo>
-                <a:lnTo>
-                  <a:pt x="1554480" y="222090"/>
-                </a:lnTo>
-                <a:lnTo>
-                  <a:pt x="1619250" y="406730"/>
-                </a:lnTo>
-                <a:lnTo>
-                  <a:pt x="1684020" y="598062"/>
-                </a:lnTo>
-                <a:lnTo>
-                  <a:pt x="1748790" y="769624"/>
-                </a:lnTo>
-                <a:lnTo>
-                  <a:pt x="1813560" y="906171"/>
-                </a:lnTo>
-                <a:lnTo>
-                  <a:pt x="1878330" y="1003936"/>
-                </a:lnTo>
-                <a:lnTo>
-                  <a:pt x="1943100" y="1067407"/>
-                </a:lnTo>
-                <a:lnTo>
-                  <a:pt x="2007870" y="1104960"/>
-                </a:lnTo>
-                <a:lnTo>
-                  <a:pt x="2072640" y="1125279"/>
-                </a:lnTo>
-                <a:lnTo>
-                  <a:pt x="2137410" y="1135357"/>
-                </a:lnTo>
-                <a:lnTo>
-                  <a:pt x="2202180" y="1139948"/>
-                </a:lnTo>
-                <a:lnTo>
-                  <a:pt x="2266950" y="1141872"/>
-                </a:lnTo>
-                <a:lnTo>
-                  <a:pt x="2331720" y="1142614"/>
-                </a:lnTo>
-                <a:lnTo>
-                  <a:pt x="2396490" y="1142877"/>
-                </a:lnTo>
-                <a:lnTo>
-                  <a:pt x="2461260" y="1142964"/>
-                </a:lnTo>
-                <a:lnTo>
-                  <a:pt x="2526030" y="1142990"/>
-                </a:lnTo>
-                <a:lnTo>
-                  <a:pt x="2590800" y="1142997"/>
-                </a:lnTo>
-                <a:lnTo>
-                  <a:pt x="2655570" y="1142999"/>
-                </a:lnTo>
-                <a:lnTo>
-                  <a:pt x="2720340" y="1142999"/>
-                </a:lnTo>
-                <a:lnTo>
-                  <a:pt x="2785110" y="1142999"/>
-                </a:lnTo>
-                <a:lnTo>
-                  <a:pt x="2849880" y="1142999"/>
-                </a:lnTo>
-                <a:lnTo>
-                  <a:pt x="2914650" y="1142999"/>
-                </a:lnTo>
-                <a:lnTo>
-                  <a:pt x="2979420" y="1142999"/>
-                </a:lnTo>
-                <a:lnTo>
-                  <a:pt x="3044190" y="1142999"/>
-                </a:lnTo>
-                <a:lnTo>
-                  <a:pt x="3108960" y="1142999"/>
-                </a:lnTo>
-                <a:lnTo>
-                  <a:pt x="3108960" y="1143000"/>
-                </a:lnTo>
-                <a:close/>
-              </a:path>
-            </a:pathLst>
-          </a:custGeom>
-          <a:solidFill>
-            <a:srgbClr val="F8DDC7"/>
-          </a:solidFill>
-          <a:ln w="25400">
-            <a:solidFill>
-              <a:srgbClr val="E8883A"/>
-            </a:solidFill>
-          </a:ln>
-          <a:effectLst/>
-        </p:spPr>
-        <p:style>
-          <a:lnRef idx="1">
-            <a:schemeClr val="accent1"/>
-          </a:lnRef>
-          <a:fillRef idx="3">
-            <a:schemeClr val="accent1"/>
-          </a:fillRef>
-          <a:effectRef idx="2">
-            <a:schemeClr val="accent1"/>
-          </a:effectRef>
-          <a:fontRef idx="minor">
-            <a:schemeClr val="lt1"/>
-          </a:fontRef>
-        </p:style>
-        <p:txBody>
-          <a:bodyPr rtlCol="0" anchor="ctr"/>
-          <a:lstStyle/>
-          <a:p>
-            <a:pPr algn="ctr"/>
-          </a:p>
-        </p:txBody>
-      </p:sp>
-      <p:cxnSp>
-        <p:nvCxnSpPr>
-          <p:cNvPr id="19" name="Connector 18"/>
-          <p:cNvCxnSpPr/>
-          <p:nvPr/>
-        </p:nvCxnSpPr>
-        <p:spPr>
-          <a:xfrm>
-            <a:off x="8503920" y="3108960"/>
-            <a:ext cx="3108960" cy="0"/>
-          </a:xfrm>
-          <a:prstGeom prst="bentConnector3">
-            <a:avLst/>
-          </a:prstGeom>
-          <a:ln w="12700">
-            <a:solidFill>
-              <a:srgbClr val="8A93A3"/>
-            </a:solidFill>
-          </a:ln>
-          <a:effectLst/>
-        </p:spPr>
-        <p:style>
-          <a:lnRef idx="2">
-            <a:schemeClr val="accent1"/>
-          </a:lnRef>
-          <a:fillRef idx="0">
-            <a:schemeClr val="accent1"/>
-          </a:fillRef>
-          <a:effectRef idx="1">
-            <a:schemeClr val="accent1"/>
-          </a:effectRef>
-          <a:fontRef idx="minor">
-            <a:schemeClr val="tx1"/>
-          </a:fontRef>
-        </p:style>
-      </p:cxnSp>
-      <p:sp>
-        <p:nvSpPr>
-          <p:cNvPr id="20" name="TextBox 19"/>
-          <p:cNvSpPr txBox="1"/>
-          <p:nvPr/>
-        </p:nvSpPr>
-        <p:spPr>
-          <a:xfrm>
-            <a:off x="8321040" y="3154679"/>
-            <a:ext cx="3474720" cy="365760"/>
-          </a:xfrm>
-          <a:prstGeom prst="rect">
-            <a:avLst/>
-          </a:prstGeom>
-          <a:noFill/>
-        </p:spPr>
-        <p:txBody>
-          <a:bodyPr wrap="square">
-            <a:spAutoFit/>
-          </a:bodyPr>
-          <a:lstStyle/>
-          <a:p>
-            <a:pPr algn="ctr"/>
-            <a:r>
-              <a:rPr sz="1200" b="1">
-                <a:solidFill>
-                  <a:srgbClr val="1A2238"/>
-                </a:solidFill>
-              </a:rPr>
-              <a:t>matrix: one Dirichlet, thin tails</a:t>
-            </a:r>
-          </a:p>
-        </p:txBody>
-      </p:sp>
-      <p:sp>
-        <p:nvSpPr>
-          <p:cNvPr id="21" name="Freeform 20"/>
-          <p:cNvSpPr/>
-          <p:nvPr/>
-        </p:nvSpPr>
-        <p:spPr>
-          <a:xfrm>
-            <a:off x="8503920" y="3657600"/>
-            <a:ext cx="3108960" cy="1143000"/>
-          </a:xfrm>
-          <a:custGeom>
-            <a:avLst/>
-            <a:gdLst/>
-            <a:ahLst/>
-            <a:cxnLst/>
-            <a:rect l="l" t="t" r="r" b="b"/>
-            <a:pathLst>
-              <a:path w="3108960" h="1143000">
-                <a:moveTo>
-                  <a:pt x="0" y="1143000"/>
-                </a:moveTo>
-                <a:lnTo>
-                  <a:pt x="0" y="1142335"/>
-                </a:lnTo>
-                <a:lnTo>
-                  <a:pt x="64770" y="1142002"/>
-                </a:lnTo>
-                <a:lnTo>
-                  <a:pt x="129540" y="1141529"/>
-                </a:lnTo>
-                <a:lnTo>
-                  <a:pt x="194310" y="1140872"/>
-                </a:lnTo>
-                <a:lnTo>
-                  <a:pt x="259080" y="1139979"/>
-                </a:lnTo>
-                <a:lnTo>
-                  <a:pt x="323850" y="1138782"/>
-                </a:lnTo>
-                <a:lnTo>
-                  <a:pt x="388620" y="1137190"/>
-                </a:lnTo>
-                <a:lnTo>
-                  <a:pt x="453390" y="1135056"/>
-                </a:lnTo>
-                <a:lnTo>
-                  <a:pt x="518160" y="1132089"/>
-                </a:lnTo>
-                <a:lnTo>
-                  <a:pt x="582930" y="1127685"/>
-                </a:lnTo>
-                <a:lnTo>
-                  <a:pt x="647700" y="1120604"/>
-                </a:lnTo>
-                <a:lnTo>
-                  <a:pt x="712470" y="1108488"/>
-                </a:lnTo>
-                <a:lnTo>
-                  <a:pt x="777240" y="1087283"/>
-                </a:lnTo>
-                <a:lnTo>
-                  <a:pt x="842010" y="1050865"/>
-                </a:lnTo>
-                <a:lnTo>
-                  <a:pt x="906780" y="991353"/>
-                </a:lnTo>
-                <a:lnTo>
-                  <a:pt x="971550" y="900684"/>
-                </a:lnTo>
-                <a:lnTo>
-                  <a:pt x="1036320" y="773737"/>
-                </a:lnTo>
-                <a:lnTo>
-                  <a:pt x="1101090" y="612421"/>
-                </a:lnTo>
-                <a:lnTo>
-                  <a:pt x="1165860" y="429111"/>
-                </a:lnTo>
-                <a:lnTo>
-                  <a:pt x="1230630" y="247204"/>
-                </a:lnTo>
-                <a:lnTo>
-                  <a:pt x="1295400" y="97168"/>
-                </a:lnTo>
-                <a:lnTo>
-                  <a:pt x="1360170" y="8441"/>
-                </a:lnTo>
-                <a:lnTo>
-                  <a:pt x="1424940" y="0"/>
-                </a:lnTo>
-                <a:lnTo>
-                  <a:pt x="1489710" y="73704"/>
-                </a:lnTo>
-                <a:lnTo>
-                  <a:pt x="1554480" y="213629"/>
-                </a:lnTo>
-                <a:lnTo>
-                  <a:pt x="1619250" y="391703"/>
-                </a:lnTo>
-                <a:lnTo>
-                  <a:pt x="1684020" y="576918"/>
-                </a:lnTo>
-                <a:lnTo>
-                  <a:pt x="1748790" y="743993"/>
-                </a:lnTo>
-                <a:lnTo>
-                  <a:pt x="1813560" y="878263"/>
-                </a:lnTo>
-                <a:lnTo>
-                  <a:pt x="1878330" y="975942"/>
-                </a:lnTo>
-                <a:lnTo>
-                  <a:pt x="1943100" y="1041081"/>
-                </a:lnTo>
-                <a:lnTo>
-                  <a:pt x="2007870" y="1081449"/>
-                </a:lnTo>
-                <a:lnTo>
-                  <a:pt x="2072640" y="1105139"/>
-                </a:lnTo>
-                <a:lnTo>
-                  <a:pt x="2137410" y="1118686"/>
-                </a:lnTo>
-                <a:lnTo>
-                  <a:pt x="2202180" y="1126539"/>
-                </a:lnTo>
-                <a:lnTo>
-                  <a:pt x="2266950" y="1131351"/>
-                </a:lnTo>
-                <a:lnTo>
-                  <a:pt x="2331720" y="1134542"/>
-                </a:lnTo>
-                <a:lnTo>
-                  <a:pt x="2396490" y="1136813"/>
-                </a:lnTo>
-                <a:lnTo>
-                  <a:pt x="2461260" y="1138499"/>
-                </a:lnTo>
-                <a:lnTo>
-                  <a:pt x="2526030" y="1139766"/>
-                </a:lnTo>
-                <a:lnTo>
-                  <a:pt x="2590800" y="1140714"/>
-                </a:lnTo>
-                <a:lnTo>
-                  <a:pt x="2655570" y="1141414"/>
-                </a:lnTo>
-                <a:lnTo>
-                  <a:pt x="2720340" y="1141919"/>
-                </a:lnTo>
-                <a:lnTo>
-                  <a:pt x="2785110" y="1142278"/>
-                </a:lnTo>
-                <a:lnTo>
-                  <a:pt x="2849880" y="1142527"/>
-                </a:lnTo>
-                <a:lnTo>
-                  <a:pt x="2914650" y="1142695"/>
-                </a:lnTo>
-                <a:lnTo>
-                  <a:pt x="2979420" y="1142808"/>
-                </a:lnTo>
-                <a:lnTo>
-                  <a:pt x="3044190" y="1142881"/>
-                </a:lnTo>
-                <a:lnTo>
-                  <a:pt x="3108960" y="1142928"/>
-                </a:lnTo>
-                <a:lnTo>
-                  <a:pt x="3108960" y="1143000"/>
-                </a:lnTo>
-                <a:close/>
-              </a:path>
-            </a:pathLst>
-          </a:custGeom>
-          <a:solidFill>
-            <a:srgbClr val="C3E3DF"/>
-          </a:solidFill>
-          <a:ln w="25400">
-            <a:solidFill>
-              <a:srgbClr val="2A9D8F"/>
-            </a:solidFill>
-          </a:ln>
-          <a:effectLst/>
-        </p:spPr>
-        <p:style>
-          <a:lnRef idx="1">
-            <a:schemeClr val="accent1"/>
-          </a:lnRef>
-          <a:fillRef idx="3">
-            <a:schemeClr val="accent1"/>
-          </a:fillRef>
-          <a:effectRef idx="2">
-            <a:schemeClr val="accent1"/>
-          </a:effectRef>
-          <a:fontRef idx="minor">
-            <a:schemeClr val="lt1"/>
-          </a:fontRef>
-        </p:style>
-        <p:txBody>
-          <a:bodyPr rtlCol="0" anchor="ctr"/>
-          <a:lstStyle/>
-          <a:p>
-            <a:pPr algn="ctr"/>
-          </a:p>
-        </p:txBody>
-      </p:sp>
-      <p:cxnSp>
-        <p:nvCxnSpPr>
-          <p:cNvPr id="22" name="Connector 21"/>
-          <p:cNvCxnSpPr/>
-          <p:nvPr/>
-        </p:nvCxnSpPr>
-        <p:spPr>
-          <a:xfrm>
-            <a:off x="8503920" y="4800600"/>
-            <a:ext cx="3108960" cy="0"/>
-          </a:xfrm>
-          <a:prstGeom prst="bentConnector3">
-            <a:avLst/>
-          </a:prstGeom>
-          <a:ln w="12700">
-            <a:solidFill>
-              <a:srgbClr val="8A93A3"/>
-            </a:solidFill>
-          </a:ln>
-          <a:effectLst/>
-        </p:spPr>
-        <p:style>
-          <a:lnRef idx="2">
-            <a:schemeClr val="accent1"/>
-          </a:lnRef>
-          <a:fillRef idx="0">
-            <a:schemeClr val="accent1"/>
-          </a:fillRef>
-          <a:effectRef idx="1">
-            <a:schemeClr val="accent1"/>
-          </a:effectRef>
-          <a:fontRef idx="minor">
-            <a:schemeClr val="tx1"/>
-          </a:fontRef>
-        </p:style>
-      </p:cxnSp>
-      <p:sp>
-        <p:nvSpPr>
-          <p:cNvPr id="23" name="TextBox 22"/>
-          <p:cNvSpPr txBox="1"/>
-          <p:nvPr/>
-        </p:nvSpPr>
-        <p:spPr>
-          <a:xfrm>
-            <a:off x="8321040" y="4846320"/>
-            <a:ext cx="3474720" cy="365760"/>
-          </a:xfrm>
-          <a:prstGeom prst="rect">
-            <a:avLst/>
-          </a:prstGeom>
-          <a:noFill/>
-        </p:spPr>
-        <p:txBody>
-          <a:bodyPr wrap="square">
-            <a:spAutoFit/>
-          </a:bodyPr>
-          <a:lstStyle/>
-          <a:p>
-            <a:pPr algn="ctr"/>
-            <a:r>
-              <a:rPr sz="1200" b="1">
-                <a:solidFill>
-                  <a:srgbClr val="1A2238"/>
-                </a:solidFill>
-              </a:rPr>
-              <a:t>tailed: same mean, 5% wide component</a:t>
-            </a:r>
-          </a:p>
-        </p:txBody>
-      </p:sp>
-      <p:sp>
-        <p:nvSpPr>
-          <p:cNvPr id="24" name="TextBox 23"/>
-          <p:cNvSpPr txBox="1"/>
-          <p:nvPr/>
-        </p:nvSpPr>
-        <p:spPr>
-          <a:xfrm>
-            <a:off x="8321040" y="4892040"/>
-            <a:ext cx="3474720" cy="731520"/>
-          </a:xfrm>
-          <a:prstGeom prst="rect">
-            <a:avLst/>
-          </a:prstGeom>
-          <a:noFill/>
-        </p:spPr>
-        <p:txBody>
-          <a:bodyPr wrap="square">
-            <a:spAutoFit/>
-          </a:bodyPr>
-          <a:lstStyle/>
-          <a:p>
-            <a:pPr algn="ctr"/>
-            <a:r>
-              <a:rPr sz="1000" b="0">
-                <a:solidFill>
-                  <a:srgbClr val="8A93A3"/>
-                </a:solidFill>
-              </a:rPr>
-              <a:t>the repair is to interval-MISS rocks (score), not to the stated intervals (width)</a:t>
-            </a:r>
-          </a:p>
-        </p:txBody>
-      </p:sp>
-      <p:sp>
-        <p:nvSpPr>
-          <p:cNvPr id="25" name="Rounded Rectangle 24"/>
-          <p:cNvSpPr/>
-          <p:nvPr/>
-        </p:nvSpPr>
-        <p:spPr>
-          <a:xfrm>
-            <a:off x="502920" y="5257800"/>
-            <a:ext cx="11201400" cy="731520"/>
+            <a:off x="8503920" y="1828800"/>
+            <a:ext cx="3200400" cy="2286000"/>
           </a:xfrm>
           <a:prstGeom prst="roundRect">
             <a:avLst/>
@@ -22673,37 +21730,70 @@
           <a:p>
             <a:pPr algn="ctr"/>
             <a:r>
-              <a:rPr sz="1200" b="1">
-                <a:solidFill>
-                  <a:srgbClr val="8A93A3"/>
-                </a:solidFill>
-              </a:rPr>
-              <a:t>how many labelled rocks does this need?</a:t>
-            </a:r>
-          </a:p>
-          <a:p>
-            <a:pPr algn="ctr"/>
-            <a:r>
-              <a:rPr sz="900" b="0">
-                <a:solidFill>
-                  <a:srgbClr val="8A93A3"/>
-                </a:solidFill>
-              </a:rPr>
-              <a:t>~26 rocks recover ~77% of the 9.55-nat magnitude gain, then it flattens hard. matrix and tailed are indistinguishable there (paired delta -0.001) -- 25 rocks carry too few interval misses to identify two contamination parameters -- and tailed then wins 10/10 paired draws at every budget from 50 up (-0.11 at 100, -0.29 at 200, -0.30 at full train). vector lags from 50 on and never goes negative.</a:t>
-            </a:r>
-          </a:p>
-        </p:txBody>
-      </p:sp>
-      <p:sp>
-        <p:nvSpPr>
-          <p:cNvPr id="26" name="TextBox 25"/>
+              <a:rPr sz="1100" b="1">
+                <a:solidFill>
+                  <a:srgbClr val="8A93A3"/>
+                </a:solidFill>
+              </a:rPr>
+              <a:t>80% interval coverage on val</a:t>
+            </a:r>
+          </a:p>
+          <a:p>
+            <a:pPr algn="ctr"/>
+            <a:r>
+              <a:rPr sz="800" b="0">
+                <a:solidFill>
+                  <a:srgbClr val="8A93A3"/>
+                </a:solidFill>
+              </a:rPr>
+              <a:t>zero-shot: 0.19-0.55 per group</a:t>
+            </a:r>
+          </a:p>
+          <a:p>
+            <a:pPr algn="ctr"/>
+            <a:r>
+              <a:rPr sz="800" b="0">
+                <a:solidFill>
+                  <a:srgbClr val="8A93A3"/>
+                </a:solidFill>
+              </a:rPr>
+              <a:t>matrix: 0.64-0.89</a:t>
+            </a:r>
+          </a:p>
+          <a:p>
+            <a:pPr algn="ctr"/>
+            <a:r>
+              <a:rPr sz="800" b="0">
+                <a:solidFill>
+                  <a:srgbClr val="8A93A3"/>
+                </a:solidFill>
+              </a:rPr>
+              <a:t>median width 0.20-0.31 after the fit</a:t>
+            </a:r>
+          </a:p>
+          <a:p>
+            <a:pPr algn="ctr"/>
+            <a:r>
+              <a:rPr sz="800" b="0">
+                <a:solidFill>
+                  <a:srgbClr val="8A93A3"/>
+                </a:solidFill>
+              </a:rPr>
+              <a:t>widening buys score, not vacuity</a:t>
+            </a:r>
+          </a:p>
+        </p:txBody>
+      </p:sp>
+      <p:sp>
+        <p:nvSpPr>
+          <p:cNvPr id="16" name="TextBox 15"/>
           <p:cNvSpPr txBox="1"/>
           <p:nvPr/>
         </p:nvSpPr>
         <p:spPr>
           <a:xfrm>
-            <a:off x="502920" y="6172200"/>
-            <a:ext cx="11201400" cy="731520"/>
+            <a:off x="8321040" y="4251960"/>
+            <a:ext cx="3474720" cy="731520"/>
           </a:xfrm>
           <a:prstGeom prst="rect">
             <a:avLst/>
@@ -22716,6 +21806,105 @@
           </a:bodyPr>
           <a:lstStyle/>
           <a:p>
+            <a:pPr algn="ctr"/>
+            <a:r>
+              <a:rPr sz="1000" b="0">
+                <a:solidFill>
+                  <a:srgbClr val="8A93A3"/>
+                </a:solidFill>
+              </a:rPr>
+              <a:t>the correction widens the Dirichlet (val alpha0 ~2.7x smaller) and recentres opq/bi up, q/fsp down</a:t>
+            </a:r>
+          </a:p>
+        </p:txBody>
+      </p:sp>
+      <p:sp>
+        <p:nvSpPr>
+          <p:cNvPr id="17" name="Rounded Rectangle 16"/>
+          <p:cNvSpPr/>
+          <p:nvPr/>
+        </p:nvSpPr>
+        <p:spPr>
+          <a:xfrm>
+            <a:off x="502920" y="5257800"/>
+            <a:ext cx="11201400" cy="731520"/>
+          </a:xfrm>
+          <a:prstGeom prst="roundRect">
+            <a:avLst/>
+          </a:prstGeom>
+          <a:solidFill>
+            <a:srgbClr val="FFFFFF"/>
+          </a:solidFill>
+          <a:ln w="12700">
+            <a:solidFill>
+              <a:srgbClr val="C8CDD6"/>
+            </a:solidFill>
+          </a:ln>
+          <a:effectLst/>
+        </p:spPr>
+        <p:style>
+          <a:lnRef idx="1">
+            <a:schemeClr val="accent1"/>
+          </a:lnRef>
+          <a:fillRef idx="3">
+            <a:schemeClr val="accent1"/>
+          </a:fillRef>
+          <a:effectRef idx="2">
+            <a:schemeClr val="accent1"/>
+          </a:effectRef>
+          <a:fontRef idx="minor">
+            <a:schemeClr val="lt1"/>
+          </a:fontRef>
+        </p:style>
+        <p:txBody>
+          <a:bodyPr rtlCol="0" anchor="ctr" wrap="square"/>
+          <a:lstStyle/>
+          <a:p>
+            <a:pPr algn="ctr"/>
+            <a:r>
+              <a:rPr sz="1200" b="1">
+                <a:solidFill>
+                  <a:srgbClr val="8A93A3"/>
+                </a:solidFill>
+              </a:rPr>
+              <a:t>how many labelled rocks does this need?</a:t>
+            </a:r>
+          </a:p>
+          <a:p>
+            <a:pPr algn="ctr"/>
+            <a:r>
+              <a:rPr sz="900" b="0">
+                <a:solidFill>
+                  <a:srgbClr val="8A93A3"/>
+                </a:solidFill>
+              </a:rPr>
+              <a:t>25 rocks (~8 eruptions) recover ~49% of matrix's 7.4-nat magnitude gain and ~79% of vector's 7.0; 50 rocks recover 86% (matrix). vector and matrix tie on paired draws through 50 rocks (5/10), then matrix wins 10/10 from 100 up (-0.45 at 100, -0.55 at 200, -0.59 at full train).</a:t>
+            </a:r>
+          </a:p>
+        </p:txBody>
+      </p:sp>
+      <p:sp>
+        <p:nvSpPr>
+          <p:cNvPr id="18" name="TextBox 17"/>
+          <p:cNvSpPr txBox="1"/>
+          <p:nvPr/>
+        </p:nvSpPr>
+        <p:spPr>
+          <a:xfrm>
+            <a:off x="502920" y="6172200"/>
+            <a:ext cx="11201400" cy="731520"/>
+          </a:xfrm>
+          <a:prstGeom prst="rect">
+            <a:avLst/>
+          </a:prstGeom>
+          <a:noFill/>
+        </p:spPr>
+        <p:txBody>
+          <a:bodyPr wrap="square">
+            <a:spAutoFit/>
+          </a:bodyPr>
+          <a:lstStyle/>
+          <a:p>
             <a:pPr algn="l"/>
             <a:r>
               <a:rPr sz="1000" b="0">
@@ -22723,7 +21912,7 @@
                   <a:srgbClr val="8A93A3"/>
                 </a:solidFill>
               </a:rPr>
-              <a:t>current limits: at 25 rocks the 10-90 draw band spans ~2.5 nats, so WHICH eruptions you label dominates which tier you fit. The silica location hypothesis was tested and refuted at the joint-likelihood level. Rendered verdicts stay stamped to the tier that produced them. The 161-rock test slice is sealed. full report: explorations/real_rock_fewshot/results/&lt;tag&gt;/</a:t>
+              <a:t>current limits: at 25 rocks the 10-90 draw band spans ~6 nats (2.5 to 8.8), so WHICH eruptions you label dominates which tier you fit. Rendered verdicts stay stamped to the tier that produced them. The 162-rock test slice is sealed and has never been scored. full report: explorations/real_rock_fewshot/results/&lt;tag&gt;/</a:t>
             </a:r>
           </a:p>
         </p:txBody>

</xml_diff>